<commit_message>
Building blocks: drop the STAC API mention (Portolan is static), mark GeoParquet as inside OGC
</commit_message>
<xml_diff>
--- a/export/ogc-metadata-summit-2026.pptx
+++ b/export/ogc-metadata-summit-2026.pptx
@@ -1678,13 +1678,13 @@
             <a:r>
               <a:rPr lang="en-US" dirty="0"/>
               <a:t>[Say] (1:30)
-"Everything a Portolan catalog is made of, you already know, and most of it carries an OGC stamp. STAC, catalog to asset, has been an OGC Community Standard since last October; a STAC Item is a GeoJSON Feature, and the STAC API extends OGC API Features. Cloud Optimized GeoTIFF is an OGC Standard since 2023. GeoParquet is in an OGC Standards Working Group, pending approval. Zarr, which we plan but have not shipped, is an OGC Community Standard. PMTiles for display is a community format outside OGC, and underneath it all are HTTP range requests on object storage. Nothing here is ours."
+"Everything a Portolan catalog is made of, you already know, and most of it carries an OGC stamp. STAC, catalog to asset, has been an OGC Community Standard since last October, and every STAC Item is a GeoJSON Feature. Portolan uses the static side of STAC only: files, no API. Cloud Optimized GeoTIFF is an OGC Standard since 2023. GeoParquet has its own OGC Standards Working Group; approval of 1.0 is the remaining formality. Zarr, which we plan but have not shipped, is an OGC Community Standard. PMTiles for display is a community format outside OGC, and underneath it all are HTTP range requests on object storage. Nothing here is ours."
 [Click 1]
 "So what is left to specify? Every one of those standards deliberately leaves the publishing choices open: how files are laid out, whether they are spatially ordered, which statistics they carry, what documentation sits next to them, how they are hosted, who produced them. That is the right design for a standard. It is the wrong thing to leave open for a reader, because every open choice is a branch every reader has to handle."
 [Click 2]
 "That is the gap Portolan fills. STAC describes the data. Portolan defines how it is published. It is a publishing profile on top of these standards, not a new format: Apache-2.0, version 0.2.0, 128 requirements, 105 of them checked by a machine."
 [Sources]
-- https://www.ogc.org/announcement/ogc-announces-publication-of-the-spatiotemporal-asset-catalog-community-standards/ (28 Oct 2025; "an Item … is simply a GeoJSON Feature"; "The STAC API extends the OGC API – Features – Part 1: Core")
+- https://www.ogc.org/announcement/ogc-announces-publication-of-the-spatiotemporal-asset-catalog-community-standards/ (28 Oct 2025; "an Item … is simply a GeoJSON Feature")
 - https://docs.ogc.org/is/21-026/21-026.html (OGC Cloud Optimized GeoTIFF Standard 1.0, 2023)
 - https://github.com/opengeospatial/geoparquet/blob/main/README.md ("official Standards Working Group … pending OGC approval", checked 3 Sep 2026)
 - https://www.ogc.org/announcement/ogc-forms-new-geozarr-standards-working-group-to-establish-a-zarr-encoding-for-geospatial-data/ (Zarr V2 endorsed as OGC Community Standard, June 2022)

</xml_diff>

<commit_message>
Add the 'why we moved' slide (SDI ambition, three shifts, the assembly problem); 15 main slides
</commit_message>
<xml_diff>
--- a/export/ogc-metadata-summit-2026.pptx
+++ b/export/ogc-metadata-summit-2026.pptx
@@ -23,9 +23,10 @@
     <p:sldId id="271" r:id="rId17"/>
     <p:sldId id="272" r:id="rId18"/>
     <p:sldId id="273" r:id="rId19"/>
+    <p:sldId id="274" r:id="rId20"/>
   </p:sldIdLst>
   <p:notesMasterIdLst>
-    <p:notesMasterId r:id="rId20"/>
+    <p:notesMasterId r:id="rId21"/>
   </p:notesMasterIdLst>
   <p:sldSz cx="9334500" cy="5248275"/>
   <p:notesSz cx="5248275" cy="9334500"/>
@@ -611,6 +612,104 @@
           <a:p>
             <a:r>
               <a:rPr lang="en-US" dirty="0"/>
+              <a:t>[Say] (1:15)
+"Three lessons from building this. The first is the one I would keep if I could keep only one. A well-formed STAC catalog is already findable and crawlable. Discovery is largely solved. What people and agents cannot do yet is evaluate: is this dataset fit for my question, where is it weak, how wrong can it be."
+[Click 1]
+"One sentence from a real catalog, Fields of the World: a field polygon is a remote-sensing field unit, not a cadastral parcel. That single sentence prevents a whole category of misuse that no accuracy number would catch. In the Bolzano answer you saw the same thing: a hospital point inside a hazard polygon is a location, not a catchment. Someone wrote that down."
+[Click 2]
+"So our working definition. AI-ready means documented limitations, quantified uncertainty and named biases. As data where possible, a confidence column or a quality mask an agent can filter on, rather than a paragraph it has to interpret. This is the expertise that otherwise lives only in the heads of domain experts, and it is the part of your metadata work that no automation replaces."
+[Sources]
+- https://github.com/portolan-sdi/portolan-spec/blob/main/specs/best-practices/documentation.md
+- Trochim &amp; Roy 2025, Candid Core Framework, doi:10.5281/zenodo.15227664
+- https://source.coop/ftw/global-data
+- https://www.portolan-sdi.org/blog/introducing-portolan ("context that'd otherwise be scattered across documentation or live only in the heads of domain experts")</a:t>
+            </a:r>
+            <a:endParaRPr lang="en-US" dirty="0"/>
+          </a:p>
+        </p:txBody>
+      </p:sp>
+      <p:sp>
+        <p:nvSpPr>
+          <p:cNvPr id="4" name="Slide Number Placeholder 3"/>
+          <p:cNvSpPr>
+            <a:spLocks noGrp="1"/>
+          </p:cNvSpPr>
+          <p:nvPr>
+            <p:ph type="sldNum" sz="quarter" idx="10"/>
+          </p:nvPr>
+        </p:nvSpPr>
+        <p:spPr/>
+        <p:txBody>
+          <a:bodyPr/>
+          <a:lstStyle/>
+          <a:p>
+            <a:fld id="{F7021451-1387-4CA6-816F-3879F97B5CBC}" type="slidenum">
+              <a:rPr lang="en-US"/>
+              <a:t>10</a:t>
+            </a:fld>
+            <a:endParaRPr lang="en-US"/>
+          </a:p>
+        </p:txBody>
+      </p:sp>
+    </p:spTree>
+    <p:extLst>
+      <p:ext uri="{BB962C8B-B14F-4D97-AF65-F5344CB8AC3E}">
+        <p14:creationId xmlns:p14="http://schemas.microsoft.com/office/powerpoint/2010/main" val="1024086991"/>
+      </p:ext>
+    </p:extLst>
+  </p:cSld>
+  <p:clrMapOvr>
+    <a:masterClrMapping/>
+  </p:clrMapOvr>
+</p:notes>
+</file>
+
+<file path=ppt/notesSlides/notesSlide11.xml><?xml version="1.0" encoding="utf-8"?>
+<p:notes xmlns:a="http://schemas.openxmlformats.org/drawingml/2006/main" xmlns:r="http://schemas.openxmlformats.org/officeDocument/2006/relationships" xmlns:p="http://schemas.openxmlformats.org/presentationml/2006/main">
+  <p:cSld>
+    <p:spTree>
+      <p:nvGrpSpPr>
+        <p:cNvPr id="1" name=""/>
+        <p:cNvGrpSpPr/>
+        <p:nvPr/>
+      </p:nvGrpSpPr>
+      <p:grpSpPr>
+        <a:xfrm>
+          <a:off x="0" y="0"/>
+          <a:ext cx="0" cy="0"/>
+          <a:chOff x="0" y="0"/>
+          <a:chExt cx="0" cy="0"/>
+        </a:xfrm>
+      </p:grpSpPr>
+      <p:sp>
+        <p:nvSpPr>
+          <p:cNvPr id="2" name="Slide Image Placeholder 1"/>
+          <p:cNvSpPr>
+            <a:spLocks noGrp="1" noRot="1" noChangeAspect="1"/>
+          </p:cNvSpPr>
+          <p:nvPr>
+            <p:ph type="sldImg"/>
+          </p:nvPr>
+        </p:nvSpPr>
+        <p:spPr/>
+      </p:sp>
+      <p:sp>
+        <p:nvSpPr>
+          <p:cNvPr id="3" name="Notes Placeholder 2"/>
+          <p:cNvSpPr>
+            <a:spLocks noGrp="1"/>
+          </p:cNvSpPr>
+          <p:nvPr>
+            <p:ph type="body" idx="1"/>
+          </p:nvPr>
+        </p:nvSpPr>
+        <p:spPr/>
+        <p:txBody>
+          <a:bodyPr/>
+          <a:lstStyle/>
+          <a:p>
+            <a:r>
+              <a:rPr lang="en-US" dirty="0"/>
               <a:t>[Say] (1:00)
 "Second lesson. Every catalog and collection carries two documents, and the spec requires both. The README is for the person deciding whether to trust the data. AGENTS dot md is for the agent that has already decided and now needs to get the query right on the first try. Same subject, different job."
 [Click 1]
@@ -645,7 +744,7 @@
           <a:p>
             <a:fld id="{F7021451-1387-4CA6-816F-3879F97B5CBC}" type="slidenum">
               <a:rPr lang="en-US"/>
-              <a:t>10</a:t>
+              <a:t>11</a:t>
             </a:fld>
             <a:endParaRPr lang="en-US"/>
           </a:p>
@@ -664,7 +763,7 @@
 </p:notes>
 </file>
 
-<file path=ppt/notesSlides/notesSlide11.xml><?xml version="1.0" encoding="utf-8"?>
+<file path=ppt/notesSlides/notesSlide12.xml><?xml version="1.0" encoding="utf-8"?>
 <p:notes xmlns:a="http://schemas.openxmlformats.org/drawingml/2006/main" xmlns:r="http://schemas.openxmlformats.org/officeDocument/2006/relationships" xmlns:p="http://schemas.openxmlformats.org/presentationml/2006/main">
   <p:cSld>
     <p:spTree>
@@ -748,7 +847,7 @@
           <a:p>
             <a:fld id="{F7021451-1387-4CA6-816F-3879F97B5CBC}" type="slidenum">
               <a:rPr lang="en-US"/>
-              <a:t>11</a:t>
+              <a:t>12</a:t>
             </a:fld>
             <a:endParaRPr lang="en-US"/>
           </a:p>
@@ -767,7 +866,7 @@
 </p:notes>
 </file>
 
-<file path=ppt/notesSlides/notesSlide12.xml><?xml version="1.0" encoding="utf-8"?>
+<file path=ppt/notesSlides/notesSlide13.xml><?xml version="1.0" encoding="utf-8"?>
 <p:notes xmlns:a="http://schemas.openxmlformats.org/drawingml/2006/main" xmlns:r="http://schemas.openxmlformats.org/officeDocument/2006/relationships" xmlns:p="http://schemas.openxmlformats.org/presentationml/2006/main">
   <p:cSld>
     <p:spTree>
@@ -844,7 +943,7 @@
           <a:p>
             <a:fld id="{F7021451-1387-4CA6-816F-3879F97B5CBC}" type="slidenum">
               <a:rPr lang="en-US"/>
-              <a:t>12</a:t>
+              <a:t>13</a:t>
             </a:fld>
             <a:endParaRPr lang="en-US"/>
           </a:p>
@@ -863,7 +962,7 @@
 </p:notes>
 </file>
 
-<file path=ppt/notesSlides/notesSlide13.xml><?xml version="1.0" encoding="utf-8"?>
+<file path=ppt/notesSlides/notesSlide14.xml><?xml version="1.0" encoding="utf-8"?>
 <p:notes xmlns:a="http://schemas.openxmlformats.org/drawingml/2006/main" xmlns:r="http://schemas.openxmlformats.org/officeDocument/2006/relationships" xmlns:p="http://schemas.openxmlformats.org/presentationml/2006/main">
   <p:cSld>
     <p:spTree>
@@ -942,7 +1041,7 @@
           <a:p>
             <a:fld id="{F7021451-1387-4CA6-816F-3879F97B5CBC}" type="slidenum">
               <a:rPr lang="en-US"/>
-              <a:t>13</a:t>
+              <a:t>14</a:t>
             </a:fld>
             <a:endParaRPr lang="en-US"/>
           </a:p>
@@ -961,7 +1060,7 @@
 </p:notes>
 </file>
 
-<file path=ppt/notesSlides/notesSlide14.xml><?xml version="1.0" encoding="utf-8"?>
+<file path=ppt/notesSlides/notesSlide15.xml><?xml version="1.0" encoding="utf-8"?>
 <p:notes xmlns:a="http://schemas.openxmlformats.org/drawingml/2006/main" xmlns:r="http://schemas.openxmlformats.org/officeDocument/2006/relationships" xmlns:p="http://schemas.openxmlformats.org/presentationml/2006/main">
   <p:cSld>
     <p:spTree>
@@ -1040,7 +1139,7 @@
           <a:p>
             <a:fld id="{F7021451-1387-4CA6-816F-3879F97B5CBC}" type="slidenum">
               <a:rPr lang="en-US"/>
-              <a:t>14</a:t>
+              <a:t>15</a:t>
             </a:fld>
             <a:endParaRPr lang="en-US"/>
           </a:p>
@@ -1059,7 +1158,7 @@
 </p:notes>
 </file>
 
-<file path=ppt/notesSlides/notesSlide15.xml><?xml version="1.0" encoding="utf-8"?>
+<file path=ppt/notesSlides/notesSlide16.xml><?xml version="1.0" encoding="utf-8"?>
 <p:notes xmlns:a="http://schemas.openxmlformats.org/drawingml/2006/main" xmlns:r="http://schemas.openxmlformats.org/officeDocument/2006/relationships" xmlns:p="http://schemas.openxmlformats.org/presentationml/2006/main">
   <p:cSld>
     <p:spTree>
@@ -1140,7 +1239,7 @@
           <a:p>
             <a:fld id="{F7021451-1387-4CA6-816F-3879F97B5CBC}" type="slidenum">
               <a:rPr lang="en-US"/>
-              <a:t>15</a:t>
+              <a:t>16</a:t>
             </a:fld>
             <a:endParaRPr lang="en-US"/>
           </a:p>
@@ -1159,7 +1258,7 @@
 </p:notes>
 </file>
 
-<file path=ppt/notesSlides/notesSlide16.xml><?xml version="1.0" encoding="utf-8"?>
+<file path=ppt/notesSlides/notesSlide17.xml><?xml version="1.0" encoding="utf-8"?>
 <p:notes xmlns:a="http://schemas.openxmlformats.org/drawingml/2006/main" xmlns:r="http://schemas.openxmlformats.org/officeDocument/2006/relationships" xmlns:p="http://schemas.openxmlformats.org/presentationml/2006/main">
   <p:cSld>
     <p:spTree>
@@ -1230,7 +1329,7 @@
           <a:p>
             <a:fld id="{F7021451-1387-4CA6-816F-3879F97B5CBC}" type="slidenum">
               <a:rPr lang="en-US"/>
-              <a:t>16</a:t>
+              <a:t>17</a:t>
             </a:fld>
             <a:endParaRPr lang="en-US"/>
           </a:p>
@@ -1249,7 +1348,7 @@
 </p:notes>
 </file>
 
-<file path=ppt/notesSlides/notesSlide17.xml><?xml version="1.0" encoding="utf-8"?>
+<file path=ppt/notesSlides/notesSlide18.xml><?xml version="1.0" encoding="utf-8"?>
 <p:notes xmlns:a="http://schemas.openxmlformats.org/drawingml/2006/main" xmlns:r="http://schemas.openxmlformats.org/officeDocument/2006/relationships" xmlns:p="http://schemas.openxmlformats.org/presentationml/2006/main">
   <p:cSld>
     <p:spTree>
@@ -1327,7 +1426,7 @@
           <a:p>
             <a:fld id="{F7021451-1387-4CA6-816F-3879F97B5CBC}" type="slidenum">
               <a:rPr lang="en-US"/>
-              <a:t>17</a:t>
+              <a:t>18</a:t>
             </a:fld>
             <a:endParaRPr lang="en-US"/>
           </a:p>
@@ -1346,7 +1445,7 @@
 </p:notes>
 </file>
 
-<file path=ppt/notesSlides/notesSlide18.xml><?xml version="1.0" encoding="utf-8"?>
+<file path=ppt/notesSlides/notesSlide19.xml><?xml version="1.0" encoding="utf-8"?>
 <p:notes xmlns:a="http://schemas.openxmlformats.org/drawingml/2006/main" xmlns:r="http://schemas.openxmlformats.org/officeDocument/2006/relationships" xmlns:p="http://schemas.openxmlformats.org/presentationml/2006/main">
   <p:cSld>
     <p:spTree>
@@ -1423,7 +1522,7 @@
           <a:p>
             <a:fld id="{F7021451-1387-4CA6-816F-3879F97B5CBC}" type="slidenum">
               <a:rPr lang="en-US"/>
-              <a:t>18</a:t>
+              <a:t>19</a:t>
             </a:fld>
             <a:endParaRPr lang="en-US"/>
           </a:p>
@@ -1632,6 +1731,103 @@
 </file>
 
 <file path=ppt/notesSlides/notesSlide4.xml><?xml version="1.0" encoding="utf-8"?>
+<p:notes xmlns:a="http://schemas.openxmlformats.org/drawingml/2006/main" xmlns:r="http://schemas.openxmlformats.org/officeDocument/2006/relationships" xmlns:p="http://schemas.openxmlformats.org/presentationml/2006/main">
+  <p:cSld>
+    <p:spTree>
+      <p:nvGrpSpPr>
+        <p:cNvPr id="1" name=""/>
+        <p:cNvGrpSpPr/>
+        <p:nvPr/>
+      </p:nvGrpSpPr>
+      <p:grpSpPr>
+        <a:xfrm>
+          <a:off x="0" y="0"/>
+          <a:ext cx="0" cy="0"/>
+          <a:chOff x="0" y="0"/>
+          <a:chExt cx="0" cy="0"/>
+        </a:xfrm>
+      </p:grpSpPr>
+      <p:sp>
+        <p:nvSpPr>
+          <p:cNvPr id="2" name="Slide Image Placeholder 1"/>
+          <p:cNvSpPr>
+            <a:spLocks noGrp="1" noRot="1" noChangeAspect="1"/>
+          </p:cNvSpPr>
+          <p:nvPr>
+            <p:ph type="sldImg"/>
+          </p:nvPr>
+        </p:nvSpPr>
+        <p:spPr/>
+      </p:sp>
+      <p:sp>
+        <p:nvSpPr>
+          <p:cNvPr id="3" name="Notes Placeholder 2"/>
+          <p:cNvSpPr>
+            <a:spLocks noGrp="1"/>
+          </p:cNvSpPr>
+          <p:nvPr>
+            <p:ph type="body" idx="1"/>
+          </p:nvPr>
+        </p:nvSpPr>
+        <p:spPr/>
+        <p:txBody>
+          <a:bodyPr/>
+          <a:lstStyle/>
+          <a:p>
+            <a:r>
+              <a:rPr lang="en-US" dirty="0"/>
+              <a:t>[Say] (1:15)
+"Why did we move at all? Because the ambition of spatial data infrastructures, INSPIRE's ambition, discoverable, interoperable, usable across borders, was right, and the experience has often been painful. For the publisher, publishing a dataset has meant deploying databases, servers, APIs and a portal, then maintaining them for years, sized for peaks, paid for whether anyone uses the data or not. For the user, finding the dataset is only the beginning: understand the service, interpret the metadata, download, reproject, clean, combine. In practice, mainly GIS specialists get through."
+[Click 1]
+"Three changes are now converging. Cloud-native formats changed the economics: a client reads only the bytes it needs, with its own compute, and the publisher stores the data once. Agents changed who can use the data: given structured metadata and direct access, an agent finds the authoritative sources, inspects them, runs the analysis and answers with its sources and a query you can re-run; federation without a central copy. And sovereignty became an architectural requirement: where the data lives, where queries run, which models may touch it, how easily each layer can be replaced."
+[Click 2]
+"All three were already under way. What was still hard was assembling them into an infrastructure a real publisher can create, operate and maintain without designing the whole architecture from scratch. That is why we joined others in building Portolan."
+[Sources]
+- Launch commentary, 2 September 2026: https://carto.com/blog/introducing-portolan-and-carto-sdi/ ("The ambition was right. The experience has often been painful."; "Three changes reshaping spatial data infrastructure"; "What is still difficult is assembling them into an SDI that a real data publisher can create, operate, and maintain")
+- https://www.portolan-sdi.org/blog/introducing-portolan ("What Portolan makes possible", "Built for people and agents")
+- https://inspire.ec.europa.eu/</a:t>
+            </a:r>
+            <a:endParaRPr lang="en-US" dirty="0"/>
+          </a:p>
+        </p:txBody>
+      </p:sp>
+      <p:sp>
+        <p:nvSpPr>
+          <p:cNvPr id="4" name="Slide Number Placeholder 3"/>
+          <p:cNvSpPr>
+            <a:spLocks noGrp="1"/>
+          </p:cNvSpPr>
+          <p:nvPr>
+            <p:ph type="sldNum" sz="quarter" idx="10"/>
+          </p:nvPr>
+        </p:nvSpPr>
+        <p:spPr/>
+        <p:txBody>
+          <a:bodyPr/>
+          <a:lstStyle/>
+          <a:p>
+            <a:fld id="{F7021451-1387-4CA6-816F-3879F97B5CBC}" type="slidenum">
+              <a:rPr lang="en-US"/>
+              <a:t>4</a:t>
+            </a:fld>
+            <a:endParaRPr lang="en-US"/>
+          </a:p>
+        </p:txBody>
+      </p:sp>
+    </p:spTree>
+    <p:extLst>
+      <p:ext uri="{BB962C8B-B14F-4D97-AF65-F5344CB8AC3E}">
+        <p14:creationId xmlns:p14="http://schemas.microsoft.com/office/powerpoint/2010/main" val="1024086991"/>
+      </p:ext>
+    </p:extLst>
+  </p:cSld>
+  <p:clrMapOvr>
+    <a:masterClrMapping/>
+  </p:clrMapOvr>
+</p:notes>
+</file>
+
+<file path=ppt/notesSlides/notesSlide5.xml><?xml version="1.0" encoding="utf-8"?>
 <p:notes xmlns:a="http://schemas.openxmlformats.org/drawingml/2006/main" xmlns:r="http://schemas.openxmlformats.org/officeDocument/2006/relationships" xmlns:p="http://schemas.openxmlformats.org/presentationml/2006/main">
   <p:cSld>
     <p:spTree>
@@ -1712,7 +1908,7 @@
           <a:p>
             <a:fld id="{F7021451-1387-4CA6-816F-3879F97B5CBC}" type="slidenum">
               <a:rPr lang="en-US"/>
-              <a:t>4</a:t>
+              <a:t>5</a:t>
             </a:fld>
             <a:endParaRPr lang="en-US"/>
           </a:p>
@@ -1731,7 +1927,7 @@
 </p:notes>
 </file>
 
-<file path=ppt/notesSlides/notesSlide5.xml><?xml version="1.0" encoding="utf-8"?>
+<file path=ppt/notesSlides/notesSlide6.xml><?xml version="1.0" encoding="utf-8"?>
 <p:notes xmlns:a="http://schemas.openxmlformats.org/drawingml/2006/main" xmlns:r="http://schemas.openxmlformats.org/officeDocument/2006/relationships" xmlns:p="http://schemas.openxmlformats.org/presentationml/2006/main">
   <p:cSld>
     <p:spTree>
@@ -1777,8 +1973,8 @@
           <a:p>
             <a:r>
               <a:rPr lang="en-US" dirty="0"/>
-              <a:t>[Say] (1:30)
-"So what does Portolan add, and why should anyone outside this room care? Four things the standards leave open become mandatory. One: a quality floor you can check. Spatial ordering and bounding boxes inside every GeoParquet, overviews in every COG, providers and a license on every collection, range requests and CORS on the host; and the validator reads the bytes, not just the JSON. Two: documentation for two audiences at every level, a README for the person deciding whether to trust the data and an AGENTS file for the agent that needs the join key and the caveats. Three: no server in the request path; a catalog is a folder in storage the publisher controls, cost drops to storage and egress, sovereignty is structural, nothing runs after publishing. Four: federation without a central copy, a registry of independently hosted catalogs with producer, provider and host named on every one. Why now? Cloud-native formats moved the compute to whoever asks the question. Agents changed who can ask. Sovereignty made every layer a choice. Portolan is the missing agreement that lets a city and a planetary archive publish the same way."
+              <a:t>[Say] (1:15)
+"So what does Portolan add, and why should anyone outside this room care? Four things the standards leave open become mandatory. One: a quality floor you can check. Spatial ordering and bounding boxes inside every GeoParquet, overviews in every COG, providers and a license on every collection, range requests and CORS on the host; and the validator reads the bytes, not just the JSON. Two: documentation for two audiences at every level, a README for the person deciding whether to trust the data and an AGENTS file for the agent that needs the join key and the caveats. Three: no server in the request path; a catalog is a folder in storage the publisher controls, cost drops to storage and egress, sovereignty is structural, nothing runs after publishing. Four: federation without a central copy, a registry of independently hosted catalogs with producer, provider and host named on every one. Portolan is the missing agreement that lets a city and a planetary archive publish the same way."
 [Click 1]
 "Does a static model scale? Fields of the World publishes its global field-boundary dataset as one Portolan catalog on Source Cooperative: 369 terabytes, and it served a hundred and six terabytes in the last four weeks of August. Nothing sits in front of it. The publisher pays for storage and egress; compute belongs to whoever asks the question."
 [Sources]
@@ -1810,7 +2006,7 @@
           <a:p>
             <a:fld id="{F7021451-1387-4CA6-816F-3879F97B5CBC}" type="slidenum">
               <a:rPr lang="en-US"/>
-              <a:t>5</a:t>
+              <a:t>6</a:t>
             </a:fld>
             <a:endParaRPr lang="en-US"/>
           </a:p>
@@ -1829,7 +2025,7 @@
 </p:notes>
 </file>
 
-<file path=ppt/notesSlides/notesSlide6.xml><?xml version="1.0" encoding="utf-8"?>
+<file path=ppt/notesSlides/notesSlide7.xml><?xml version="1.0" encoding="utf-8"?>
 <p:notes xmlns:a="http://schemas.openxmlformats.org/drawingml/2006/main" xmlns:r="http://schemas.openxmlformats.org/officeDocument/2006/relationships" xmlns:p="http://schemas.openxmlformats.org/presentationml/2006/main">
   <p:cSld>
     <p:spTree>
@@ -1912,7 +2108,7 @@
           <a:p>
             <a:fld id="{F7021451-1387-4CA6-816F-3879F97B5CBC}" type="slidenum">
               <a:rPr lang="en-US"/>
-              <a:t>6</a:t>
+              <a:t>7</a:t>
             </a:fld>
             <a:endParaRPr lang="en-US"/>
           </a:p>
@@ -1931,7 +2127,7 @@
 </p:notes>
 </file>
 
-<file path=ppt/notesSlides/notesSlide7.xml><?xml version="1.0" encoding="utf-8"?>
+<file path=ppt/notesSlides/notesSlide8.xml><?xml version="1.0" encoding="utf-8"?>
 <p:notes xmlns:a="http://schemas.openxmlformats.org/drawingml/2006/main" xmlns:r="http://schemas.openxmlformats.org/officeDocument/2006/relationships" xmlns:p="http://schemas.openxmlformats.org/presentationml/2006/main">
   <p:cSld>
     <p:spTree>
@@ -2007,7 +2203,7 @@
           <a:p>
             <a:fld id="{F7021451-1387-4CA6-816F-3879F97B5CBC}" type="slidenum">
               <a:rPr lang="en-US"/>
-              <a:t>7</a:t>
+              <a:t>8</a:t>
             </a:fld>
             <a:endParaRPr lang="en-US"/>
           </a:p>
@@ -2026,7 +2222,7 @@
 </p:notes>
 </file>
 
-<file path=ppt/notesSlides/notesSlide8.xml><?xml version="1.0" encoding="utf-8"?>
+<file path=ppt/notesSlides/notesSlide9.xml><?xml version="1.0" encoding="utf-8"?>
 <p:notes xmlns:a="http://schemas.openxmlformats.org/drawingml/2006/main" xmlns:r="http://schemas.openxmlformats.org/officeDocument/2006/relationships" xmlns:p="http://schemas.openxmlformats.org/presentationml/2006/main">
   <p:cSld>
     <p:spTree>
@@ -2086,104 +2282,6 @@
 "It reported with method, URLs, producer, license and limitations. Every step consumed something the publisher wrote down. Nothing was guessed. I cannot run this in ten minutes, so both stories run live at the demo desk at the coffee breaks, today and tomorrow. Bring the URL of your WFS and a question."
 [Sources]
 - https://github.com/portolan-sdi/portolan-skills/tree/main/skills/reading-portolan</a:t>
-            </a:r>
-            <a:endParaRPr lang="en-US" dirty="0"/>
-          </a:p>
-        </p:txBody>
-      </p:sp>
-      <p:sp>
-        <p:nvSpPr>
-          <p:cNvPr id="4" name="Slide Number Placeholder 3"/>
-          <p:cNvSpPr>
-            <a:spLocks noGrp="1"/>
-          </p:cNvSpPr>
-          <p:nvPr>
-            <p:ph type="sldNum" sz="quarter" idx="10"/>
-          </p:nvPr>
-        </p:nvSpPr>
-        <p:spPr/>
-        <p:txBody>
-          <a:bodyPr/>
-          <a:lstStyle/>
-          <a:p>
-            <a:fld id="{F7021451-1387-4CA6-816F-3879F97B5CBC}" type="slidenum">
-              <a:rPr lang="en-US"/>
-              <a:t>8</a:t>
-            </a:fld>
-            <a:endParaRPr lang="en-US"/>
-          </a:p>
-        </p:txBody>
-      </p:sp>
-    </p:spTree>
-    <p:extLst>
-      <p:ext uri="{BB962C8B-B14F-4D97-AF65-F5344CB8AC3E}">
-        <p14:creationId xmlns:p14="http://schemas.microsoft.com/office/powerpoint/2010/main" val="1024086991"/>
-      </p:ext>
-    </p:extLst>
-  </p:cSld>
-  <p:clrMapOvr>
-    <a:masterClrMapping/>
-  </p:clrMapOvr>
-</p:notes>
-</file>
-
-<file path=ppt/notesSlides/notesSlide9.xml><?xml version="1.0" encoding="utf-8"?>
-<p:notes xmlns:a="http://schemas.openxmlformats.org/drawingml/2006/main" xmlns:r="http://schemas.openxmlformats.org/officeDocument/2006/relationships" xmlns:p="http://schemas.openxmlformats.org/presentationml/2006/main">
-  <p:cSld>
-    <p:spTree>
-      <p:nvGrpSpPr>
-        <p:cNvPr id="1" name=""/>
-        <p:cNvGrpSpPr/>
-        <p:nvPr/>
-      </p:nvGrpSpPr>
-      <p:grpSpPr>
-        <a:xfrm>
-          <a:off x="0" y="0"/>
-          <a:ext cx="0" cy="0"/>
-          <a:chOff x="0" y="0"/>
-          <a:chExt cx="0" cy="0"/>
-        </a:xfrm>
-      </p:grpSpPr>
-      <p:sp>
-        <p:nvSpPr>
-          <p:cNvPr id="2" name="Slide Image Placeholder 1"/>
-          <p:cNvSpPr>
-            <a:spLocks noGrp="1" noRot="1" noChangeAspect="1"/>
-          </p:cNvSpPr>
-          <p:nvPr>
-            <p:ph type="sldImg"/>
-          </p:nvPr>
-        </p:nvSpPr>
-        <p:spPr/>
-      </p:sp>
-      <p:sp>
-        <p:nvSpPr>
-          <p:cNvPr id="3" name="Notes Placeholder 2"/>
-          <p:cNvSpPr>
-            <a:spLocks noGrp="1"/>
-          </p:cNvSpPr>
-          <p:nvPr>
-            <p:ph type="body" idx="1"/>
-          </p:nvPr>
-        </p:nvSpPr>
-        <p:spPr/>
-        <p:txBody>
-          <a:bodyPr/>
-          <a:lstStyle/>
-          <a:p>
-            <a:r>
-              <a:rPr lang="en-US" dirty="0"/>
-              <a:t>[Say] (1:15)
-"Three lessons from building this. The first is the one I would keep if I could keep only one. A well-formed STAC catalog is already findable and crawlable. Discovery is largely solved. What people and agents cannot do yet is evaluate: is this dataset fit for my question, where is it weak, how wrong can it be."
-[Click 1]
-"One sentence from a real catalog, Fields of the World: a field polygon is a remote-sensing field unit, not a cadastral parcel. That single sentence prevents a whole category of misuse that no accuracy number would catch. In the Bolzano answer you saw the same thing: a hospital point inside a hazard polygon is a location, not a catchment. Someone wrote that down."
-[Click 2]
-"So our working definition. AI-ready means documented limitations, quantified uncertainty and named biases. As data where possible, a confidence column or a quality mask an agent can filter on, rather than a paragraph it has to interpret. This is the expertise that otherwise lives only in the heads of domain experts, and it is the part of your metadata work that no automation replaces."
-[Sources]
-- https://github.com/portolan-sdi/portolan-spec/blob/main/specs/best-practices/documentation.md
-- Trochim &amp; Roy 2025, Candid Core Framework, doi:10.5281/zenodo.15227664
-- https://source.coop/ftw/global-data
-- https://www.portolan-sdi.org/blog/introducing-portolan ("context that'd otherwise be scattered across documentation or live only in the heads of domain experts")</a:t>
             </a:r>
             <a:endParaRPr lang="en-US" dirty="0"/>
           </a:p>
@@ -2886,6 +2984,45 @@
 <file path=ppt/slides/slide18.xml><?xml version="1.0" encoding="utf-8"?>
 <p:sld xmlns:a="http://schemas.openxmlformats.org/drawingml/2006/main" xmlns:r="http://schemas.openxmlformats.org/officeDocument/2006/relationships" xmlns:p="http://schemas.openxmlformats.org/presentationml/2006/main">
   <p:cSld name="Slide 18">
+    <p:bg>
+      <p:bgPr>
+        <a:blipFill dpi="0" rotWithShape="1">
+          <a:blip r:embed="rId1">
+            <a:lum/>
+          </a:blip>
+          <a:srcRect/>
+          <a:stretch>
+            <a:fillRect/>
+          </a:stretch>
+        </a:blipFill>
+        <a:effectLst/>
+      </p:bgPr>
+    </p:bg>
+    <p:spTree>
+      <p:nvGrpSpPr>
+        <p:cNvPr id="1" name=""/>
+        <p:cNvGrpSpPr/>
+        <p:nvPr/>
+      </p:nvGrpSpPr>
+      <p:grpSpPr>
+        <a:xfrm>
+          <a:off x="0" y="0"/>
+          <a:ext cx="0" cy="0"/>
+          <a:chOff x="0" y="0"/>
+          <a:chExt cx="0" cy="0"/>
+        </a:xfrm>
+      </p:grpSpPr>
+    </p:spTree>
+  </p:cSld>
+  <p:clrMapOvr>
+    <a:masterClrMapping/>
+  </p:clrMapOvr>
+</p:sld>
+</file>
+
+<file path=ppt/slides/slide19.xml><?xml version="1.0" encoding="utf-8"?>
+<p:sld xmlns:a="http://schemas.openxmlformats.org/drawingml/2006/main" xmlns:r="http://schemas.openxmlformats.org/officeDocument/2006/relationships" xmlns:p="http://schemas.openxmlformats.org/presentationml/2006/main">
+  <p:cSld name="Slide 19">
     <p:bg>
       <p:bgPr>
         <a:blipFill dpi="0" rotWithShape="1">

</xml_diff>

<commit_message>
Postscript slide on the name (Agnese 1550 chart, public domain); cover logos readable in dark mode
</commit_message>
<xml_diff>
--- a/export/ogc-metadata-summit-2026.pptx
+++ b/export/ogc-metadata-summit-2026.pptx
@@ -24,9 +24,10 @@
     <p:sldId id="272" r:id="rId18"/>
     <p:sldId id="273" r:id="rId19"/>
     <p:sldId id="274" r:id="rId20"/>
+    <p:sldId id="275" r:id="rId21"/>
   </p:sldIdLst>
   <p:notesMasterIdLst>
-    <p:notesMasterId r:id="rId21"/>
+    <p:notesMasterId r:id="rId22"/>
   </p:notesMasterIdLst>
   <p:sldSz cx="9334500" cy="5248275"/>
   <p:notesSz cx="5248275" cy="9334500"/>
@@ -1106,6 +1107,100 @@
           <a:p>
             <a:r>
               <a:rPr lang="en-US" dirty="0"/>
+              <a:t>[Say] (0:45)
+"A postscript on the name. Portolan charts were among the earliest practical navigational maps. Not theoretical pictures of the world but working tools: built from sailors' observations, continuously refined, shared across ports and nations. Decentralised, made and improved by many hands. Interoperable, readable wherever a ship went. And critical infrastructure, for trade, for safety, for sovereignty."
+[Click 1]
+"The project takes its name from that tradition. Practical rather than academic. Built from data in open formats rather than drawings. Designed for sharing across organisations, clouds and borders. Thank you."
+[Sources]
+- Launch commentary, 2 September 2026: https://carto.com/blog/introducing-portolan-and-carto-sdi/ ("A postscript on the name")
+- Image: Wikimedia Commons, "1550 Portolan chart of the Mediterranean Sea and the Black Sea", Battista Agnese; Bibliothèque nationale de France; public domain</a:t>
+            </a:r>
+            <a:endParaRPr lang="en-US" dirty="0"/>
+          </a:p>
+        </p:txBody>
+      </p:sp>
+      <p:sp>
+        <p:nvSpPr>
+          <p:cNvPr id="4" name="Slide Number Placeholder 3"/>
+          <p:cNvSpPr>
+            <a:spLocks noGrp="1"/>
+          </p:cNvSpPr>
+          <p:nvPr>
+            <p:ph type="sldNum" sz="quarter" idx="10"/>
+          </p:nvPr>
+        </p:nvSpPr>
+        <p:spPr/>
+        <p:txBody>
+          <a:bodyPr/>
+          <a:lstStyle/>
+          <a:p>
+            <a:fld id="{F7021451-1387-4CA6-816F-3879F97B5CBC}" type="slidenum">
+              <a:rPr lang="en-US"/>
+              <a:t>15</a:t>
+            </a:fld>
+            <a:endParaRPr lang="en-US"/>
+          </a:p>
+        </p:txBody>
+      </p:sp>
+    </p:spTree>
+    <p:extLst>
+      <p:ext uri="{BB962C8B-B14F-4D97-AF65-F5344CB8AC3E}">
+        <p14:creationId xmlns:p14="http://schemas.microsoft.com/office/powerpoint/2010/main" val="1024086991"/>
+      </p:ext>
+    </p:extLst>
+  </p:cSld>
+  <p:clrMapOvr>
+    <a:masterClrMapping/>
+  </p:clrMapOvr>
+</p:notes>
+</file>
+
+<file path=ppt/notesSlides/notesSlide16.xml><?xml version="1.0" encoding="utf-8"?>
+<p:notes xmlns:a="http://schemas.openxmlformats.org/drawingml/2006/main" xmlns:r="http://schemas.openxmlformats.org/officeDocument/2006/relationships" xmlns:p="http://schemas.openxmlformats.org/presentationml/2006/main">
+  <p:cSld>
+    <p:spTree>
+      <p:nvGrpSpPr>
+        <p:cNvPr id="1" name=""/>
+        <p:cNvGrpSpPr/>
+        <p:nvPr/>
+      </p:nvGrpSpPr>
+      <p:grpSpPr>
+        <a:xfrm>
+          <a:off x="0" y="0"/>
+          <a:ext cx="0" cy="0"/>
+          <a:chOff x="0" y="0"/>
+          <a:chExt cx="0" cy="0"/>
+        </a:xfrm>
+      </p:grpSpPr>
+      <p:sp>
+        <p:nvSpPr>
+          <p:cNvPr id="2" name="Slide Image Placeholder 1"/>
+          <p:cNvSpPr>
+            <a:spLocks noGrp="1" noRot="1" noChangeAspect="1"/>
+          </p:cNvSpPr>
+          <p:nvPr>
+            <p:ph type="sldImg"/>
+          </p:nvPr>
+        </p:nvSpPr>
+        <p:spPr/>
+      </p:sp>
+      <p:sp>
+        <p:nvSpPr>
+          <p:cNvPr id="3" name="Notes Placeholder 2"/>
+          <p:cNvSpPr>
+            <a:spLocks noGrp="1"/>
+          </p:cNvSpPr>
+          <p:nvPr>
+            <p:ph type="body" idx="1"/>
+          </p:nvPr>
+        </p:nvSpPr>
+        <p:spPr/>
+        <p:txBody>
+          <a:bodyPr/>
+          <a:lstStyle/>
+          <a:p>
+            <a:r>
+              <a:rPr lang="en-US" dirty="0"/>
               <a:t>[Say] (shown during Q&amp;A, no talk time)
 "Feedback as GitHub issues against the spec or against any catalog. Mirrors of national datasets are welcome, there is an open list. The validator and the grader are open for anyone to run. One URL: portolan-sdi.org. And find me at the demo desk."
 [Sources]
@@ -1139,7 +1234,7 @@
           <a:p>
             <a:fld id="{F7021451-1387-4CA6-816F-3879F97B5CBC}" type="slidenum">
               <a:rPr lang="en-US"/>
-              <a:t>15</a:t>
+              <a:t>16</a:t>
             </a:fld>
             <a:endParaRPr lang="en-US"/>
           </a:p>
@@ -1158,7 +1253,7 @@
 </p:notes>
 </file>
 
-<file path=ppt/notesSlides/notesSlide16.xml><?xml version="1.0" encoding="utf-8"?>
+<file path=ppt/notesSlides/notesSlide17.xml><?xml version="1.0" encoding="utf-8"?>
 <p:notes xmlns:a="http://schemas.openxmlformats.org/drawingml/2006/main" xmlns:r="http://schemas.openxmlformats.org/officeDocument/2006/relationships" xmlns:p="http://schemas.openxmlformats.org/presentationml/2006/main">
   <p:cSld>
     <p:spTree>
@@ -1239,7 +1334,7 @@
           <a:p>
             <a:fld id="{F7021451-1387-4CA6-816F-3879F97B5CBC}" type="slidenum">
               <a:rPr lang="en-US"/>
-              <a:t>16</a:t>
+              <a:t>17</a:t>
             </a:fld>
             <a:endParaRPr lang="en-US"/>
           </a:p>
@@ -1258,7 +1353,7 @@
 </p:notes>
 </file>
 
-<file path=ppt/notesSlides/notesSlide17.xml><?xml version="1.0" encoding="utf-8"?>
+<file path=ppt/notesSlides/notesSlide18.xml><?xml version="1.0" encoding="utf-8"?>
 <p:notes xmlns:a="http://schemas.openxmlformats.org/drawingml/2006/main" xmlns:r="http://schemas.openxmlformats.org/officeDocument/2006/relationships" xmlns:p="http://schemas.openxmlformats.org/presentationml/2006/main">
   <p:cSld>
     <p:spTree>
@@ -1329,7 +1424,7 @@
           <a:p>
             <a:fld id="{F7021451-1387-4CA6-816F-3879F97B5CBC}" type="slidenum">
               <a:rPr lang="en-US"/>
-              <a:t>17</a:t>
+              <a:t>18</a:t>
             </a:fld>
             <a:endParaRPr lang="en-US"/>
           </a:p>
@@ -1348,7 +1443,7 @@
 </p:notes>
 </file>
 
-<file path=ppt/notesSlides/notesSlide18.xml><?xml version="1.0" encoding="utf-8"?>
+<file path=ppt/notesSlides/notesSlide19.xml><?xml version="1.0" encoding="utf-8"?>
 <p:notes xmlns:a="http://schemas.openxmlformats.org/drawingml/2006/main" xmlns:r="http://schemas.openxmlformats.org/officeDocument/2006/relationships" xmlns:p="http://schemas.openxmlformats.org/presentationml/2006/main">
   <p:cSld>
     <p:spTree>
@@ -1426,7 +1521,7 @@
           <a:p>
             <a:fld id="{F7021451-1387-4CA6-816F-3879F97B5CBC}" type="slidenum">
               <a:rPr lang="en-US"/>
-              <a:t>18</a:t>
+              <a:t>19</a:t>
             </a:fld>
             <a:endParaRPr lang="en-US"/>
           </a:p>
@@ -1445,7 +1540,99 @@
 </p:notes>
 </file>
 
-<file path=ppt/notesSlides/notesSlide19.xml><?xml version="1.0" encoding="utf-8"?>
+<file path=ppt/notesSlides/notesSlide2.xml><?xml version="1.0" encoding="utf-8"?>
+<p:notes xmlns:a="http://schemas.openxmlformats.org/drawingml/2006/main" xmlns:r="http://schemas.openxmlformats.org/officeDocument/2006/relationships" xmlns:p="http://schemas.openxmlformats.org/presentationml/2006/main">
+  <p:cSld>
+    <p:spTree>
+      <p:nvGrpSpPr>
+        <p:cNvPr id="1" name=""/>
+        <p:cNvGrpSpPr/>
+        <p:nvPr/>
+      </p:nvGrpSpPr>
+      <p:grpSpPr>
+        <a:xfrm>
+          <a:off x="0" y="0"/>
+          <a:ext cx="0" cy="0"/>
+          <a:chOff x="0" y="0"/>
+          <a:chExt cx="0" cy="0"/>
+        </a:xfrm>
+      </p:grpSpPr>
+      <p:sp>
+        <p:nvSpPr>
+          <p:cNvPr id="2" name="Slide Image Placeholder 1"/>
+          <p:cNvSpPr>
+            <a:spLocks noGrp="1" noRot="1" noChangeAspect="1"/>
+          </p:cNvSpPr>
+          <p:nvPr>
+            <p:ph type="sldImg"/>
+          </p:nvPr>
+        </p:nvSpPr>
+        <p:spPr/>
+      </p:sp>
+      <p:sp>
+        <p:nvSpPr>
+          <p:cNvPr id="3" name="Notes Placeholder 2"/>
+          <p:cNvSpPr>
+            <a:spLocks noGrp="1"/>
+          </p:cNvSpPr>
+          <p:nvPr>
+            <p:ph type="body" idx="1"/>
+          </p:nvPr>
+        </p:nvSpPr>
+        <p:spPr/>
+        <p:txBody>
+          <a:bodyPr/>
+          <a:lstStyle/>
+          <a:p>
+            <a:r>
+              <a:rPr lang="en-US" dirty="0"/>
+              <a:t>[Say] (0:45)
+"Briefly, who is talking. I have spent more than twenty years in geospatial, on data, science and maps: spatial data infrastructures, spatial SQL, and lately the cloud-native formats. I work at CARTO in Seville, and I am one of the contributors to Portolan: the publisher CLI, catalogs, and the mirror of this province's data you will see in a few minutes. I also work on STAC extensions. Everything I show is open; the addresses are on the right and on the last slide. Find me at the demo desk in the breaks."
+[Sources]
+- https://github.com/cayetanobv (public profile: "Data, science &amp; maps", CARTO, Seville; repos stac-portolan-extension, stac-partition-extension, stac-osi-extension, authentication, duckdb-raquet, geoparquet-overviews)
+- https://www.portolan-sdi.org/blog/introducing-portolan (named contributor)</a:t>
+            </a:r>
+            <a:endParaRPr lang="en-US" dirty="0"/>
+          </a:p>
+        </p:txBody>
+      </p:sp>
+      <p:sp>
+        <p:nvSpPr>
+          <p:cNvPr id="4" name="Slide Number Placeholder 3"/>
+          <p:cNvSpPr>
+            <a:spLocks noGrp="1"/>
+          </p:cNvSpPr>
+          <p:nvPr>
+            <p:ph type="sldNum" sz="quarter" idx="10"/>
+          </p:nvPr>
+        </p:nvSpPr>
+        <p:spPr/>
+        <p:txBody>
+          <a:bodyPr/>
+          <a:lstStyle/>
+          <a:p>
+            <a:fld id="{F7021451-1387-4CA6-816F-3879F97B5CBC}" type="slidenum">
+              <a:rPr lang="en-US"/>
+              <a:t>2</a:t>
+            </a:fld>
+            <a:endParaRPr lang="en-US"/>
+          </a:p>
+        </p:txBody>
+      </p:sp>
+    </p:spTree>
+    <p:extLst>
+      <p:ext uri="{BB962C8B-B14F-4D97-AF65-F5344CB8AC3E}">
+        <p14:creationId xmlns:p14="http://schemas.microsoft.com/office/powerpoint/2010/main" val="1024086991"/>
+      </p:ext>
+    </p:extLst>
+  </p:cSld>
+  <p:clrMapOvr>
+    <a:masterClrMapping/>
+  </p:clrMapOvr>
+</p:notes>
+</file>
+
+<file path=ppt/notesSlides/notesSlide20.xml><?xml version="1.0" encoding="utf-8"?>
 <p:notes xmlns:a="http://schemas.openxmlformats.org/drawingml/2006/main" xmlns:r="http://schemas.openxmlformats.org/officeDocument/2006/relationships" xmlns:p="http://schemas.openxmlformats.org/presentationml/2006/main">
   <p:cSld>
     <p:spTree>
@@ -1522,99 +1709,7 @@
           <a:p>
             <a:fld id="{F7021451-1387-4CA6-816F-3879F97B5CBC}" type="slidenum">
               <a:rPr lang="en-US"/>
-              <a:t>19</a:t>
-            </a:fld>
-            <a:endParaRPr lang="en-US"/>
-          </a:p>
-        </p:txBody>
-      </p:sp>
-    </p:spTree>
-    <p:extLst>
-      <p:ext uri="{BB962C8B-B14F-4D97-AF65-F5344CB8AC3E}">
-        <p14:creationId xmlns:p14="http://schemas.microsoft.com/office/powerpoint/2010/main" val="1024086991"/>
-      </p:ext>
-    </p:extLst>
-  </p:cSld>
-  <p:clrMapOvr>
-    <a:masterClrMapping/>
-  </p:clrMapOvr>
-</p:notes>
-</file>
-
-<file path=ppt/notesSlides/notesSlide2.xml><?xml version="1.0" encoding="utf-8"?>
-<p:notes xmlns:a="http://schemas.openxmlformats.org/drawingml/2006/main" xmlns:r="http://schemas.openxmlformats.org/officeDocument/2006/relationships" xmlns:p="http://schemas.openxmlformats.org/presentationml/2006/main">
-  <p:cSld>
-    <p:spTree>
-      <p:nvGrpSpPr>
-        <p:cNvPr id="1" name=""/>
-        <p:cNvGrpSpPr/>
-        <p:nvPr/>
-      </p:nvGrpSpPr>
-      <p:grpSpPr>
-        <a:xfrm>
-          <a:off x="0" y="0"/>
-          <a:ext cx="0" cy="0"/>
-          <a:chOff x="0" y="0"/>
-          <a:chExt cx="0" cy="0"/>
-        </a:xfrm>
-      </p:grpSpPr>
-      <p:sp>
-        <p:nvSpPr>
-          <p:cNvPr id="2" name="Slide Image Placeholder 1"/>
-          <p:cNvSpPr>
-            <a:spLocks noGrp="1" noRot="1" noChangeAspect="1"/>
-          </p:cNvSpPr>
-          <p:nvPr>
-            <p:ph type="sldImg"/>
-          </p:nvPr>
-        </p:nvSpPr>
-        <p:spPr/>
-      </p:sp>
-      <p:sp>
-        <p:nvSpPr>
-          <p:cNvPr id="3" name="Notes Placeholder 2"/>
-          <p:cNvSpPr>
-            <a:spLocks noGrp="1"/>
-          </p:cNvSpPr>
-          <p:nvPr>
-            <p:ph type="body" idx="1"/>
-          </p:nvPr>
-        </p:nvSpPr>
-        <p:spPr/>
-        <p:txBody>
-          <a:bodyPr/>
-          <a:lstStyle/>
-          <a:p>
-            <a:r>
-              <a:rPr lang="en-US" dirty="0"/>
-              <a:t>[Say] (0:45)
-"Briefly, who is talking. I have spent more than twenty years in geospatial, on data, science and maps: spatial data infrastructures, spatial SQL, and lately the cloud-native formats. I work at CARTO in Seville, and I am one of the contributors to Portolan: the publisher CLI, catalogs, and the mirror of this province's data you will see in a few minutes. I also work on STAC extensions. Everything I show is open; the addresses are on the right and on the last slide. Find me at the demo desk in the breaks."
-[Sources]
-- https://github.com/cayetanobv (public profile: "Data, science &amp; maps", CARTO, Seville; repos stac-portolan-extension, stac-partition-extension, stac-osi-extension, authentication, duckdb-raquet, geoparquet-overviews)
-- https://www.portolan-sdi.org/blog/introducing-portolan (named contributor)</a:t>
-            </a:r>
-            <a:endParaRPr lang="en-US" dirty="0"/>
-          </a:p>
-        </p:txBody>
-      </p:sp>
-      <p:sp>
-        <p:nvSpPr>
-          <p:cNvPr id="4" name="Slide Number Placeholder 3"/>
-          <p:cNvSpPr>
-            <a:spLocks noGrp="1"/>
-          </p:cNvSpPr>
-          <p:nvPr>
-            <p:ph type="sldNum" sz="quarter" idx="10"/>
-          </p:nvPr>
-        </p:nvSpPr>
-        <p:spPr/>
-        <p:txBody>
-          <a:bodyPr/>
-          <a:lstStyle/>
-          <a:p>
-            <a:fld id="{F7021451-1387-4CA6-816F-3879F97B5CBC}" type="slidenum">
-              <a:rPr lang="en-US"/>
-              <a:t>2</a:t>
+              <a:t>20</a:t>
             </a:fld>
             <a:endParaRPr lang="en-US"/>
           </a:p>
@@ -3062,6 +3157,45 @@
 <file path=ppt/slides/slide2.xml><?xml version="1.0" encoding="utf-8"?>
 <p:sld xmlns:a="http://schemas.openxmlformats.org/drawingml/2006/main" xmlns:r="http://schemas.openxmlformats.org/officeDocument/2006/relationships" xmlns:p="http://schemas.openxmlformats.org/presentationml/2006/main">
   <p:cSld name="Slide 2">
+    <p:bg>
+      <p:bgPr>
+        <a:blipFill dpi="0" rotWithShape="1">
+          <a:blip r:embed="rId1">
+            <a:lum/>
+          </a:blip>
+          <a:srcRect/>
+          <a:stretch>
+            <a:fillRect/>
+          </a:stretch>
+        </a:blipFill>
+        <a:effectLst/>
+      </p:bgPr>
+    </p:bg>
+    <p:spTree>
+      <p:nvGrpSpPr>
+        <p:cNvPr id="1" name=""/>
+        <p:cNvGrpSpPr/>
+        <p:nvPr/>
+      </p:nvGrpSpPr>
+      <p:grpSpPr>
+        <a:xfrm>
+          <a:off x="0" y="0"/>
+          <a:ext cx="0" cy="0"/>
+          <a:chOff x="0" y="0"/>
+          <a:chExt cx="0" cy="0"/>
+        </a:xfrm>
+      </p:grpSpPr>
+    </p:spTree>
+  </p:cSld>
+  <p:clrMapOvr>
+    <a:masterClrMapping/>
+  </p:clrMapOvr>
+</p:sld>
+</file>
+
+<file path=ppt/slides/slide20.xml><?xml version="1.0" encoding="utf-8"?>
+<p:sld xmlns:a="http://schemas.openxmlformats.org/drawingml/2006/main" xmlns:r="http://schemas.openxmlformats.org/officeDocument/2006/relationships" xmlns:p="http://schemas.openxmlformats.org/presentationml/2006/main">
+  <p:cSld name="Slide 20">
     <p:bg>
       <p:bgPr>
         <a:blipFill dpi="0" rotWithShape="1">

</xml_diff>

<commit_message>
Bio slide: five-line profile, compact links card with the talk URL
</commit_message>
<xml_diff>
--- a/export/ogc-metadata-summit-2026.pptx
+++ b/export/ogc-metadata-summit-2026.pptx
@@ -1586,11 +1586,11 @@
           <a:p>
             <a:r>
               <a:rPr lang="en-US" dirty="0"/>
-              <a:t>[Say] (0:45)
-"Briefly, who is talking. I have spent more than twenty years in geospatial, on data, science and maps: spatial data infrastructures, spatial SQL, and lately the cloud-native formats. I work at CARTO in Seville, and I am one of the contributors to Portolan: the publisher CLI, catalogs, and the mirror of this province's data you will see in a few minutes. I also work on STAC extensions. Everything I show is open; the addresses are on the right and on the last slide. Find me at the demo desk in the breaks."
+              <a:t>[Say] (0:35)
+"Briefly, who is talking. I am Director of Engineering for Professional Services at CARTO, I collaborate on the Portolan SDI project, and I have spent more than twenty years in the geospatial industry, most of it contributing to open-source software. I am based in Seville. Everything I show is open; the slides and the catalog are at the addresses on the right."
 [Sources]
-- https://github.com/cayetanobv (public profile: "Data, science &amp; maps", CARTO, Seville; repos stac-portolan-extension, stac-partition-extension, stac-osi-extension, authentication, duckdb-raquet, geoparquet-overviews)
-- https://www.portolan-sdi.org/blog/introducing-portolan (named contributor)</a:t>
+- https://github.com/cayetanobv
+- https://cayetanobv.github.io/ogc-metadata-summit-bolzano/</a:t>
             </a:r>
             <a:endParaRPr lang="en-US" dirty="0"/>
           </a:p>

</xml_diff>

<commit_message>
Why slide: reframed for SDI builders (same goals, lighter delivery), shorter
</commit_message>
<xml_diff>
--- a/export/ogc-metadata-summit-2026.pptx
+++ b/export/ogc-metadata-summit-2026.pptx
@@ -1871,15 +1871,13 @@
           <a:p>
             <a:r>
               <a:rPr lang="en-US" dirty="0"/>
-              <a:t>[Say] (1:15)
-"Why did we move at all? Because the ambition of spatial data infrastructures, INSPIRE's ambition, discoverable, interoperable, usable across borders, was right, and the experience has often been painful. For the publisher, publishing a dataset has meant deploying databases, servers, APIs and a portal, then maintaining them for years, sized for peaks, paid for whether anyone uses the data or not. For the user, finding the dataset is only the beginning: understand the service, interpret the metadata, download, reproject, clean, combine. In practice, mainly GIS specialists get through."
+              <a:t>[Say] (0:50)
+"Why did we build Portolan? Not because spatial data infrastructures failed. Two decades of your work got the hard part right: harmonised models, catalogues, INSPIRE themes, ISO records, services that made national data findable across borders. Portolan starts from that work."
 [Click 1]
-"Three changes are now converging. Cloud-native formats changed the economics: a client reads only the bytes it needs, with its own compute, and the publisher stores the data once. Agents changed who can use the data: given structured metadata and direct access, an agent finds the authoritative sources, inspects them, runs the analysis and answers with its sources and a query you can re-run; federation without a central copy. And sovereignty became an architectural requirement: where the data lives, where queries run, which models may touch it, how easily each layer can be replaced."
-[Click 2]
-"All three were already under way. What was still hard was assembling them into an infrastructure a real publisher can create, operate and maintain without designing the whole architecture from scratch. That is why we joined others in building Portolan."
+"What changed is the delivery layer underneath it. A file in object storage can now be queried directly, so a dataset no longer needs its own server to be usable. Agents are readers too, and they need the same metadata people need, machine-checkable and next to the data. And sovereignty is designed in: storage, compute, models and standards chosen and replaced independently. Portolan is the publishing profile that lets the data you already curate reach more people and more agents, with less to run, while your catalogues, records and models stay authoritative."
 [Sources]
-- Launch commentary, 2 September 2026: https://carto.com/blog/introducing-portolan-and-carto-sdi/ ("The ambition was right. The experience has often been painful."; "Three changes reshaping spatial data infrastructure"; "What is still difficult is assembling them into an SDI that a real data publisher can create, operate, and maintain")
 - https://www.portolan-sdi.org/blog/introducing-portolan ("What Portolan makes possible", "Built for people and agents")
+- https://github.com/portolan-sdi/portolan-ops/blob/main/copy/messaging.md ("Why Portolan?", "Does it standardize my data model?")
 - https://inspire.ec.europa.eu/</a:t>
             </a:r>
             <a:endParaRPr lang="en-US" dirty="0"/>

</xml_diff>

<commit_message>
Skills slide (ten Portolan agent skills behind the two stories); skills named in the stories; honest-work moved to backups
</commit_message>
<xml_diff>
--- a/export/ogc-metadata-summit-2026.pptx
+++ b/export/ogc-metadata-summit-2026.pptx
@@ -25,9 +25,10 @@
     <p:sldId id="273" r:id="rId19"/>
     <p:sldId id="274" r:id="rId20"/>
     <p:sldId id="275" r:id="rId21"/>
+    <p:sldId id="276" r:id="rId22"/>
   </p:sldIdLst>
   <p:notesMasterIdLst>
-    <p:notesMasterId r:id="rId22"/>
+    <p:notesMasterId r:id="rId23"/>
   </p:notesMasterIdLst>
   <p:sldSz cx="9334500" cy="5248275"/>
   <p:notesSz cx="5248275" cy="9334500"/>
@@ -613,6 +614,102 @@
           <a:p>
             <a:r>
               <a:rPr lang="en-US" dirty="0"/>
+              <a:t>[Say] (0:45)
+"One more thing the two stories relied on: skills. Portolan ships ten agent skills, plain SKILL files in the open Agent Skills format."
+[Click 1]
+"On the publishing side: bootstrap takes a WFS, an Esri service, a portal or a folder all the way to a documented, validated, published catalog; the CLI skill covers the day-to-day commands; thumbnails, migrate, and the skills for git-backed metadata, hosting and the registry pull request."
+[Click 2]
+"On the consuming side: reading-portolan is what the agent used in story two, navigating the STAC tree, querying GeoParquet with DuckDB, joining collections, reporting with sources; consume adds maps; and report-catalog-issue turns a wrong licence into an issue on the registry. The same files work in Claude Code, Gemini CLI and other agents. The spec says what a good catalog is; the skills encode how to build and use one."
+[Sources]
+- https://github.com/portolan-sdi/portolan-skills (ten skills, README checked 4 Sep 2026)
+- https://github.com/anthropics/agent-skills (Agent Skills open format, SKILL.md)</a:t>
+            </a:r>
+            <a:endParaRPr lang="en-US" dirty="0"/>
+          </a:p>
+        </p:txBody>
+      </p:sp>
+      <p:sp>
+        <p:nvSpPr>
+          <p:cNvPr id="4" name="Slide Number Placeholder 3"/>
+          <p:cNvSpPr>
+            <a:spLocks noGrp="1"/>
+          </p:cNvSpPr>
+          <p:nvPr>
+            <p:ph type="sldNum" sz="quarter" idx="10"/>
+          </p:nvPr>
+        </p:nvSpPr>
+        <p:spPr/>
+        <p:txBody>
+          <a:bodyPr/>
+          <a:lstStyle/>
+          <a:p>
+            <a:fld id="{F7021451-1387-4CA6-816F-3879F97B5CBC}" type="slidenum">
+              <a:rPr lang="en-US"/>
+              <a:t>10</a:t>
+            </a:fld>
+            <a:endParaRPr lang="en-US"/>
+          </a:p>
+        </p:txBody>
+      </p:sp>
+    </p:spTree>
+    <p:extLst>
+      <p:ext uri="{BB962C8B-B14F-4D97-AF65-F5344CB8AC3E}">
+        <p14:creationId xmlns:p14="http://schemas.microsoft.com/office/powerpoint/2010/main" val="1024086991"/>
+      </p:ext>
+    </p:extLst>
+  </p:cSld>
+  <p:clrMapOvr>
+    <a:masterClrMapping/>
+  </p:clrMapOvr>
+</p:notes>
+</file>
+
+<file path=ppt/notesSlides/notesSlide11.xml><?xml version="1.0" encoding="utf-8"?>
+<p:notes xmlns:a="http://schemas.openxmlformats.org/drawingml/2006/main" xmlns:r="http://schemas.openxmlformats.org/officeDocument/2006/relationships" xmlns:p="http://schemas.openxmlformats.org/presentationml/2006/main">
+  <p:cSld>
+    <p:spTree>
+      <p:nvGrpSpPr>
+        <p:cNvPr id="1" name=""/>
+        <p:cNvGrpSpPr/>
+        <p:nvPr/>
+      </p:nvGrpSpPr>
+      <p:grpSpPr>
+        <a:xfrm>
+          <a:off x="0" y="0"/>
+          <a:ext cx="0" cy="0"/>
+          <a:chOff x="0" y="0"/>
+          <a:chExt cx="0" cy="0"/>
+        </a:xfrm>
+      </p:grpSpPr>
+      <p:sp>
+        <p:nvSpPr>
+          <p:cNvPr id="2" name="Slide Image Placeholder 1"/>
+          <p:cNvSpPr>
+            <a:spLocks noGrp="1" noRot="1" noChangeAspect="1"/>
+          </p:cNvSpPr>
+          <p:nvPr>
+            <p:ph type="sldImg"/>
+          </p:nvPr>
+        </p:nvSpPr>
+        <p:spPr/>
+      </p:sp>
+      <p:sp>
+        <p:nvSpPr>
+          <p:cNvPr id="3" name="Notes Placeholder 2"/>
+          <p:cNvSpPr>
+            <a:spLocks noGrp="1"/>
+          </p:cNvSpPr>
+          <p:nvPr>
+            <p:ph type="body" idx="1"/>
+          </p:nvPr>
+        </p:nvSpPr>
+        <p:spPr/>
+        <p:txBody>
+          <a:bodyPr/>
+          <a:lstStyle/>
+          <a:p>
+            <a:r>
+              <a:rPr lang="en-US" dirty="0"/>
               <a:t>[Say] (1:15)
 "Three lessons from building this. The first is the one I would keep if I could keep only one. A well-formed STAC catalog is already findable and crawlable. Discovery is largely solved. What people and agents cannot do yet is evaluate: is this dataset fit for my question, where is it weak, how wrong can it be."
 [Click 1]
@@ -646,7 +743,7 @@
           <a:p>
             <a:fld id="{F7021451-1387-4CA6-816F-3879F97B5CBC}" type="slidenum">
               <a:rPr lang="en-US"/>
-              <a:t>10</a:t>
+              <a:t>11</a:t>
             </a:fld>
             <a:endParaRPr lang="en-US"/>
           </a:p>
@@ -665,7 +762,7 @@
 </p:notes>
 </file>
 
-<file path=ppt/notesSlides/notesSlide11.xml><?xml version="1.0" encoding="utf-8"?>
+<file path=ppt/notesSlides/notesSlide12.xml><?xml version="1.0" encoding="utf-8"?>
 <p:notes xmlns:a="http://schemas.openxmlformats.org/drawingml/2006/main" xmlns:r="http://schemas.openxmlformats.org/officeDocument/2006/relationships" xmlns:p="http://schemas.openxmlformats.org/presentationml/2006/main">
   <p:cSld>
     <p:spTree>
@@ -745,7 +842,7 @@
           <a:p>
             <a:fld id="{F7021451-1387-4CA6-816F-3879F97B5CBC}" type="slidenum">
               <a:rPr lang="en-US"/>
-              <a:t>11</a:t>
+              <a:t>12</a:t>
             </a:fld>
             <a:endParaRPr lang="en-US"/>
           </a:p>
@@ -764,7 +861,7 @@
 </p:notes>
 </file>
 
-<file path=ppt/notesSlides/notesSlide12.xml><?xml version="1.0" encoding="utf-8"?>
+<file path=ppt/notesSlides/notesSlide13.xml><?xml version="1.0" encoding="utf-8"?>
 <p:notes xmlns:a="http://schemas.openxmlformats.org/drawingml/2006/main" xmlns:r="http://schemas.openxmlformats.org/officeDocument/2006/relationships" xmlns:p="http://schemas.openxmlformats.org/presentationml/2006/main">
   <p:cSld>
     <p:spTree>
@@ -848,102 +945,6 @@
           <a:p>
             <a:fld id="{F7021451-1387-4CA6-816F-3879F97B5CBC}" type="slidenum">
               <a:rPr lang="en-US"/>
-              <a:t>12</a:t>
-            </a:fld>
-            <a:endParaRPr lang="en-US"/>
-          </a:p>
-        </p:txBody>
-      </p:sp>
-    </p:spTree>
-    <p:extLst>
-      <p:ext uri="{BB962C8B-B14F-4D97-AF65-F5344CB8AC3E}">
-        <p14:creationId xmlns:p14="http://schemas.microsoft.com/office/powerpoint/2010/main" val="1024086991"/>
-      </p:ext>
-    </p:extLst>
-  </p:cSld>
-  <p:clrMapOvr>
-    <a:masterClrMapping/>
-  </p:clrMapOvr>
-</p:notes>
-</file>
-
-<file path=ppt/notesSlides/notesSlide13.xml><?xml version="1.0" encoding="utf-8"?>
-<p:notes xmlns:a="http://schemas.openxmlformats.org/drawingml/2006/main" xmlns:r="http://schemas.openxmlformats.org/officeDocument/2006/relationships" xmlns:p="http://schemas.openxmlformats.org/presentationml/2006/main">
-  <p:cSld>
-    <p:spTree>
-      <p:nvGrpSpPr>
-        <p:cNvPr id="1" name=""/>
-        <p:cNvGrpSpPr/>
-        <p:nvPr/>
-      </p:nvGrpSpPr>
-      <p:grpSpPr>
-        <a:xfrm>
-          <a:off x="0" y="0"/>
-          <a:ext cx="0" cy="0"/>
-          <a:chOff x="0" y="0"/>
-          <a:chExt cx="0" cy="0"/>
-        </a:xfrm>
-      </p:grpSpPr>
-      <p:sp>
-        <p:nvSpPr>
-          <p:cNvPr id="2" name="Slide Image Placeholder 1"/>
-          <p:cNvSpPr>
-            <a:spLocks noGrp="1" noRot="1" noChangeAspect="1"/>
-          </p:cNvSpPr>
-          <p:nvPr>
-            <p:ph type="sldImg"/>
-          </p:nvPr>
-        </p:nvSpPr>
-        <p:spPr/>
-      </p:sp>
-      <p:sp>
-        <p:nvSpPr>
-          <p:cNvPr id="3" name="Notes Placeholder 2"/>
-          <p:cNvSpPr>
-            <a:spLocks noGrp="1"/>
-          </p:cNvSpPr>
-          <p:nvPr>
-            <p:ph type="body" idx="1"/>
-          </p:nvPr>
-        </p:nvSpPr>
-        <p:spPr/>
-        <p:txBody>
-          <a:bodyPr/>
-          <a:lstStyle/>
-          <a:p>
-            <a:r>
-              <a:rPr lang="en-US" dirty="0"/>
-              <a:t>[Say] (1:00)
-"Before the close, the honesty checkpoint. This is the architecture of the portal, not a claim that infrastructure disappears. In a service-first portal, legacy files and a spatial database feed a GIS server, gateway, APIs, and tiles. Every request travels through that service chain."
-[Click 1]
-"A static-first portal moves the expensive preparation to a publisher-controlled job. It writes GeoParquet, COG, or PMTiles to object storage, links them through STAC, and lets browsers, desktop tools, and agents read them directly. Compute or an OGC API remains available on demand when a use case needs it."
-[Click 2]
-"The query path can shrink, but the operating work remains. We still convert, document, and validate releases. We still operate storage, CDN, IAM, DNS, security, and monitoring. People still govern quality, updates, and release decisions."
-[Sources]
-- https://github.com/portolan-sdi/portolan-spec/blob/main/specs/portolan/core.md
-- Speaker-provided `cng-infrastructure-concept.pdf`, consolidated and redrawn as a horizontal architecture comparison</a:t>
-            </a:r>
-            <a:endParaRPr lang="en-US" dirty="0"/>
-          </a:p>
-        </p:txBody>
-      </p:sp>
-      <p:sp>
-        <p:nvSpPr>
-          <p:cNvPr id="4" name="Slide Number Placeholder 3"/>
-          <p:cNvSpPr>
-            <a:spLocks noGrp="1"/>
-          </p:cNvSpPr>
-          <p:nvPr>
-            <p:ph type="sldNum" sz="quarter" idx="10"/>
-          </p:nvPr>
-        </p:nvSpPr>
-        <p:spPr/>
-        <p:txBody>
-          <a:bodyPr/>
-          <a:lstStyle/>
-          <a:p>
-            <a:fld id="{F7021451-1387-4CA6-816F-3879F97B5CBC}" type="slidenum">
-              <a:rPr lang="en-US"/>
               <a:t>13</a:t>
             </a:fld>
             <a:endParaRPr lang="en-US"/>
@@ -1254,6 +1255,102 @@
 </file>
 
 <file path=ppt/notesSlides/notesSlide17.xml><?xml version="1.0" encoding="utf-8"?>
+<p:notes xmlns:a="http://schemas.openxmlformats.org/drawingml/2006/main" xmlns:r="http://schemas.openxmlformats.org/officeDocument/2006/relationships" xmlns:p="http://schemas.openxmlformats.org/presentationml/2006/main">
+  <p:cSld>
+    <p:spTree>
+      <p:nvGrpSpPr>
+        <p:cNvPr id="1" name=""/>
+        <p:cNvGrpSpPr/>
+        <p:nvPr/>
+      </p:nvGrpSpPr>
+      <p:grpSpPr>
+        <a:xfrm>
+          <a:off x="0" y="0"/>
+          <a:ext cx="0" cy="0"/>
+          <a:chOff x="0" y="0"/>
+          <a:chExt cx="0" cy="0"/>
+        </a:xfrm>
+      </p:grpSpPr>
+      <p:sp>
+        <p:nvSpPr>
+          <p:cNvPr id="2" name="Slide Image Placeholder 1"/>
+          <p:cNvSpPr>
+            <a:spLocks noGrp="1" noRot="1" noChangeAspect="1"/>
+          </p:cNvSpPr>
+          <p:nvPr>
+            <p:ph type="sldImg"/>
+          </p:nvPr>
+        </p:nvSpPr>
+        <p:spPr/>
+      </p:sp>
+      <p:sp>
+        <p:nvSpPr>
+          <p:cNvPr id="3" name="Notes Placeholder 2"/>
+          <p:cNvSpPr>
+            <a:spLocks noGrp="1"/>
+          </p:cNvSpPr>
+          <p:nvPr>
+            <p:ph type="body" idx="1"/>
+          </p:nvPr>
+        </p:nvSpPr>
+        <p:spPr/>
+        <p:txBody>
+          <a:bodyPr/>
+          <a:lstStyle/>
+          <a:p>
+            <a:r>
+              <a:rPr lang="en-US" dirty="0"/>
+              <a:t>[Say] (1:00)
+"Before the close, the honesty checkpoint. This is the architecture of the portal, not a claim that infrastructure disappears. In a service-first portal, legacy files and a spatial database feed a GIS server, gateway, APIs, and tiles. Every request travels through that service chain."
+[Click 1]
+"A static-first portal moves the expensive preparation to a publisher-controlled job. It writes GeoParquet, COG, or PMTiles to object storage, links them through STAC, and lets browsers, desktop tools, and agents read them directly. Compute or an OGC API remains available on demand when a use case needs it."
+[Click 2]
+"The query path can shrink, but the operating work remains. We still convert, document, and validate releases. We still operate storage, CDN, IAM, DNS, security, and monitoring. People still govern quality, updates, and release decisions."
+[Sources]
+- https://github.com/portolan-sdi/portolan-spec/blob/main/specs/portolan/core.md
+- Speaker-provided `cng-infrastructure-concept.pdf`, consolidated and redrawn as a horizontal architecture comparison</a:t>
+            </a:r>
+            <a:endParaRPr lang="en-US" dirty="0"/>
+          </a:p>
+        </p:txBody>
+      </p:sp>
+      <p:sp>
+        <p:nvSpPr>
+          <p:cNvPr id="4" name="Slide Number Placeholder 3"/>
+          <p:cNvSpPr>
+            <a:spLocks noGrp="1"/>
+          </p:cNvSpPr>
+          <p:nvPr>
+            <p:ph type="sldNum" sz="quarter" idx="10"/>
+          </p:nvPr>
+        </p:nvSpPr>
+        <p:spPr/>
+        <p:txBody>
+          <a:bodyPr/>
+          <a:lstStyle/>
+          <a:p>
+            <a:fld id="{F7021451-1387-4CA6-816F-3879F97B5CBC}" type="slidenum">
+              <a:rPr lang="en-US"/>
+              <a:t>17</a:t>
+            </a:fld>
+            <a:endParaRPr lang="en-US"/>
+          </a:p>
+        </p:txBody>
+      </p:sp>
+    </p:spTree>
+    <p:extLst>
+      <p:ext uri="{BB962C8B-B14F-4D97-AF65-F5344CB8AC3E}">
+        <p14:creationId xmlns:p14="http://schemas.microsoft.com/office/powerpoint/2010/main" val="1024086991"/>
+      </p:ext>
+    </p:extLst>
+  </p:cSld>
+  <p:clrMapOvr>
+    <a:masterClrMapping/>
+  </p:clrMapOvr>
+</p:notes>
+</file>
+
+<file path=ppt/notesSlides/notesSlide18.xml><?xml version="1.0" encoding="utf-8"?>
 <p:notes xmlns:a="http://schemas.openxmlformats.org/drawingml/2006/main" xmlns:r="http://schemas.openxmlformats.org/officeDocument/2006/relationships" xmlns:p="http://schemas.openxmlformats.org/presentationml/2006/main">
   <p:cSld>
     <p:spTree>
@@ -1334,7 +1431,7 @@
           <a:p>
             <a:fld id="{F7021451-1387-4CA6-816F-3879F97B5CBC}" type="slidenum">
               <a:rPr lang="en-US"/>
-              <a:t>17</a:t>
+              <a:t>18</a:t>
             </a:fld>
             <a:endParaRPr lang="en-US"/>
           </a:p>
@@ -1353,7 +1450,7 @@
 </p:notes>
 </file>
 
-<file path=ppt/notesSlides/notesSlide18.xml><?xml version="1.0" encoding="utf-8"?>
+<file path=ppt/notesSlides/notesSlide19.xml><?xml version="1.0" encoding="utf-8"?>
 <p:notes xmlns:a="http://schemas.openxmlformats.org/drawingml/2006/main" xmlns:r="http://schemas.openxmlformats.org/officeDocument/2006/relationships" xmlns:p="http://schemas.openxmlformats.org/presentationml/2006/main">
   <p:cSld>
     <p:spTree>
@@ -1424,7 +1521,7 @@
           <a:p>
             <a:fld id="{F7021451-1387-4CA6-816F-3879F97B5CBC}" type="slidenum">
               <a:rPr lang="en-US"/>
-              <a:t>18</a:t>
+              <a:t>19</a:t>
             </a:fld>
             <a:endParaRPr lang="en-US"/>
           </a:p>
@@ -1443,7 +1540,99 @@
 </p:notes>
 </file>
 
-<file path=ppt/notesSlides/notesSlide19.xml><?xml version="1.0" encoding="utf-8"?>
+<file path=ppt/notesSlides/notesSlide2.xml><?xml version="1.0" encoding="utf-8"?>
+<p:notes xmlns:a="http://schemas.openxmlformats.org/drawingml/2006/main" xmlns:r="http://schemas.openxmlformats.org/officeDocument/2006/relationships" xmlns:p="http://schemas.openxmlformats.org/presentationml/2006/main">
+  <p:cSld>
+    <p:spTree>
+      <p:nvGrpSpPr>
+        <p:cNvPr id="1" name=""/>
+        <p:cNvGrpSpPr/>
+        <p:nvPr/>
+      </p:nvGrpSpPr>
+      <p:grpSpPr>
+        <a:xfrm>
+          <a:off x="0" y="0"/>
+          <a:ext cx="0" cy="0"/>
+          <a:chOff x="0" y="0"/>
+          <a:chExt cx="0" cy="0"/>
+        </a:xfrm>
+      </p:grpSpPr>
+      <p:sp>
+        <p:nvSpPr>
+          <p:cNvPr id="2" name="Slide Image Placeholder 1"/>
+          <p:cNvSpPr>
+            <a:spLocks noGrp="1" noRot="1" noChangeAspect="1"/>
+          </p:cNvSpPr>
+          <p:nvPr>
+            <p:ph type="sldImg"/>
+          </p:nvPr>
+        </p:nvSpPr>
+        <p:spPr/>
+      </p:sp>
+      <p:sp>
+        <p:nvSpPr>
+          <p:cNvPr id="3" name="Notes Placeholder 2"/>
+          <p:cNvSpPr>
+            <a:spLocks noGrp="1"/>
+          </p:cNvSpPr>
+          <p:nvPr>
+            <p:ph type="body" idx="1"/>
+          </p:nvPr>
+        </p:nvSpPr>
+        <p:spPr/>
+        <p:txBody>
+          <a:bodyPr/>
+          <a:lstStyle/>
+          <a:p>
+            <a:r>
+              <a:rPr lang="en-US" dirty="0"/>
+              <a:t>[Say] (0:35)
+"Briefly, who is talking. I am Director of Engineering for Professional Services at CARTO, I collaborate on the Portolan SDI project, and I have spent more than twenty years in the geospatial industry, most of it contributing to open-source software. I am based in Seville. Everything I show is open; the slides and the catalog are at the addresses on the right."
+[Sources]
+- https://github.com/cayetanobv
+- https://cayetanobv.github.io/ogc-metadata-summit-bolzano/</a:t>
+            </a:r>
+            <a:endParaRPr lang="en-US" dirty="0"/>
+          </a:p>
+        </p:txBody>
+      </p:sp>
+      <p:sp>
+        <p:nvSpPr>
+          <p:cNvPr id="4" name="Slide Number Placeholder 3"/>
+          <p:cNvSpPr>
+            <a:spLocks noGrp="1"/>
+          </p:cNvSpPr>
+          <p:nvPr>
+            <p:ph type="sldNum" sz="quarter" idx="10"/>
+          </p:nvPr>
+        </p:nvSpPr>
+        <p:spPr/>
+        <p:txBody>
+          <a:bodyPr/>
+          <a:lstStyle/>
+          <a:p>
+            <a:fld id="{F7021451-1387-4CA6-816F-3879F97B5CBC}" type="slidenum">
+              <a:rPr lang="en-US"/>
+              <a:t>2</a:t>
+            </a:fld>
+            <a:endParaRPr lang="en-US"/>
+          </a:p>
+        </p:txBody>
+      </p:sp>
+    </p:spTree>
+    <p:extLst>
+      <p:ext uri="{BB962C8B-B14F-4D97-AF65-F5344CB8AC3E}">
+        <p14:creationId xmlns:p14="http://schemas.microsoft.com/office/powerpoint/2010/main" val="1024086991"/>
+      </p:ext>
+    </p:extLst>
+  </p:cSld>
+  <p:clrMapOvr>
+    <a:masterClrMapping/>
+  </p:clrMapOvr>
+</p:notes>
+</file>
+
+<file path=ppt/notesSlides/notesSlide20.xml><?xml version="1.0" encoding="utf-8"?>
 <p:notes xmlns:a="http://schemas.openxmlformats.org/drawingml/2006/main" xmlns:r="http://schemas.openxmlformats.org/officeDocument/2006/relationships" xmlns:p="http://schemas.openxmlformats.org/presentationml/2006/main">
   <p:cSld>
     <p:spTree>
@@ -1521,7 +1710,7 @@
           <a:p>
             <a:fld id="{F7021451-1387-4CA6-816F-3879F97B5CBC}" type="slidenum">
               <a:rPr lang="en-US"/>
-              <a:t>19</a:t>
+              <a:t>20</a:t>
             </a:fld>
             <a:endParaRPr lang="en-US"/>
           </a:p>
@@ -1540,99 +1729,7 @@
 </p:notes>
 </file>
 
-<file path=ppt/notesSlides/notesSlide2.xml><?xml version="1.0" encoding="utf-8"?>
-<p:notes xmlns:a="http://schemas.openxmlformats.org/drawingml/2006/main" xmlns:r="http://schemas.openxmlformats.org/officeDocument/2006/relationships" xmlns:p="http://schemas.openxmlformats.org/presentationml/2006/main">
-  <p:cSld>
-    <p:spTree>
-      <p:nvGrpSpPr>
-        <p:cNvPr id="1" name=""/>
-        <p:cNvGrpSpPr/>
-        <p:nvPr/>
-      </p:nvGrpSpPr>
-      <p:grpSpPr>
-        <a:xfrm>
-          <a:off x="0" y="0"/>
-          <a:ext cx="0" cy="0"/>
-          <a:chOff x="0" y="0"/>
-          <a:chExt cx="0" cy="0"/>
-        </a:xfrm>
-      </p:grpSpPr>
-      <p:sp>
-        <p:nvSpPr>
-          <p:cNvPr id="2" name="Slide Image Placeholder 1"/>
-          <p:cNvSpPr>
-            <a:spLocks noGrp="1" noRot="1" noChangeAspect="1"/>
-          </p:cNvSpPr>
-          <p:nvPr>
-            <p:ph type="sldImg"/>
-          </p:nvPr>
-        </p:nvSpPr>
-        <p:spPr/>
-      </p:sp>
-      <p:sp>
-        <p:nvSpPr>
-          <p:cNvPr id="3" name="Notes Placeholder 2"/>
-          <p:cNvSpPr>
-            <a:spLocks noGrp="1"/>
-          </p:cNvSpPr>
-          <p:nvPr>
-            <p:ph type="body" idx="1"/>
-          </p:nvPr>
-        </p:nvSpPr>
-        <p:spPr/>
-        <p:txBody>
-          <a:bodyPr/>
-          <a:lstStyle/>
-          <a:p>
-            <a:r>
-              <a:rPr lang="en-US" dirty="0"/>
-              <a:t>[Say] (0:35)
-"Briefly, who is talking. I am Director of Engineering for Professional Services at CARTO, I collaborate on the Portolan SDI project, and I have spent more than twenty years in the geospatial industry, most of it contributing to open-source software. I am based in Seville. Everything I show is open; the slides and the catalog are at the addresses on the right."
-[Sources]
-- https://github.com/cayetanobv
-- https://cayetanobv.github.io/ogc-metadata-summit-bolzano/</a:t>
-            </a:r>
-            <a:endParaRPr lang="en-US" dirty="0"/>
-          </a:p>
-        </p:txBody>
-      </p:sp>
-      <p:sp>
-        <p:nvSpPr>
-          <p:cNvPr id="4" name="Slide Number Placeholder 3"/>
-          <p:cNvSpPr>
-            <a:spLocks noGrp="1"/>
-          </p:cNvSpPr>
-          <p:nvPr>
-            <p:ph type="sldNum" sz="quarter" idx="10"/>
-          </p:nvPr>
-        </p:nvSpPr>
-        <p:spPr/>
-        <p:txBody>
-          <a:bodyPr/>
-          <a:lstStyle/>
-          <a:p>
-            <a:fld id="{F7021451-1387-4CA6-816F-3879F97B5CBC}" type="slidenum">
-              <a:rPr lang="en-US"/>
-              <a:t>2</a:t>
-            </a:fld>
-            <a:endParaRPr lang="en-US"/>
-          </a:p>
-        </p:txBody>
-      </p:sp>
-    </p:spTree>
-    <p:extLst>
-      <p:ext uri="{BB962C8B-B14F-4D97-AF65-F5344CB8AC3E}">
-        <p14:creationId xmlns:p14="http://schemas.microsoft.com/office/powerpoint/2010/main" val="1024086991"/>
-      </p:ext>
-    </p:extLst>
-  </p:cSld>
-  <p:clrMapOvr>
-    <a:masterClrMapping/>
-  </p:clrMapOvr>
-</p:notes>
-</file>
-
-<file path=ppt/notesSlides/notesSlide20.xml><?xml version="1.0" encoding="utf-8"?>
+<file path=ppt/notesSlides/notesSlide21.xml><?xml version="1.0" encoding="utf-8"?>
 <p:notes xmlns:a="http://schemas.openxmlformats.org/drawingml/2006/main" xmlns:r="http://schemas.openxmlformats.org/officeDocument/2006/relationships" xmlns:p="http://schemas.openxmlformats.org/presentationml/2006/main">
   <p:cSld>
     <p:spTree>
@@ -1709,7 +1806,7 @@
           <a:p>
             <a:fld id="{F7021451-1387-4CA6-816F-3879F97B5CBC}" type="slidenum">
               <a:rPr lang="en-US"/>
-              <a:t>20</a:t>
+              <a:t>21</a:t>
             </a:fld>
             <a:endParaRPr lang="en-US"/>
           </a:p>
@@ -1777,7 +1874,7 @@
               <a:t>[Say] (0:35)
 "The phrase AI-ready metadata is everywhere. Few people say what it means when you actually have to publish a dataset on a Monday morning. We tried to answer it by building instead of defining."
 [Click 1]
-"A spec, a validator, a CLI, a registry, and real catalogs. Portolan went public last Wednesday, the second of September, after a year of building in the open. So this is a success story with the scars still visible: what worked, and what surprised us."
+"A spec, a validator, a CLI, ten agent skills, a registry, and real catalogs. Portolan went public last Wednesday, the second of September, after a year of building in the open. So this is a success story with the scars still visible: what worked, and what surprised us."
 [Sources]
 - https://www.portolan-sdi.org/blog/introducing-portolan
 - https://github.com/portolan-sdi/portolan-spec
@@ -3194,6 +3291,45 @@
 <file path=ppt/slides/slide20.xml><?xml version="1.0" encoding="utf-8"?>
 <p:sld xmlns:a="http://schemas.openxmlformats.org/drawingml/2006/main" xmlns:r="http://schemas.openxmlformats.org/officeDocument/2006/relationships" xmlns:p="http://schemas.openxmlformats.org/presentationml/2006/main">
   <p:cSld name="Slide 20">
+    <p:bg>
+      <p:bgPr>
+        <a:blipFill dpi="0" rotWithShape="1">
+          <a:blip r:embed="rId1">
+            <a:lum/>
+          </a:blip>
+          <a:srcRect/>
+          <a:stretch>
+            <a:fillRect/>
+          </a:stretch>
+        </a:blipFill>
+        <a:effectLst/>
+      </p:bgPr>
+    </p:bg>
+    <p:spTree>
+      <p:nvGrpSpPr>
+        <p:cNvPr id="1" name=""/>
+        <p:cNvGrpSpPr/>
+        <p:nvPr/>
+      </p:nvGrpSpPr>
+      <p:grpSpPr>
+        <a:xfrm>
+          <a:off x="0" y="0"/>
+          <a:ext cx="0" cy="0"/>
+          <a:chOff x="0" y="0"/>
+          <a:chExt cx="0" cy="0"/>
+        </a:xfrm>
+      </p:grpSpPr>
+    </p:spTree>
+  </p:cSld>
+  <p:clrMapOvr>
+    <a:masterClrMapping/>
+  </p:clrMapOvr>
+</p:sld>
+</file>
+
+<file path=ppt/slides/slide21.xml><?xml version="1.0" encoding="utf-8"?>
+<p:sld xmlns:a="http://schemas.openxmlformats.org/drawingml/2006/main" xmlns:r="http://schemas.openxmlformats.org/officeDocument/2006/relationships" xmlns:p="http://schemas.openxmlformats.org/presentationml/2006/main">
+  <p:cSld name="Slide 21">
     <p:bg>
       <p:bgPr>
         <a:blipFill dpi="0" rotWithShape="1">

</xml_diff>

<commit_message>
Restructure the talk: what Portolan is, five goals, lifecycle, metadata sources; appendix section
- New slides: what Portolan is (definition), publish/update/use lifecycle
  (VizPortolanContract ported from the CNG Japan deck), where the metadata
  comes from (VizMetadataSources: measured / harvested / asserted).
- Why slide rebuilt around the five goals; building blocks uses VizTheGap and
  greys GeoJSON; what-Portolan-adds as four icon cards; lesson 1 shows where a
  limitation lives; close shortened to open questions and status.
- Questions slide is now slide 17; QR regenerated; appendix x01-x03 (name,
  ISO/INSPIRE, ISO JSON); experiment, honest-work, prescriptive and no-API
  slides removed.
- Cover and bio redistributed; validator rejects the 84-rules figure;
  README/AGENTS updated; exports rebuilt.

Co-Authored-By: Claude Fable 5.1 <noreply@anthropic.com>
</commit_message>
<xml_diff>
--- a/export/ogc-metadata-summit-2026.pptx
+++ b/export/ogc-metadata-summit-2026.pptx
@@ -25,10 +25,9 @@
     <p:sldId id="273" r:id="rId19"/>
     <p:sldId id="274" r:id="rId20"/>
     <p:sldId id="275" r:id="rId21"/>
-    <p:sldId id="276" r:id="rId22"/>
   </p:sldIdLst>
   <p:notesMasterIdLst>
-    <p:notesMasterId r:id="rId23"/>
+    <p:notesMasterId r:id="rId22"/>
   </p:notesMasterIdLst>
   <p:sldSz cx="9334500" cy="5248275"/>
   <p:notesSz cx="5248275" cy="9334500"/>
@@ -614,6 +613,202 @@
           <a:p>
             <a:r>
               <a:rPr lang="en-US" dirty="0"/>
+              <a:t>[Say] (1:15)
+"Second story, same catalog, the next day. Out of 69 collections, an agent was asked a question no single layer answers: which hospitals and pharmacies sit inside high or very-high hydraulic hazard zones, and how many residents live in those municipalities. Nobody guided it."
+[Click 1]
+"Four of seventeen hospitals, in Bolzano, Bressanone, Brunico and Ortisei. Thirty-one of a hundred and fifty-eight pharmacies. A hundred and eight of the hundred and sixteen municipalities have an approved plan. The agent joined five collections on the ISTAT code, filtered the hazard classes by the strings the AGENTS file told it about, and ran the intersection in DuckDB against the GeoParquet in place."
+[Click 2]
+"And it said what the numbers do not mean, because the publisher wrote it down: points are locations, not catchments; hazard classes are planning zones, not forecasts; eight municipalities have no approved plan yet. Producer, license and the query came attached. This is a screening, not a risk assessment. But look at what it did not have: a server, an API, credentials, or a person in the loop. The same catalog answers the next question tomorrow."
+[Sources]
+- https://github.com/portolan-sdi/portolan-skills/tree/main/skills/reading-portolan</a:t>
+            </a:r>
+            <a:endParaRPr lang="en-US" dirty="0"/>
+          </a:p>
+        </p:txBody>
+      </p:sp>
+      <p:sp>
+        <p:nvSpPr>
+          <p:cNvPr id="4" name="Slide Number Placeholder 3"/>
+          <p:cNvSpPr>
+            <a:spLocks noGrp="1"/>
+          </p:cNvSpPr>
+          <p:nvPr>
+            <p:ph type="sldNum" sz="quarter" idx="10"/>
+          </p:nvPr>
+        </p:nvSpPr>
+        <p:spPr/>
+        <p:txBody>
+          <a:bodyPr/>
+          <a:lstStyle/>
+          <a:p>
+            <a:fld id="{F7021451-1387-4CA6-816F-3879F97B5CBC}" type="slidenum">
+              <a:rPr lang="en-US"/>
+              <a:t>10</a:t>
+            </a:fld>
+            <a:endParaRPr lang="en-US"/>
+          </a:p>
+        </p:txBody>
+      </p:sp>
+    </p:spTree>
+    <p:extLst>
+      <p:ext uri="{BB962C8B-B14F-4D97-AF65-F5344CB8AC3E}">
+        <p14:creationId xmlns:p14="http://schemas.microsoft.com/office/powerpoint/2010/main" val="1024086991"/>
+      </p:ext>
+    </p:extLst>
+  </p:cSld>
+  <p:clrMapOvr>
+    <a:masterClrMapping/>
+  </p:clrMapOvr>
+</p:notes>
+</file>
+
+<file path=ppt/notesSlides/notesSlide11.xml><?xml version="1.0" encoding="utf-8"?>
+<p:notes xmlns:a="http://schemas.openxmlformats.org/drawingml/2006/main" xmlns:r="http://schemas.openxmlformats.org/officeDocument/2006/relationships" xmlns:p="http://schemas.openxmlformats.org/presentationml/2006/main">
+  <p:cSld>
+    <p:spTree>
+      <p:nvGrpSpPr>
+        <p:cNvPr id="1" name=""/>
+        <p:cNvGrpSpPr/>
+        <p:nvPr/>
+      </p:nvGrpSpPr>
+      <p:grpSpPr>
+        <a:xfrm>
+          <a:off x="0" y="0"/>
+          <a:ext cx="0" cy="0"/>
+          <a:chOff x="0" y="0"/>
+          <a:chExt cx="0" cy="0"/>
+        </a:xfrm>
+      </p:grpSpPr>
+      <p:sp>
+        <p:nvSpPr>
+          <p:cNvPr id="2" name="Slide Image Placeholder 1"/>
+          <p:cNvSpPr>
+            <a:spLocks noGrp="1" noRot="1" noChangeAspect="1"/>
+          </p:cNvSpPr>
+          <p:nvPr>
+            <p:ph type="sldImg"/>
+          </p:nvPr>
+        </p:nvSpPr>
+        <p:spPr/>
+      </p:sp>
+      <p:sp>
+        <p:nvSpPr>
+          <p:cNvPr id="3" name="Notes Placeholder 2"/>
+          <p:cNvSpPr>
+            <a:spLocks noGrp="1"/>
+          </p:cNvSpPr>
+          <p:nvPr>
+            <p:ph type="body" idx="1"/>
+          </p:nvPr>
+        </p:nvSpPr>
+        <p:spPr/>
+        <p:txBody>
+          <a:bodyPr/>
+          <a:lstStyle/>
+          <a:p>
+            <a:r>
+              <a:rPr lang="en-US" dirty="0"/>
+              <a:t>[Say] (0:50)
+"Here is what the agent actually did, because this is where AI-ready stops being a slogan."
+[Click 1]
+"It opened the catalog and followed the explicit child links: eleven theme catalogs, sixty-nine collections. The linked graph is the publication boundary."
+[Click 2]
+"It read AGENTS dot md: the join key, the coordinate system, the exact hazard-class strings, and what the data is not for."
+[Click 3]
+"It inspected each collection: one GeoParquet asset each, with provider, license, extent and row count."
+[Click 4]
+"It planned a DuckDB query. The model plans and explains; DuckDB computes, reading only the row groups it needs thanks to the spatial ordering the spec requires."
+[Click 5]
+"It reported with method, URLs, producer, license and limitations. Every step consumed something the publisher wrote down. Nothing was guessed. I cannot run this in ten minutes, so both stories run live at the demo desk at the coffee breaks, today and tomorrow. Bring the URL of your WFS and a question."
+[Sources]
+- https://github.com/portolan-sdi/portolan-skills/tree/main/skills/reading-portolan</a:t>
+            </a:r>
+            <a:endParaRPr lang="en-US" dirty="0"/>
+          </a:p>
+        </p:txBody>
+      </p:sp>
+      <p:sp>
+        <p:nvSpPr>
+          <p:cNvPr id="4" name="Slide Number Placeholder 3"/>
+          <p:cNvSpPr>
+            <a:spLocks noGrp="1"/>
+          </p:cNvSpPr>
+          <p:nvPr>
+            <p:ph type="sldNum" sz="quarter" idx="10"/>
+          </p:nvPr>
+        </p:nvSpPr>
+        <p:spPr/>
+        <p:txBody>
+          <a:bodyPr/>
+          <a:lstStyle/>
+          <a:p>
+            <a:fld id="{F7021451-1387-4CA6-816F-3879F97B5CBC}" type="slidenum">
+              <a:rPr lang="en-US"/>
+              <a:t>11</a:t>
+            </a:fld>
+            <a:endParaRPr lang="en-US"/>
+          </a:p>
+        </p:txBody>
+      </p:sp>
+    </p:spTree>
+    <p:extLst>
+      <p:ext uri="{BB962C8B-B14F-4D97-AF65-F5344CB8AC3E}">
+        <p14:creationId xmlns:p14="http://schemas.microsoft.com/office/powerpoint/2010/main" val="1024086991"/>
+      </p:ext>
+    </p:extLst>
+  </p:cSld>
+  <p:clrMapOvr>
+    <a:masterClrMapping/>
+  </p:clrMapOvr>
+</p:notes>
+</file>
+
+<file path=ppt/notesSlides/notesSlide12.xml><?xml version="1.0" encoding="utf-8"?>
+<p:notes xmlns:a="http://schemas.openxmlformats.org/drawingml/2006/main" xmlns:r="http://schemas.openxmlformats.org/officeDocument/2006/relationships" xmlns:p="http://schemas.openxmlformats.org/presentationml/2006/main">
+  <p:cSld>
+    <p:spTree>
+      <p:nvGrpSpPr>
+        <p:cNvPr id="1" name=""/>
+        <p:cNvGrpSpPr/>
+        <p:nvPr/>
+      </p:nvGrpSpPr>
+      <p:grpSpPr>
+        <a:xfrm>
+          <a:off x="0" y="0"/>
+          <a:ext cx="0" cy="0"/>
+          <a:chOff x="0" y="0"/>
+          <a:chExt cx="0" cy="0"/>
+        </a:xfrm>
+      </p:grpSpPr>
+      <p:sp>
+        <p:nvSpPr>
+          <p:cNvPr id="2" name="Slide Image Placeholder 1"/>
+          <p:cNvSpPr>
+            <a:spLocks noGrp="1" noRot="1" noChangeAspect="1"/>
+          </p:cNvSpPr>
+          <p:nvPr>
+            <p:ph type="sldImg"/>
+          </p:nvPr>
+        </p:nvSpPr>
+        <p:spPr/>
+      </p:sp>
+      <p:sp>
+        <p:nvSpPr>
+          <p:cNvPr id="3" name="Notes Placeholder 2"/>
+          <p:cNvSpPr>
+            <a:spLocks noGrp="1"/>
+          </p:cNvSpPr>
+          <p:nvPr>
+            <p:ph type="body" idx="1"/>
+          </p:nvPr>
+        </p:nvSpPr>
+        <p:spPr/>
+        <p:txBody>
+          <a:bodyPr/>
+          <a:lstStyle/>
+          <a:p>
+            <a:r>
+              <a:rPr lang="en-US" dirty="0"/>
               <a:t>[Say] (0:45)
 "One more thing the two stories relied on: skills. Portolan ships ten agent skills, plain SKILL files in the open Agent Skills format."
 [Click 1]
@@ -645,7 +840,7 @@
           <a:p>
             <a:fld id="{F7021451-1387-4CA6-816F-3879F97B5CBC}" type="slidenum">
               <a:rPr lang="en-US"/>
-              <a:t>10</a:t>
+              <a:t>12</a:t>
             </a:fld>
             <a:endParaRPr lang="en-US"/>
           </a:p>
@@ -664,7 +859,7 @@
 </p:notes>
 </file>
 
-<file path=ppt/notesSlides/notesSlide11.xml><?xml version="1.0" encoding="utf-8"?>
+<file path=ppt/notesSlides/notesSlide13.xml><?xml version="1.0" encoding="utf-8"?>
 <p:notes xmlns:a="http://schemas.openxmlformats.org/drawingml/2006/main" xmlns:r="http://schemas.openxmlformats.org/officeDocument/2006/relationships" xmlns:p="http://schemas.openxmlformats.org/presentationml/2006/main">
   <p:cSld>
     <p:spTree>
@@ -710,14 +905,15 @@
           <a:p>
             <a:r>
               <a:rPr lang="en-US" dirty="0"/>
-              <a:t>[Say] (1:15)
+              <a:t>[Say] (1:10)
 "Three lessons from building this. The first is the one I would keep if I could keep only one. A well-formed STAC catalog is already findable and crawlable. Discovery is largely solved. What people and agents cannot do yet is evaluate: is this dataset fit for my question, where is it weak, how wrong can it be."
 [Click 1]
 "One sentence from a real catalog, Fields of the World: a field polygon is a remote-sensing field unit, not a cadastral parcel. That single sentence prevents a whole category of misuse that no accuracy number would catch. In the Bolzano answer you saw the same thing: a hospital point inside a hazard polygon is a location, not a catchment. Someone wrote that down."
 [Click 2]
-"So our working definition. AI-ready means documented limitations, quantified uncertainty and named biases. As data where possible, a confidence column or a quality mask an agent can filter on, rather than a paragraph it has to interpret. This is the expertise that otherwise lives only in the heads of domain experts, and it is the part of your metadata work that no automation replaces."
+"So our working definition: AI-ready means documented limitations, quantified uncertainty and named biases, as data where possible. And where does that live? In one field, known_issues, in the publisher's YAML. From there the CLI puts it in the Known Issues section of the README for people; the AGENTS file carries the data-quality and usage notes for agents; and the best practice is to make it a column an agent can filter on, a confidence value or a quality mask, rather than a paragraph it has to interpret. This is the expertise that otherwise lives only in the heads of domain experts, and it is the part of your metadata work that no automation replaces."
 [Sources]
 - https://github.com/portolan-sdi/portolan-spec/blob/main/specs/best-practices/documentation.md
+- South Tyrol mirror, health/rest-homes: `known_issues` in `.portolan/metadata.yaml` → `## Known Issues` in README.md; `## Data quality &amp; usage notes` in AGENTS.md (portolan-cli 0.8.0, checked 4 Sep 2026)
 - Trochim &amp; Roy 2025, Candid Core Framework, doi:10.5281/zenodo.15227664
 - https://source.coop/ftw/global-data
 - https://www.portolan-sdi.org/blog/introducing-portolan ("context that'd otherwise be scattered across documentation or live only in the heads of domain experts")</a:t>
@@ -743,7 +939,7 @@
           <a:p>
             <a:fld id="{F7021451-1387-4CA6-816F-3879F97B5CBC}" type="slidenum">
               <a:rPr lang="en-US"/>
-              <a:t>11</a:t>
+              <a:t>13</a:t>
             </a:fld>
             <a:endParaRPr lang="en-US"/>
           </a:p>
@@ -762,7 +958,7 @@
 </p:notes>
 </file>
 
-<file path=ppt/notesSlides/notesSlide12.xml><?xml version="1.0" encoding="utf-8"?>
+<file path=ppt/notesSlides/notesSlide14.xml><?xml version="1.0" encoding="utf-8"?>
 <p:notes xmlns:a="http://schemas.openxmlformats.org/drawingml/2006/main" xmlns:r="http://schemas.openxmlformats.org/officeDocument/2006/relationships" xmlns:p="http://schemas.openxmlformats.org/presentationml/2006/main">
   <p:cSld>
     <p:spTree>
@@ -842,7 +1038,7 @@
           <a:p>
             <a:fld id="{F7021451-1387-4CA6-816F-3879F97B5CBC}" type="slidenum">
               <a:rPr lang="en-US"/>
-              <a:t>12</a:t>
+              <a:t>14</a:t>
             </a:fld>
             <a:endParaRPr lang="en-US"/>
           </a:p>
@@ -861,7 +1057,7 @@
 </p:notes>
 </file>
 
-<file path=ppt/notesSlides/notesSlide13.xml><?xml version="1.0" encoding="utf-8"?>
+<file path=ppt/notesSlides/notesSlide15.xml><?xml version="1.0" encoding="utf-8"?>
 <p:notes xmlns:a="http://schemas.openxmlformats.org/drawingml/2006/main" xmlns:r="http://schemas.openxmlformats.org/officeDocument/2006/relationships" xmlns:p="http://schemas.openxmlformats.org/presentationml/2006/main">
   <p:cSld>
     <p:spTree>
@@ -945,7 +1141,7 @@
           <a:p>
             <a:fld id="{F7021451-1387-4CA6-816F-3879F97B5CBC}" type="slidenum">
               <a:rPr lang="en-US"/>
-              <a:t>13</a:t>
+              <a:t>15</a:t>
             </a:fld>
             <a:endParaRPr lang="en-US"/>
           </a:p>
@@ -964,7 +1160,7 @@
 </p:notes>
 </file>
 
-<file path=ppt/notesSlides/notesSlide14.xml><?xml version="1.0" encoding="utf-8"?>
+<file path=ppt/notesSlides/notesSlide16.xml><?xml version="1.0" encoding="utf-8"?>
 <p:notes xmlns:a="http://schemas.openxmlformats.org/drawingml/2006/main" xmlns:r="http://schemas.openxmlformats.org/officeDocument/2006/relationships" xmlns:p="http://schemas.openxmlformats.org/presentationml/2006/main">
   <p:cSld>
     <p:spTree>
@@ -1010,12 +1206,10 @@
           <a:p>
             <a:r>
               <a:rPr lang="en-US" dirty="0"/>
-              <a:t>[Say] (1:15)
-"Let me close with what we have not solved. Today every collection names who produced, licensed, processed and hosts the data. Whether a catalog is official or a mirror is derived from that, and a mirror must name its producer and link back to the original. The registry is deliberately nothing more than a catalog of independently hosted catalogs, about twenty at launch, from Overture and GHSL to national agencies in Argentina and Moldova to cities like Madrid, Utrecht and Philadelphia. If the registry disappeared tomorrow, every one of them would keep working."
+              <a:t>[Say] (0:45)
+"Let me close with what we have not solved. Today every collection names who produced, licensed, processed and hosts the data; whether a catalog is official or a mirror is derived from that; and the registry is nothing more than a catalog of about twenty independently hosted catalogs. If it disappeared tomorrow, every one of them would keep working. All of that is declarative. So three open questions, and they map straight onto the Testbed on Trusted Data and Systems: how should authority be signalled cryptographically? What does trust mean when the consumer is an agent nobody is watching? And how does a mirror prove it is faithful to its source?"
 [Click 1]
-"Everything on the left is declarative. The open questions map straight onto the Testbed on Trusted Data and Systems. How should authority be signalled cryptographically? What does trust mean when the consumer is an agent nobody is watching? How does a mirror prove it is faithful to its source?"
-[Click 2]
-"Portolan has been public for five days. It is built by a group of contributors across several organisations, it wants early adopters, and it still expects breaking changes. The first goal is about a hundred reference catalogs. The community call is Fridays at ten, Central European time, and the Slack channel is open. These are the questions we would like to work on with the people in this room. Thank you."
+"Portolan has been public for five days. It is built by contributors across several organisations, it wants early adopters, and it still expects breaking changes. The first goal is about a hundred reference catalogs. The community call is Fridays at ten, Central European time, the Slack channel is open, and I am at the demo desk during the coffee breaks. These are the questions we would like to work on with the people in this room. Thank you."
 [Sources]
 - https://github.com/portolan-sdi/portolan-spec/blob/main/specs/portolan/core.md (Providers, Source Provenance)
 - https://github.com/portolan-sdi/portolan-registry
@@ -1043,7 +1237,7 @@
           <a:p>
             <a:fld id="{F7021451-1387-4CA6-816F-3879F97B5CBC}" type="slidenum">
               <a:rPr lang="en-US"/>
-              <a:t>14</a:t>
+              <a:t>16</a:t>
             </a:fld>
             <a:endParaRPr lang="en-US"/>
           </a:p>
@@ -1062,101 +1256,7 @@
 </p:notes>
 </file>
 
-<file path=ppt/notesSlides/notesSlide15.xml><?xml version="1.0" encoding="utf-8"?>
-<p:notes xmlns:a="http://schemas.openxmlformats.org/drawingml/2006/main" xmlns:r="http://schemas.openxmlformats.org/officeDocument/2006/relationships" xmlns:p="http://schemas.openxmlformats.org/presentationml/2006/main">
-  <p:cSld>
-    <p:spTree>
-      <p:nvGrpSpPr>
-        <p:cNvPr id="1" name=""/>
-        <p:cNvGrpSpPr/>
-        <p:nvPr/>
-      </p:nvGrpSpPr>
-      <p:grpSpPr>
-        <a:xfrm>
-          <a:off x="0" y="0"/>
-          <a:ext cx="0" cy="0"/>
-          <a:chOff x="0" y="0"/>
-          <a:chExt cx="0" cy="0"/>
-        </a:xfrm>
-      </p:grpSpPr>
-      <p:sp>
-        <p:nvSpPr>
-          <p:cNvPr id="2" name="Slide Image Placeholder 1"/>
-          <p:cNvSpPr>
-            <a:spLocks noGrp="1" noRot="1" noChangeAspect="1"/>
-          </p:cNvSpPr>
-          <p:nvPr>
-            <p:ph type="sldImg"/>
-          </p:nvPr>
-        </p:nvSpPr>
-        <p:spPr/>
-      </p:sp>
-      <p:sp>
-        <p:nvSpPr>
-          <p:cNvPr id="3" name="Notes Placeholder 2"/>
-          <p:cNvSpPr>
-            <a:spLocks noGrp="1"/>
-          </p:cNvSpPr>
-          <p:nvPr>
-            <p:ph type="body" idx="1"/>
-          </p:nvPr>
-        </p:nvSpPr>
-        <p:spPr/>
-        <p:txBody>
-          <a:bodyPr/>
-          <a:lstStyle/>
-          <a:p>
-            <a:r>
-              <a:rPr lang="en-US" dirty="0"/>
-              <a:t>[Say] (0:45)
-"A postscript on the name. Portolan charts were among the earliest practical navigational maps. Not theoretical pictures of the world but working tools: built from sailors' observations, continuously refined, shared across ports and nations. Decentralised, made and improved by many hands. Interoperable, readable wherever a ship went. And critical infrastructure, for trade, for safety, for sovereignty."
-[Click 1]
-"The project takes its name from that tradition. Practical rather than academic. Built from data in open formats rather than drawings. Designed for sharing across organisations, clouds and borders. Thank you."
-[Sources]
-- Launch commentary, 2 September 2026: https://carto.com/blog/introducing-portolan-and-carto-sdi/ ("A postscript on the name")
-- Image: Wikimedia Commons, "1550 Portolan chart of the Mediterranean Sea and the Black Sea", Battista Agnese; Bibliothèque nationale de France; public domain</a:t>
-            </a:r>
-            <a:endParaRPr lang="en-US" dirty="0"/>
-          </a:p>
-        </p:txBody>
-      </p:sp>
-      <p:sp>
-        <p:nvSpPr>
-          <p:cNvPr id="4" name="Slide Number Placeholder 3"/>
-          <p:cNvSpPr>
-            <a:spLocks noGrp="1"/>
-          </p:cNvSpPr>
-          <p:nvPr>
-            <p:ph type="sldNum" sz="quarter" idx="10"/>
-          </p:nvPr>
-        </p:nvSpPr>
-        <p:spPr/>
-        <p:txBody>
-          <a:bodyPr/>
-          <a:lstStyle/>
-          <a:p>
-            <a:fld id="{F7021451-1387-4CA6-816F-3879F97B5CBC}" type="slidenum">
-              <a:rPr lang="en-US"/>
-              <a:t>15</a:t>
-            </a:fld>
-            <a:endParaRPr lang="en-US"/>
-          </a:p>
-        </p:txBody>
-      </p:sp>
-    </p:spTree>
-    <p:extLst>
-      <p:ext uri="{BB962C8B-B14F-4D97-AF65-F5344CB8AC3E}">
-        <p14:creationId xmlns:p14="http://schemas.microsoft.com/office/powerpoint/2010/main" val="1024086991"/>
-      </p:ext>
-    </p:extLst>
-  </p:cSld>
-  <p:clrMapOvr>
-    <a:masterClrMapping/>
-  </p:clrMapOvr>
-</p:notes>
-</file>
-
-<file path=ppt/notesSlides/notesSlide16.xml><?xml version="1.0" encoding="utf-8"?>
+<file path=ppt/notesSlides/notesSlide17.xml><?xml version="1.0" encoding="utf-8"?>
 <p:notes xmlns:a="http://schemas.openxmlformats.org/drawingml/2006/main" xmlns:r="http://schemas.openxmlformats.org/officeDocument/2006/relationships" xmlns:p="http://schemas.openxmlformats.org/presentationml/2006/main">
   <p:cSld>
     <p:spTree>
@@ -1235,7 +1335,7 @@
           <a:p>
             <a:fld id="{F7021451-1387-4CA6-816F-3879F97B5CBC}" type="slidenum">
               <a:rPr lang="en-US"/>
-              <a:t>16</a:t>
+              <a:t>17</a:t>
             </a:fld>
             <a:endParaRPr lang="en-US"/>
           </a:p>
@@ -1254,7 +1354,7 @@
 </p:notes>
 </file>
 
-<file path=ppt/notesSlides/notesSlide17.xml><?xml version="1.0" encoding="utf-8"?>
+<file path=ppt/notesSlides/notesSlide18.xml><?xml version="1.0" encoding="utf-8"?>
 <p:notes xmlns:a="http://schemas.openxmlformats.org/drawingml/2006/main" xmlns:r="http://schemas.openxmlformats.org/officeDocument/2006/relationships" xmlns:p="http://schemas.openxmlformats.org/presentationml/2006/main">
   <p:cSld>
     <p:spTree>
@@ -1300,15 +1400,13 @@
           <a:p>
             <a:r>
               <a:rPr lang="en-US" dirty="0"/>
-              <a:t>[Say] (1:00)
-"Before the close, the honesty checkpoint. This is the architecture of the portal, not a claim that infrastructure disappears. In a service-first portal, legacy files and a spatial database feed a GIS server, gateway, APIs, and tiles. Every request travels through that service chain."
+              <a:t>[Say] (0:45)
+"Portolan charts were among the earliest practical navigational maps. Not theoretical pictures of the world but working tools: built from sailors' observations, continuously refined, shared across ports and nations. Decentralised, made and improved by many hands. Interoperable, readable wherever a ship went. And critical infrastructure, for trade, for safety, for sovereignty."
 [Click 1]
-"A static-first portal moves the expensive preparation to a publisher-controlled job. It writes GeoParquet, COG, or PMTiles to object storage, links them through STAC, and lets browsers, desktop tools, and agents read them directly. Compute or an OGC API remains available on demand when a use case needs it."
-[Click 2]
-"The query path can shrink, but the operating work remains. We still convert, document, and validate releases. We still operate storage, CDN, IAM, DNS, security, and monitoring. People still govern quality, updates, and release decisions."
+"The project takes its name from that tradition. Practical rather than academic. Built from data in open formats rather than drawings. Designed for sharing across organisations, clouds and borders."
 [Sources]
-- https://github.com/portolan-sdi/portolan-spec/blob/main/specs/portolan/core.md
-- Speaker-provided `cng-infrastructure-concept.pdf`, consolidated and redrawn as a horizontal architecture comparison</a:t>
+- Launch commentary, 2 September 2026: https://carto.com/blog/introducing-portolan-and-carto-sdi/ ("A postscript on the name")
+- Image: Wikimedia Commons, "1550 Portolan chart of the Mediterranean Sea and the Black Sea", Battista Agnese; Bibliothèque nationale de France; public domain</a:t>
             </a:r>
             <a:endParaRPr lang="en-US" dirty="0"/>
           </a:p>
@@ -1331,7 +1429,7 @@
           <a:p>
             <a:fld id="{F7021451-1387-4CA6-816F-3879F97B5CBC}" type="slidenum">
               <a:rPr lang="en-US"/>
-              <a:t>17</a:t>
+              <a:t>18</a:t>
             </a:fld>
             <a:endParaRPr lang="en-US"/>
           </a:p>
@@ -1350,7 +1448,7 @@
 </p:notes>
 </file>
 
-<file path=ppt/notesSlides/notesSlide18.xml><?xml version="1.0" encoding="utf-8"?>
+<file path=ppt/notesSlides/notesSlide19.xml><?xml version="1.0" encoding="utf-8"?>
 <p:notes xmlns:a="http://schemas.openxmlformats.org/drawingml/2006/main" xmlns:r="http://schemas.openxmlformats.org/officeDocument/2006/relationships" xmlns:p="http://schemas.openxmlformats.org/presentationml/2006/main">
   <p:cSld>
     <p:spTree>
@@ -1431,7 +1529,7 @@
           <a:p>
             <a:fld id="{F7021451-1387-4CA6-816F-3879F97B5CBC}" type="slidenum">
               <a:rPr lang="en-US"/>
-              <a:t>18</a:t>
+              <a:t>19</a:t>
             </a:fld>
             <a:endParaRPr lang="en-US"/>
           </a:p>
@@ -1450,7 +1548,99 @@
 </p:notes>
 </file>
 
-<file path=ppt/notesSlides/notesSlide19.xml><?xml version="1.0" encoding="utf-8"?>
+<file path=ppt/notesSlides/notesSlide2.xml><?xml version="1.0" encoding="utf-8"?>
+<p:notes xmlns:a="http://schemas.openxmlformats.org/drawingml/2006/main" xmlns:r="http://schemas.openxmlformats.org/officeDocument/2006/relationships" xmlns:p="http://schemas.openxmlformats.org/presentationml/2006/main">
+  <p:cSld>
+    <p:spTree>
+      <p:nvGrpSpPr>
+        <p:cNvPr id="1" name=""/>
+        <p:cNvGrpSpPr/>
+        <p:nvPr/>
+      </p:nvGrpSpPr>
+      <p:grpSpPr>
+        <a:xfrm>
+          <a:off x="0" y="0"/>
+          <a:ext cx="0" cy="0"/>
+          <a:chOff x="0" y="0"/>
+          <a:chExt cx="0" cy="0"/>
+        </a:xfrm>
+      </p:grpSpPr>
+      <p:sp>
+        <p:nvSpPr>
+          <p:cNvPr id="2" name="Slide Image Placeholder 1"/>
+          <p:cNvSpPr>
+            <a:spLocks noGrp="1" noRot="1" noChangeAspect="1"/>
+          </p:cNvSpPr>
+          <p:nvPr>
+            <p:ph type="sldImg"/>
+          </p:nvPr>
+        </p:nvSpPr>
+        <p:spPr/>
+      </p:sp>
+      <p:sp>
+        <p:nvSpPr>
+          <p:cNvPr id="3" name="Notes Placeholder 2"/>
+          <p:cNvSpPr>
+            <a:spLocks noGrp="1"/>
+          </p:cNvSpPr>
+          <p:nvPr>
+            <p:ph type="body" idx="1"/>
+          </p:nvPr>
+        </p:nvSpPr>
+        <p:spPr/>
+        <p:txBody>
+          <a:bodyPr/>
+          <a:lstStyle/>
+          <a:p>
+            <a:r>
+              <a:rPr lang="en-US" dirty="0"/>
+              <a:t>[Say] (0:30)
+"Briefly, who is talking. I am Director of Engineering for Professional Services at CARTO, I collaborate on the Portolan SDI project, and I have spent more than twenty years in the geospatial industry, most of it contributing to open-source software. I am based in Seville. Everything I show is open; the slides and the catalog are at the addresses on the right."
+[Sources]
+- https://github.com/cayetanobv
+- https://cayetanobv.github.io/ogc-metadata-summit-bolzano/</a:t>
+            </a:r>
+            <a:endParaRPr lang="en-US" dirty="0"/>
+          </a:p>
+        </p:txBody>
+      </p:sp>
+      <p:sp>
+        <p:nvSpPr>
+          <p:cNvPr id="4" name="Slide Number Placeholder 3"/>
+          <p:cNvSpPr>
+            <a:spLocks noGrp="1"/>
+          </p:cNvSpPr>
+          <p:nvPr>
+            <p:ph type="sldNum" sz="quarter" idx="10"/>
+          </p:nvPr>
+        </p:nvSpPr>
+        <p:spPr/>
+        <p:txBody>
+          <a:bodyPr/>
+          <a:lstStyle/>
+          <a:p>
+            <a:fld id="{F7021451-1387-4CA6-816F-3879F97B5CBC}" type="slidenum">
+              <a:rPr lang="en-US"/>
+              <a:t>2</a:t>
+            </a:fld>
+            <a:endParaRPr lang="en-US"/>
+          </a:p>
+        </p:txBody>
+      </p:sp>
+    </p:spTree>
+    <p:extLst>
+      <p:ext uri="{BB962C8B-B14F-4D97-AF65-F5344CB8AC3E}">
+        <p14:creationId xmlns:p14="http://schemas.microsoft.com/office/powerpoint/2010/main" val="1024086991"/>
+      </p:ext>
+    </p:extLst>
+  </p:cSld>
+  <p:clrMapOvr>
+    <a:masterClrMapping/>
+  </p:clrMapOvr>
+</p:notes>
+</file>
+
+<file path=ppt/notesSlides/notesSlide20.xml><?xml version="1.0" encoding="utf-8"?>
 <p:notes xmlns:a="http://schemas.openxmlformats.org/drawingml/2006/main" xmlns:r="http://schemas.openxmlformats.org/officeDocument/2006/relationships" xmlns:p="http://schemas.openxmlformats.org/presentationml/2006/main">
   <p:cSld>
     <p:spTree>
@@ -1521,7 +1711,7 @@
           <a:p>
             <a:fld id="{F7021451-1387-4CA6-816F-3879F97B5CBC}" type="slidenum">
               <a:rPr lang="en-US"/>
-              <a:t>19</a:t>
+              <a:t>20</a:t>
             </a:fld>
             <a:endParaRPr lang="en-US"/>
           </a:p>
@@ -1540,7 +1730,7 @@
 </p:notes>
 </file>
 
-<file path=ppt/notesSlides/notesSlide2.xml><?xml version="1.0" encoding="utf-8"?>
+<file path=ppt/notesSlides/notesSlide3.xml><?xml version="1.0" encoding="utf-8"?>
 <p:notes xmlns:a="http://schemas.openxmlformats.org/drawingml/2006/main" xmlns:r="http://schemas.openxmlformats.org/officeDocument/2006/relationships" xmlns:p="http://schemas.openxmlformats.org/presentationml/2006/main">
   <p:cSld>
     <p:spTree>
@@ -1586,11 +1776,15 @@
           <a:p>
             <a:r>
               <a:rPr lang="en-US" dirty="0"/>
-              <a:t>[Say] (0:35)
-"Briefly, who is talking. I am Director of Engineering for Professional Services at CARTO, I collaborate on the Portolan SDI project, and I have spent more than twenty years in the geospatial industry, most of it contributing to open-source software. I am based in Seville. Everything I show is open; the slides and the catalog are at the addresses on the right."
+              <a:t>[Say] (0:45)
+"Everyone says metadata should be AI-ready. Few people say what that means when you have to publish a dataset on a Monday morning. We tried to find out by building, not by defining. This is what we built. Portolan is an open-source specification and toolkit that combines cloud-native file formats with clear metadata and documentation, so that people and agents can publish and use data at any scale."
+[Click 1]
+"Each phrase in that sentence is a real thing. Specification and toolkit: a spec, a CLI, a validator called rashid, and a registry of catalogs. Cloud-native formats: GeoParquet, Cloud Optimized GeoTIFF, PMTiles. Clear metadata: a STAC publishing profile that says what a catalog must contain. Documentation: a README for people and an AGENTS file for agents, at every level. And people and agents at any scale: ten agent skills, and catalogs from a city's open data to a 369-terabyte archive. Portolan went public last Wednesday, after a year of building in the open. This is a success story with the scars still visible."
 [Sources]
-- https://github.com/cayetanobv
-- https://cayetanobv.github.io/ogc-metadata-summit-bolzano/</a:t>
+- https://www.portolan-sdi.org/ (definition sentence, checked 4 Sep 2026)
+- https://www.portolan-sdi.org/blog/introducing-portolan
+- https://github.com/portolan-sdi/portolan-spec · https://github.com/portolan-sdi/rashid · https://github.com/portolan-sdi/portolan-cli
+- https://github.com/portolan-sdi/portolan-registry · https://github.com/portolan-sdi/portolan-skills</a:t>
             </a:r>
             <a:endParaRPr lang="en-US" dirty="0"/>
           </a:p>
@@ -1613,7 +1807,7 @@
           <a:p>
             <a:fld id="{F7021451-1387-4CA6-816F-3879F97B5CBC}" type="slidenum">
               <a:rPr lang="en-US"/>
-              <a:t>2</a:t>
+              <a:t>3</a:t>
             </a:fld>
             <a:endParaRPr lang="en-US"/>
           </a:p>
@@ -1632,7 +1826,7 @@
 </p:notes>
 </file>
 
-<file path=ppt/notesSlides/notesSlide20.xml><?xml version="1.0" encoding="utf-8"?>
+<file path=ppt/notesSlides/notesSlide4.xml><?xml version="1.0" encoding="utf-8"?>
 <p:notes xmlns:a="http://schemas.openxmlformats.org/drawingml/2006/main" xmlns:r="http://schemas.openxmlformats.org/officeDocument/2006/relationships" xmlns:p="http://schemas.openxmlformats.org/presentationml/2006/main">
   <p:cSld>
     <p:spTree>
@@ -1678,16 +1872,23 @@
           <a:p>
             <a:r>
               <a:rPr lang="en-US" dirty="0"/>
-              <a:t>[Say]
-"Fourth lesson. Portolan is STAC 1.1 at its core and reuses STAC extensions wherever they fit. We build on existing standards and contribute back."
+              <a:t>[Say] (1:00)
+"Why did we build it? Not because spatial data infrastructures failed. The vision is the same one you have worked on for two decades: a federated infrastructure, discoverable, interoperable, open to all. What changed is what the delivery layer should give you. Five goals, borrowed from Chris Holmes's framing."
 [Click 1]
-"STAC keeps doing its job: describe and link catalogs, collections, items and assets."
+"AI-ready. Our SDIs were not built for agents. Agents want the full dataset and rich metadata, fast, and they should be first-class readers, not scrapers."
 [Click 2]
-"On top, Portolan makes publishing choices explicit and strict: cloud-native formats only, spatial ordering inside files, statistics, documentation at every level, providers and license on every collection. Why so prescriptive? Because an agent can only rely on what is required. Every MAY in a spec is a branch every consumer has to write. Flexibility is a cost paid by every reader, forever. Being prescriptive is what makes metadata machine-usable."
+"Easy to implement. Today you need a database, a WFS, a WMS, schemas and specialist staff. That barrier keeps most organisations out. It should be files in a bucket."
+[Click 3]
+"Scalable. Agents crawl whole datasets. Today popularity means more servers, until something breaks. It should scale with nobody on call."
+[Click 4]
+"Low cost. Servers always on, ops engineers, and a traffic spike is an emergency. Sharing public data should cost storage and egress."
+[Click 5]
+"Sovereign. The full stack inside your jurisdiction, with storage, compute, models and standards you can swap independently. Your catalogues, records and models stay authoritative. What Portolan changes is how the data underneath them is delivered."
 [Sources]
-- https://github.com/portolan-sdi/portolan-spec/blob/main/specs/portolan/core.md
-- https://github.com/portolan-sdi/portolan-spec/blob/main/specs/portolan/formats.md
-- https://github.com/portolan-sdi/portolan-spec/blob/main/specs/best-practices/philosophy.md</a:t>
+- https://cholmes.github.io/open-geodag-presentation/opengeo-dag.html (slides 5–10: the vision and the five goals; Chris frames the first as AI-first, this deck says AI-ready on screen)
+- https://www.portolan-sdi.org/blog/introducing-portolan ("What Portolan makes possible", "Built for people and agents")
+- https://github.com/portolan-sdi/portolan-ops/blob/main/copy/messaging.md ("Why Portolan?")
+- https://inspire.ec.europa.eu/</a:t>
             </a:r>
             <a:endParaRPr lang="en-US" dirty="0"/>
           </a:p>
@@ -1710,7 +1911,7 @@
           <a:p>
             <a:fld id="{F7021451-1387-4CA6-816F-3879F97B5CBC}" type="slidenum">
               <a:rPr lang="en-US"/>
-              <a:t>20</a:t>
+              <a:t>4</a:t>
             </a:fld>
             <a:endParaRPr lang="en-US"/>
           </a:p>
@@ -1729,7 +1930,7 @@
 </p:notes>
 </file>
 
-<file path=ppt/notesSlides/notesSlide21.xml><?xml version="1.0" encoding="utf-8"?>
+<file path=ppt/notesSlides/notesSlide5.xml><?xml version="1.0" encoding="utf-8"?>
 <p:notes xmlns:a="http://schemas.openxmlformats.org/drawingml/2006/main" xmlns:r="http://schemas.openxmlformats.org/officeDocument/2006/relationships" xmlns:p="http://schemas.openxmlformats.org/presentationml/2006/main">
   <p:cSld>
     <p:spTree>
@@ -1775,15 +1976,21 @@
           <a:p>
             <a:r>
               <a:rPr lang="en-US" dirty="0"/>
-              <a:t>[Say]
-"Sixth lesson. Portolan catalogs are static. Files in a bucket, described by STAC, with two Markdown files beside them. There is no server to operate and no STAC API. The metadata is the interface."
+              <a:t>[Say] (1:15)
+"Everything a Portolan catalog is made of, you already know, and most of it carries an OGC stamp. STAC, catalog to asset, has been an OGC Community Standard since last October. Every STAC Item is a GeoJSON Feature, an IETF standard. Cloud Optimized GeoTIFF is an OGC Standard since 2023. GeoParquet has its own OGC Standards Working Group; approval of 1.0 is the remaining formality. Zarr, which we plan but have not shipped, is an OGC Community Standard. PMTiles for display is a community format, and underneath it all are HTTP range requests on object storage. Nothing here is ours."
 [Click 1]
-"An agent reads the catalog and then queries the GeoParquet directly with DuckDB, with no credentials. QGIS, Pandas and BigQuery read the same files."
+"STAC does its normal job: it describes and links the same objects, catalog, collection, item, asset. Portolan uses the static side of STAC only: files, no API."
 [Click 2]
-"The consequences are what a spatial data infrastructure cares about. Cost drops to storage and egress. Nothing runs after publishing. Sovereignty is structural, because the publisher chooses where the bytes live, including a provider in their own country. And if Portolan disappeared tomorrow, every file would still open in the tools you already use."
+"Every one of those standards deliberately leaves the publishing choices open. That is the right design for a standard and the wrong thing to leave open for a reader, because every open choice is a branch every reader has to handle. Portolan makes six of those choices explicit: structure and links, formats and statistics, access and hosting, licence and provenance, README and AGENTS documentation, and visualisation. A catalog declares which version of the profile it follows. STAC describes the data. Portolan defines how it is published."
 [Sources]
-- https://github.com/portolan-sdi/portolan-spec/blob/main/specs/portolan/core.md
-- https://github.com/portolan-sdi/portolan-ops/blob/main/copy/messaging.md</a:t>
+- https://www.ogc.org/announcement/ogc-announces-publication-of-the-spatiotemporal-asset-catalog-community-standards/ (28 Oct 2025; "an Item … is simply a GeoJSON Feature")
+- https://datatracker.ietf.org/doc/html/rfc7946 (GeoJSON, IETF, not an OGC document)
+- https://docs.ogc.org/is/21-026/21-026.html (OGC Cloud Optimized GeoTIFF Standard 1.0, 2023)
+- https://github.com/opengeospatial/geoparquet/blob/main/README.md ("official Standards Working Group … pending OGC approval", checked 3 Sep 2026)
+- https://www.ogc.org/announcement/ogc-forms-new-geozarr-standards-working-group-to-establish-a-zarr-encoding-for-geospatial-data/ (Zarr V2 endorsed as OGC Community Standard, June 2022)
+- https://docs.protomaps.com/pmtiles/ (PMTiles; not an OGC document)
+- https://github.com/portolan-sdi/portolan-spec/blob/main/specs/portolan/core.md (the six families of publishing choices)
+- VizTheGap by Youssef Harby, CNG Japan 2026 deck, reused as team material</a:t>
             </a:r>
             <a:endParaRPr lang="en-US" dirty="0"/>
           </a:p>
@@ -1806,7 +2013,7 @@
           <a:p>
             <a:fld id="{F7021451-1387-4CA6-816F-3879F97B5CBC}" type="slidenum">
               <a:rPr lang="en-US"/>
-              <a:t>21</a:t>
+              <a:t>5</a:t>
             </a:fld>
             <a:endParaRPr lang="en-US"/>
           </a:p>
@@ -1825,7 +2032,7 @@
 </p:notes>
 </file>
 
-<file path=ppt/notesSlides/notesSlide3.xml><?xml version="1.0" encoding="utf-8"?>
+<file path=ppt/notesSlides/notesSlide6.xml><?xml version="1.0" encoding="utf-8"?>
 <p:notes xmlns:a="http://schemas.openxmlformats.org/drawingml/2006/main" xmlns:r="http://schemas.openxmlformats.org/officeDocument/2006/relationships" xmlns:p="http://schemas.openxmlformats.org/presentationml/2006/main">
   <p:cSld>
     <p:spTree>
@@ -1871,16 +2078,20 @@
           <a:p>
             <a:r>
               <a:rPr lang="en-US" dirty="0"/>
-              <a:t>[Say] (0:35)
-"The phrase AI-ready metadata is everywhere. Few people say what it means when you actually have to publish a dataset on a Monday morning. We tried to answer it by building instead of defining."
+              <a:t>[Say] (0:45)
+"Here is the big picture. Portolan is an opinionated, checkable STAC publishing profile and practice. It connects the pieces you just saw into one repeatable lifecycle: publish, update, use. It introduces no new data format and replaces none of STAC, GeoParquet, COG, HTTP or object storage."
 [Click 1]
-"A spec, a validator, a CLI, ten agent skills, a registry, and real catalogs. Portolan went public last Wednesday, the second of September, after a year of building in the open. So this is a success story with the scars still visible: what worked, and what surprised us."
+"Publish means convert the data to an open cloud-native format, describe it with STAC and documentation, validate it, and upload a static publication to storage the publisher controls."
+[Click 2]
+"Update follows the same contract. Change the source, preserve licence and provenance, regenerate the affected artifacts, check them again, and sync them. No second delivery path."
+[Click 3]
+"Use begins at the same catalog for software, for people and for agents. And the five goals from the previous slide are directions the design points at, not guarantees."
 [Sources]
-- https://www.portolan-sdi.org/blog/introducing-portolan
-- https://github.com/portolan-sdi/portolan-spec
-- https://github.com/portolan-sdi/rashid
-- https://github.com/portolan-sdi/portolan-cli
-- https://github.com/portolan-sdi/portolan-registry</a:t>
+- https://github.com/portolan-sdi/portolan-spec/releases/tag/v0.2.0
+- https://github.com/portolan-sdi/portolan-spec/blob/main/README.md
+- https://github.com/portolan-sdi/portolan-cli/blob/main/README.md
+- https://github.com/portolan-sdi/portolan-ops/blob/main/copy/messaging.md
+- VizPortolanContract by Youssef Harby, CNG Japan 2026 deck (slide 11 and its speaker notes), reused as team material</a:t>
             </a:r>
             <a:endParaRPr lang="en-US" dirty="0"/>
           </a:p>
@@ -1903,7 +2114,7 @@
           <a:p>
             <a:fld id="{F7021451-1387-4CA6-816F-3879F97B5CBC}" type="slidenum">
               <a:rPr lang="en-US"/>
-              <a:t>3</a:t>
+              <a:t>6</a:t>
             </a:fld>
             <a:endParaRPr lang="en-US"/>
           </a:p>
@@ -1922,7 +2133,7 @@
 </p:notes>
 </file>
 
-<file path=ppt/notesSlides/notesSlide4.xml><?xml version="1.0" encoding="utf-8"?>
+<file path=ppt/notesSlides/notesSlide7.xml><?xml version="1.0" encoding="utf-8"?>
 <p:notes xmlns:a="http://schemas.openxmlformats.org/drawingml/2006/main" xmlns:r="http://schemas.openxmlformats.org/officeDocument/2006/relationships" xmlns:p="http://schemas.openxmlformats.org/presentationml/2006/main">
   <p:cSld>
     <p:spTree>
@@ -1968,14 +2179,16 @@
           <a:p>
             <a:r>
               <a:rPr lang="en-US" dirty="0"/>
-              <a:t>[Say] (0:50)
-"Why did we build Portolan? Not because spatial data infrastructures failed. Two decades of your work got the hard part right: harmonised models, catalogues, INSPIRE themes, ISO records, services that made national data findable across borders. Portolan starts from that work."
+              <a:t>[Say] (1:00)
+"So what does Portolan add on top of those standards? Four things they leave open become mandatory. One: a quality floor you can check. Bounding boxes and spatial ordering inside every GeoParquet, overviews in every COG, providers and a licence on every collection, range requests and CORS on the host; and the validator reads the bytes, not just the JSON. Two: two documents at every level, a README for the person deciding whether to trust the data and an AGENTS file for the agent that needs the join key and the caveats. Three: no server in the request path; a catalog is a folder in storage you control, cost drops to storage and egress, nothing runs after publishing. Four: federation without a central copy, a registry of independently hosted catalogs with producer, provider and host named on every one."
 [Click 1]
-"What changed is the delivery layer underneath it. A file in object storage can now be queried directly, so a dataset no longer needs its own server to be usable. Agents are readers too, and they need the same metadata people need, machine-checkable and next to the data. And sovereignty is designed in: storage, compute, models and standards chosen and replaced independently. Portolan is the publishing profile that lets the data you already curate reach more people and more agents, with less to run, while your catalogues, records and models stay authoritative."
+"Does a static model scale? Fields of the World publishes its global field-boundary dataset as one Portolan catalog on Source Cooperative: 369 terabytes, and it served a hundred and six terabytes in the last four weeks of August. Nothing sits in front of it. The publisher pays for storage and egress; compute belongs to whoever asks the question. That is what lets a city and a planetary archive publish the same way."
 [Sources]
-- https://www.portolan-sdi.org/blog/introducing-portolan ("What Portolan makes possible", "Built for people and agents")
-- https://github.com/portolan-sdi/portolan-ops/blob/main/copy/messaging.md ("Why Portolan?", "Does it standardize my data model?")
-- https://inspire.ec.europa.eu/</a:t>
+- https://www.portolan-sdi.org/blog/introducing-portolan (Fig. 1: 369 TB, 106.6 TB in the 28 days ending 27 Aug 2026; "What Portolan makes possible", "Built for people and agents", "Toward a federated network")
+- https://github.com/portolan-sdi/portolan-ops/blob/main/copy/messaging.md ("Why Portolan?", "Common questions")
+- https://source.coop/ftw/global-data
+- https://github.com/portolan-sdi/portolan-spec/blob/main/specs/portolan/core.md
+- https://github.com/portolan-sdi/portolan-spec/blob/main/specs/portolan/formats.md</a:t>
             </a:r>
             <a:endParaRPr lang="en-US" dirty="0"/>
           </a:p>
@@ -1998,7 +2211,7 @@
           <a:p>
             <a:fld id="{F7021451-1387-4CA6-816F-3879F97B5CBC}" type="slidenum">
               <a:rPr lang="en-US"/>
-              <a:t>4</a:t>
+              <a:t>7</a:t>
             </a:fld>
             <a:endParaRPr lang="en-US"/>
           </a:p>
@@ -2017,205 +2230,7 @@
 </p:notes>
 </file>
 
-<file path=ppt/notesSlides/notesSlide5.xml><?xml version="1.0" encoding="utf-8"?>
-<p:notes xmlns:a="http://schemas.openxmlformats.org/drawingml/2006/main" xmlns:r="http://schemas.openxmlformats.org/officeDocument/2006/relationships" xmlns:p="http://schemas.openxmlformats.org/presentationml/2006/main">
-  <p:cSld>
-    <p:spTree>
-      <p:nvGrpSpPr>
-        <p:cNvPr id="1" name=""/>
-        <p:cNvGrpSpPr/>
-        <p:nvPr/>
-      </p:nvGrpSpPr>
-      <p:grpSpPr>
-        <a:xfrm>
-          <a:off x="0" y="0"/>
-          <a:ext cx="0" cy="0"/>
-          <a:chOff x="0" y="0"/>
-          <a:chExt cx="0" cy="0"/>
-        </a:xfrm>
-      </p:grpSpPr>
-      <p:sp>
-        <p:nvSpPr>
-          <p:cNvPr id="2" name="Slide Image Placeholder 1"/>
-          <p:cNvSpPr>
-            <a:spLocks noGrp="1" noRot="1" noChangeAspect="1"/>
-          </p:cNvSpPr>
-          <p:nvPr>
-            <p:ph type="sldImg"/>
-          </p:nvPr>
-        </p:nvSpPr>
-        <p:spPr/>
-      </p:sp>
-      <p:sp>
-        <p:nvSpPr>
-          <p:cNvPr id="3" name="Notes Placeholder 2"/>
-          <p:cNvSpPr>
-            <a:spLocks noGrp="1"/>
-          </p:cNvSpPr>
-          <p:nvPr>
-            <p:ph type="body" idx="1"/>
-          </p:nvPr>
-        </p:nvSpPr>
-        <p:spPr/>
-        <p:txBody>
-          <a:bodyPr/>
-          <a:lstStyle/>
-          <a:p>
-            <a:r>
-              <a:rPr lang="en-US" dirty="0"/>
-              <a:t>[Say] (1:30)
-"Everything a Portolan catalog is made of, you already know, and most of it carries an OGC stamp. STAC, catalog to asset, has been an OGC Community Standard since last October, and every STAC Item is a GeoJSON Feature. Portolan uses the static side of STAC only: files, no API. Cloud Optimized GeoTIFF is an OGC Standard since 2023. GeoParquet has its own OGC Standards Working Group; approval of 1.0 is the remaining formality. Zarr, which we plan but have not shipped, is an OGC Community Standard. PMTiles for display is a community format outside OGC, and underneath it all are HTTP range requests on object storage. Nothing here is ours."
-[Click 1]
-"So what is left to specify? Every one of those standards deliberately leaves the publishing choices open: how files are laid out, whether they are spatially ordered, which statistics they carry, what documentation sits next to them, how they are hosted, who produced them. That is the right design for a standard. It is the wrong thing to leave open for a reader, because every open choice is a branch every reader has to handle."
-[Click 2]
-"That is the gap Portolan fills. STAC describes the data. Portolan defines how it is published. It is a publishing profile on top of these standards, not a new format: Apache-2.0, version 0.2.0, 128 requirements, 105 of them checked by a machine."
-[Sources]
-- https://www.ogc.org/announcement/ogc-announces-publication-of-the-spatiotemporal-asset-catalog-community-standards/ (28 Oct 2025; "an Item … is simply a GeoJSON Feature")
-- https://docs.ogc.org/is/21-026/21-026.html (OGC Cloud Optimized GeoTIFF Standard 1.0, 2023)
-- https://github.com/opengeospatial/geoparquet/blob/main/README.md ("official Standards Working Group … pending OGC approval", checked 3 Sep 2026)
-- https://www.ogc.org/announcement/ogc-forms-new-geozarr-standards-working-group-to-establish-a-zarr-encoding-for-geospatial-data/ (Zarr V2 endorsed as OGC Community Standard, June 2022)
-- https://docs.protomaps.com/pmtiles/ (PMTiles; not an OGC document)
-- https://github.com/portolan-sdi/portolan-ops/blob/main/copy/messaging.md ("Isn't this just STAC and cloud-optimized formats?")</a:t>
-            </a:r>
-            <a:endParaRPr lang="en-US" dirty="0"/>
-          </a:p>
-        </p:txBody>
-      </p:sp>
-      <p:sp>
-        <p:nvSpPr>
-          <p:cNvPr id="4" name="Slide Number Placeholder 3"/>
-          <p:cNvSpPr>
-            <a:spLocks noGrp="1"/>
-          </p:cNvSpPr>
-          <p:nvPr>
-            <p:ph type="sldNum" sz="quarter" idx="10"/>
-          </p:nvPr>
-        </p:nvSpPr>
-        <p:spPr/>
-        <p:txBody>
-          <a:bodyPr/>
-          <a:lstStyle/>
-          <a:p>
-            <a:fld id="{F7021451-1387-4CA6-816F-3879F97B5CBC}" type="slidenum">
-              <a:rPr lang="en-US"/>
-              <a:t>5</a:t>
-            </a:fld>
-            <a:endParaRPr lang="en-US"/>
-          </a:p>
-        </p:txBody>
-      </p:sp>
-    </p:spTree>
-    <p:extLst>
-      <p:ext uri="{BB962C8B-B14F-4D97-AF65-F5344CB8AC3E}">
-        <p14:creationId xmlns:p14="http://schemas.microsoft.com/office/powerpoint/2010/main" val="1024086991"/>
-      </p:ext>
-    </p:extLst>
-  </p:cSld>
-  <p:clrMapOvr>
-    <a:masterClrMapping/>
-  </p:clrMapOvr>
-</p:notes>
-</file>
-
-<file path=ppt/notesSlides/notesSlide6.xml><?xml version="1.0" encoding="utf-8"?>
-<p:notes xmlns:a="http://schemas.openxmlformats.org/drawingml/2006/main" xmlns:r="http://schemas.openxmlformats.org/officeDocument/2006/relationships" xmlns:p="http://schemas.openxmlformats.org/presentationml/2006/main">
-  <p:cSld>
-    <p:spTree>
-      <p:nvGrpSpPr>
-        <p:cNvPr id="1" name=""/>
-        <p:cNvGrpSpPr/>
-        <p:nvPr/>
-      </p:nvGrpSpPr>
-      <p:grpSpPr>
-        <a:xfrm>
-          <a:off x="0" y="0"/>
-          <a:ext cx="0" cy="0"/>
-          <a:chOff x="0" y="0"/>
-          <a:chExt cx="0" cy="0"/>
-        </a:xfrm>
-      </p:grpSpPr>
-      <p:sp>
-        <p:nvSpPr>
-          <p:cNvPr id="2" name="Slide Image Placeholder 1"/>
-          <p:cNvSpPr>
-            <a:spLocks noGrp="1" noRot="1" noChangeAspect="1"/>
-          </p:cNvSpPr>
-          <p:nvPr>
-            <p:ph type="sldImg"/>
-          </p:nvPr>
-        </p:nvSpPr>
-        <p:spPr/>
-      </p:sp>
-      <p:sp>
-        <p:nvSpPr>
-          <p:cNvPr id="3" name="Notes Placeholder 2"/>
-          <p:cNvSpPr>
-            <a:spLocks noGrp="1"/>
-          </p:cNvSpPr>
-          <p:nvPr>
-            <p:ph type="body" idx="1"/>
-          </p:nvPr>
-        </p:nvSpPr>
-        <p:spPr/>
-        <p:txBody>
-          <a:bodyPr/>
-          <a:lstStyle/>
-          <a:p>
-            <a:r>
-              <a:rPr lang="en-US" dirty="0"/>
-              <a:t>[Say] (1:15)
-"So what does Portolan add, and why should anyone outside this room care? Four things the standards leave open become mandatory. One: a quality floor you can check. Spatial ordering and bounding boxes inside every GeoParquet, overviews in every COG, providers and a license on every collection, range requests and CORS on the host; and the validator reads the bytes, not just the JSON. Two: documentation for two audiences at every level, a README for the person deciding whether to trust the data and an AGENTS file for the agent that needs the join key and the caveats. Three: no server in the request path; a catalog is a folder in storage the publisher controls, cost drops to storage and egress, sovereignty is structural, nothing runs after publishing. Four: federation without a central copy, a registry of independently hosted catalogs with producer, provider and host named on every one. Portolan is the missing agreement that lets a city and a planetary archive publish the same way."
-[Click 1]
-"Does a static model scale? Fields of the World publishes its global field-boundary dataset as one Portolan catalog on Source Cooperative: 369 terabytes, and it served a hundred and six terabytes in the last four weeks of August. Nothing sits in front of it. The publisher pays for storage and egress; compute belongs to whoever asks the question."
-[Sources]
-- https://www.portolan-sdi.org/blog/introducing-portolan (Fig. 1: 369 TB, 106.6 TB in the 28 days ending 27 Aug 2026; "What Portolan makes possible", "Built for people and agents", "Toward a federated network")
-- https://github.com/portolan-sdi/portolan-ops/blob/main/copy/messaging.md ("Why Portolan?", "Common questions")
-- The three shifts (economics of cloud-native formats, agents changing who can use data, sovereignty as architecture) are the framing of the 2 Sep 2026 launch commentary; facts only, no vendor cited on screen
-- https://source.coop/ftw/global-data
-- https://github.com/portolan-sdi/portolan-spec/blob/main/specs/portolan/core.md
-- https://github.com/portolan-sdi/portolan-spec/blob/main/specs/portolan/formats.md</a:t>
-            </a:r>
-            <a:endParaRPr lang="en-US" dirty="0"/>
-          </a:p>
-        </p:txBody>
-      </p:sp>
-      <p:sp>
-        <p:nvSpPr>
-          <p:cNvPr id="4" name="Slide Number Placeholder 3"/>
-          <p:cNvSpPr>
-            <a:spLocks noGrp="1"/>
-          </p:cNvSpPr>
-          <p:nvPr>
-            <p:ph type="sldNum" sz="quarter" idx="10"/>
-          </p:nvPr>
-        </p:nvSpPr>
-        <p:spPr/>
-        <p:txBody>
-          <a:bodyPr/>
-          <a:lstStyle/>
-          <a:p>
-            <a:fld id="{F7021451-1387-4CA6-816F-3879F97B5CBC}" type="slidenum">
-              <a:rPr lang="en-US"/>
-              <a:t>6</a:t>
-            </a:fld>
-            <a:endParaRPr lang="en-US"/>
-          </a:p>
-        </p:txBody>
-      </p:sp>
-    </p:spTree>
-    <p:extLst>
-      <p:ext uri="{BB962C8B-B14F-4D97-AF65-F5344CB8AC3E}">
-        <p14:creationId xmlns:p14="http://schemas.microsoft.com/office/powerpoint/2010/main" val="1024086991"/>
-      </p:ext>
-    </p:extLst>
-  </p:cSld>
-  <p:clrMapOvr>
-    <a:masterClrMapping/>
-  </p:clrMapOvr>
-</p:notes>
-</file>
-
-<file path=ppt/notesSlides/notesSlide7.xml><?xml version="1.0" encoding="utf-8"?>
+<file path=ppt/notesSlides/notesSlide8.xml><?xml version="1.0" encoding="utf-8"?>
 <p:notes xmlns:a="http://schemas.openxmlformats.org/drawingml/2006/main" xmlns:r="http://schemas.openxmlformats.org/officeDocument/2006/relationships" xmlns:p="http://schemas.openxmlformats.org/presentationml/2006/main">
   <p:cSld>
     <p:spTree>
@@ -2298,7 +2313,7 @@
           <a:p>
             <a:fld id="{F7021451-1387-4CA6-816F-3879F97B5CBC}" type="slidenum">
               <a:rPr lang="en-US"/>
-              <a:t>7</a:t>
+              <a:t>8</a:t>
             </a:fld>
             <a:endParaRPr lang="en-US"/>
           </a:p>
@@ -2317,101 +2332,6 @@
 </p:notes>
 </file>
 
-<file path=ppt/notesSlides/notesSlide8.xml><?xml version="1.0" encoding="utf-8"?>
-<p:notes xmlns:a="http://schemas.openxmlformats.org/drawingml/2006/main" xmlns:r="http://schemas.openxmlformats.org/officeDocument/2006/relationships" xmlns:p="http://schemas.openxmlformats.org/presentationml/2006/main">
-  <p:cSld>
-    <p:spTree>
-      <p:nvGrpSpPr>
-        <p:cNvPr id="1" name=""/>
-        <p:cNvGrpSpPr/>
-        <p:nvPr/>
-      </p:nvGrpSpPr>
-      <p:grpSpPr>
-        <a:xfrm>
-          <a:off x="0" y="0"/>
-          <a:ext cx="0" cy="0"/>
-          <a:chOff x="0" y="0"/>
-          <a:chExt cx="0" cy="0"/>
-        </a:xfrm>
-      </p:grpSpPr>
-      <p:sp>
-        <p:nvSpPr>
-          <p:cNvPr id="2" name="Slide Image Placeholder 1"/>
-          <p:cNvSpPr>
-            <a:spLocks noGrp="1" noRot="1" noChangeAspect="1"/>
-          </p:cNvSpPr>
-          <p:nvPr>
-            <p:ph type="sldImg"/>
-          </p:nvPr>
-        </p:nvSpPr>
-        <p:spPr/>
-      </p:sp>
-      <p:sp>
-        <p:nvSpPr>
-          <p:cNvPr id="3" name="Notes Placeholder 2"/>
-          <p:cNvSpPr>
-            <a:spLocks noGrp="1"/>
-          </p:cNvSpPr>
-          <p:nvPr>
-            <p:ph type="body" idx="1"/>
-          </p:nvPr>
-        </p:nvSpPr>
-        <p:spPr/>
-        <p:txBody>
-          <a:bodyPr/>
-          <a:lstStyle/>
-          <a:p>
-            <a:r>
-              <a:rPr lang="en-US" dirty="0"/>
-              <a:t>[Say] (1:15)
-"Second story, same catalog, the next day. Out of 69 collections, an agent was asked a question no single layer answers: which hospitals and pharmacies sit inside high or very-high hydraulic hazard zones, and how many residents live in those municipalities. Nobody guided it."
-[Click 1]
-"Four of seventeen hospitals, in Bolzano, Bressanone, Brunico and Ortisei. Thirty-one of a hundred and fifty-eight pharmacies. A hundred and eight of the hundred and sixteen municipalities have an approved plan. The agent joined five collections on the ISTAT code, filtered the hazard classes by the strings the AGENTS file told it about, and ran the intersection in DuckDB against the GeoParquet in place."
-[Click 2]
-"And it said what the numbers do not mean, because the publisher wrote it down: points are locations, not catchments; hazard classes are planning zones, not forecasts; eight municipalities have no approved plan yet. Producer, license and the query came attached. This is a screening, not a risk assessment. But look at what it did not have: a server, an API, credentials, or a person in the loop. The same catalog answers the next question tomorrow."
-[Sources]
-- https://github.com/portolan-sdi/portolan-skills/tree/main/skills/reading-portolan</a:t>
-            </a:r>
-            <a:endParaRPr lang="en-US" dirty="0"/>
-          </a:p>
-        </p:txBody>
-      </p:sp>
-      <p:sp>
-        <p:nvSpPr>
-          <p:cNvPr id="4" name="Slide Number Placeholder 3"/>
-          <p:cNvSpPr>
-            <a:spLocks noGrp="1"/>
-          </p:cNvSpPr>
-          <p:nvPr>
-            <p:ph type="sldNum" sz="quarter" idx="10"/>
-          </p:nvPr>
-        </p:nvSpPr>
-        <p:spPr/>
-        <p:txBody>
-          <a:bodyPr/>
-          <a:lstStyle/>
-          <a:p>
-            <a:fld id="{F7021451-1387-4CA6-816F-3879F97B5CBC}" type="slidenum">
-              <a:rPr lang="en-US"/>
-              <a:t>8</a:t>
-            </a:fld>
-            <a:endParaRPr lang="en-US"/>
-          </a:p>
-        </p:txBody>
-      </p:sp>
-    </p:spTree>
-    <p:extLst>
-      <p:ext uri="{BB962C8B-B14F-4D97-AF65-F5344CB8AC3E}">
-        <p14:creationId xmlns:p14="http://schemas.microsoft.com/office/powerpoint/2010/main" val="1024086991"/>
-      </p:ext>
-    </p:extLst>
-  </p:cSld>
-  <p:clrMapOvr>
-    <a:masterClrMapping/>
-  </p:clrMapOvr>
-</p:notes>
-</file>
-
 <file path=ppt/notesSlides/notesSlide9.xml><?xml version="1.0" encoding="utf-8"?>
 <p:notes xmlns:a="http://schemas.openxmlformats.org/drawingml/2006/main" xmlns:r="http://schemas.openxmlformats.org/officeDocument/2006/relationships" xmlns:p="http://schemas.openxmlformats.org/presentationml/2006/main">
   <p:cSld>
@@ -2459,19 +2379,18 @@
             <a:r>
               <a:rPr lang="en-US" dirty="0"/>
               <a:t>[Say] (0:50)
-"Here is what the agent actually did, because this is where AI-ready stops being a slogan."
+"Before the second story, one slide on where all that metadata actually came from, because this is the part metadata maintainers ask about. Three kinds of value fill a record, and the CLI keeps them apart."
 [Click 1]
-"It opened the catalog and followed the explicit child links: eleven theme catalogs, sixty-nine collections. The linked graph is the publication boundary."
+"Measured, in green: what the tool reads from the file itself. Extent, coordinate system, row count, columns and types, geometry type, checksums. Re-read on every run, so the record cannot drift from the data. Harvested, in orange: what the source already published. The abstract, keywords, the dataset page, the styles, pulled from the WFS and the portal, or drafted by an agent. Where the service had nothing, the tool writes a TODO marker, so the reviewer opens a checklist and not a blank. Asserted, in blue: what only the publisher can say. Who is accountable, the licence, the providers, the known issues."
 [Click 2]
-"It read AGENTS dot md: the join key, the coordinate system, the exact hazard-class strings, and what the data is not for."
+"And the asserted part is written once. Every level of the tree carries a metadata file; a child inherits everything from its ancestors. Eighty-one files in this catalog; one of them carries the licence, the contact and the providers for all sixty-nine collections. Only title and description stay local."
 [Click 3]
-"It inspected each collection: one GeoParquet asset each, with provider, license, extent and row count."
-[Click 4]
-"It planned a DuckDB query. The model plans and explains; DuckDB computes, reading only the row groups it needs thanks to the spatial ordering the spec requires."
-[Click 5]
-"It reported with method, URLs, producer, license and limitations. Every step consumed something the publisher wrote down. Nothing was guessed. I cannot run this in ten minutes, so both stories run live at the demo desk at the coffee breaks, today and tomorrow. Bring the URL of your WFS and a question."
+"portolan add merges the three into the STAC record, the README and the AGENTS file. So the working rule is: drafted by a tool, approved by a person, gated by the validator in CI on every push. Drafting is where tools help. The reading and the accountability stay human."
 [Sources]
-- https://github.com/portolan-sdi/portolan-skills/tree/main/skills/reading-portolan</a:t>
+- https://github.com/cayetanobv/south-tyrol-geodata-portolan-mirror (81 metadata.yaml files, 11 themes, 69 collections; CI runs rashid check on every push; counted 4 Sep 2026)
+- https://cli.portolan-sdi.org/ (portolan add, portolan extract, metadata.yaml inheritance, --merge-strategy smart; portolan-cli 0.8.0)
+- https://github.com/portolan-sdi/portolan-spec/blob/main/specs/portolan/core.md
+- Portolan AI policy: "drafting is where tools help; the reading and the accountability stay human"</a:t>
             </a:r>
             <a:endParaRPr lang="en-US" dirty="0"/>
           </a:p>
@@ -3291,45 +3210,6 @@
 <file path=ppt/slides/slide20.xml><?xml version="1.0" encoding="utf-8"?>
 <p:sld xmlns:a="http://schemas.openxmlformats.org/drawingml/2006/main" xmlns:r="http://schemas.openxmlformats.org/officeDocument/2006/relationships" xmlns:p="http://schemas.openxmlformats.org/presentationml/2006/main">
   <p:cSld name="Slide 20">
-    <p:bg>
-      <p:bgPr>
-        <a:blipFill dpi="0" rotWithShape="1">
-          <a:blip r:embed="rId1">
-            <a:lum/>
-          </a:blip>
-          <a:srcRect/>
-          <a:stretch>
-            <a:fillRect/>
-          </a:stretch>
-        </a:blipFill>
-        <a:effectLst/>
-      </p:bgPr>
-    </p:bg>
-    <p:spTree>
-      <p:nvGrpSpPr>
-        <p:cNvPr id="1" name=""/>
-        <p:cNvGrpSpPr/>
-        <p:nvPr/>
-      </p:nvGrpSpPr>
-      <p:grpSpPr>
-        <a:xfrm>
-          <a:off x="0" y="0"/>
-          <a:ext cx="0" cy="0"/>
-          <a:chOff x="0" y="0"/>
-          <a:chExt cx="0" cy="0"/>
-        </a:xfrm>
-      </p:grpSpPr>
-    </p:spTree>
-  </p:cSld>
-  <p:clrMapOvr>
-    <a:masterClrMapping/>
-  </p:clrMapOvr>
-</p:sld>
-</file>
-
-<file path=ppt/slides/slide21.xml><?xml version="1.0" encoding="utf-8"?>
-<p:sld xmlns:a="http://schemas.openxmlformats.org/drawingml/2006/main" xmlns:r="http://schemas.openxmlformats.org/officeDocument/2006/relationships" xmlns:p="http://schemas.openxmlformats.org/presentationml/2006/main">
-  <p:cSld name="Slide 21">
     <p:bg>
       <p:bgPr>
         <a:blipFill dpi="0" rotWithShape="1">

</xml_diff>

<commit_message>
Split slide 5: building-blocks table, then STAC/profile diagram; deck is 18 slides, QR points at 18 (old a05 kept unreferenced for rollback)
Co-Authored-By: Claude Fable 5.1 <noreply@anthropic.com>
</commit_message>
<xml_diff>
--- a/export/ogc-metadata-summit-2026.pptx
+++ b/export/ogc-metadata-summit-2026.pptx
@@ -25,9 +25,10 @@
     <p:sldId id="273" r:id="rId19"/>
     <p:sldId id="274" r:id="rId20"/>
     <p:sldId id="275" r:id="rId21"/>
+    <p:sldId id="276" r:id="rId22"/>
   </p:sldIdLst>
   <p:notesMasterIdLst>
-    <p:notesMasterId r:id="rId22"/>
+    <p:notesMasterId r:id="rId23"/>
   </p:notesMasterIdLst>
   <p:sldSz cx="9334500" cy="5248275"/>
   <p:notesSz cx="5248275" cy="9334500"/>
@@ -613,6 +614,106 @@
           <a:p>
             <a:r>
               <a:rPr lang="en-US" dirty="0"/>
+              <a:t>[Say] (0:50)
+"Before the second story, one slide on where all that metadata actually came from, because this is the part metadata maintainers ask about. Three kinds of value fill a record, and the CLI keeps them apart."
+[Click 1]
+"Measured, in green: what the tool reads from the file itself. Extent, coordinate system, row count, columns and types, geometry type, checksums. Re-read on every run, so the record cannot drift from the data. Harvested, in orange: what the source already published. The abstract, keywords, the dataset page, the styles, pulled from the WFS and the portal, or drafted by an agent. Where the service had nothing, the tool writes a TODO marker, so the reviewer opens a checklist and not a blank. Asserted, in blue: what only the publisher can say. Who is accountable, the licence, the providers, the known issues."
+[Click 2]
+"And the asserted part is written once. Every level of the tree carries a metadata file; a child inherits everything from its ancestors. Eighty-one files in this catalog; one of them carries the licence, the contact and the providers for all sixty-nine collections. Only title and description stay local."
+[Click 3]
+"portolan add merges the three into the STAC record, the README and the AGENTS file. So the working rule is: drafted by a tool, approved by a person, gated by the validator in CI on every push. Drafting is where tools help. The reading and the accountability stay human."
+[Sources]
+- https://github.com/cayetanobv/south-tyrol-geodata-portolan-mirror (81 metadata.yaml files, 11 themes, 69 collections; CI runs rashid check on every push; counted 4 Sep 2026)
+- https://cli.portolan-sdi.org/ (portolan add, portolan extract, metadata.yaml inheritance, --merge-strategy smart; portolan-cli 0.8.0)
+- https://github.com/portolan-sdi/portolan-spec/blob/main/specs/portolan/core.md
+- Portolan AI policy: "drafting is where tools help; the reading and the accountability stay human"</a:t>
+            </a:r>
+            <a:endParaRPr lang="en-US" dirty="0"/>
+          </a:p>
+        </p:txBody>
+      </p:sp>
+      <p:sp>
+        <p:nvSpPr>
+          <p:cNvPr id="4" name="Slide Number Placeholder 3"/>
+          <p:cNvSpPr>
+            <a:spLocks noGrp="1"/>
+          </p:cNvSpPr>
+          <p:nvPr>
+            <p:ph type="sldNum" sz="quarter" idx="10"/>
+          </p:nvPr>
+        </p:nvSpPr>
+        <p:spPr/>
+        <p:txBody>
+          <a:bodyPr/>
+          <a:lstStyle/>
+          <a:p>
+            <a:fld id="{F7021451-1387-4CA6-816F-3879F97B5CBC}" type="slidenum">
+              <a:rPr lang="en-US"/>
+              <a:t>10</a:t>
+            </a:fld>
+            <a:endParaRPr lang="en-US"/>
+          </a:p>
+        </p:txBody>
+      </p:sp>
+    </p:spTree>
+    <p:extLst>
+      <p:ext uri="{BB962C8B-B14F-4D97-AF65-F5344CB8AC3E}">
+        <p14:creationId xmlns:p14="http://schemas.microsoft.com/office/powerpoint/2010/main" val="1024086991"/>
+      </p:ext>
+    </p:extLst>
+  </p:cSld>
+  <p:clrMapOvr>
+    <a:masterClrMapping/>
+  </p:clrMapOvr>
+</p:notes>
+</file>
+
+<file path=ppt/notesSlides/notesSlide11.xml><?xml version="1.0" encoding="utf-8"?>
+<p:notes xmlns:a="http://schemas.openxmlformats.org/drawingml/2006/main" xmlns:r="http://schemas.openxmlformats.org/officeDocument/2006/relationships" xmlns:p="http://schemas.openxmlformats.org/presentationml/2006/main">
+  <p:cSld>
+    <p:spTree>
+      <p:nvGrpSpPr>
+        <p:cNvPr id="1" name=""/>
+        <p:cNvGrpSpPr/>
+        <p:nvPr/>
+      </p:nvGrpSpPr>
+      <p:grpSpPr>
+        <a:xfrm>
+          <a:off x="0" y="0"/>
+          <a:ext cx="0" cy="0"/>
+          <a:chOff x="0" y="0"/>
+          <a:chExt cx="0" cy="0"/>
+        </a:xfrm>
+      </p:grpSpPr>
+      <p:sp>
+        <p:nvSpPr>
+          <p:cNvPr id="2" name="Slide Image Placeholder 1"/>
+          <p:cNvSpPr>
+            <a:spLocks noGrp="1" noRot="1" noChangeAspect="1"/>
+          </p:cNvSpPr>
+          <p:nvPr>
+            <p:ph type="sldImg"/>
+          </p:nvPr>
+        </p:nvSpPr>
+        <p:spPr/>
+      </p:sp>
+      <p:sp>
+        <p:nvSpPr>
+          <p:cNvPr id="3" name="Notes Placeholder 2"/>
+          <p:cNvSpPr>
+            <a:spLocks noGrp="1"/>
+          </p:cNvSpPr>
+          <p:nvPr>
+            <p:ph type="body" idx="1"/>
+          </p:nvPr>
+        </p:nvSpPr>
+        <p:spPr/>
+        <p:txBody>
+          <a:bodyPr/>
+          <a:lstStyle/>
+          <a:p>
+            <a:r>
+              <a:rPr lang="en-US" dirty="0"/>
               <a:t>[Say] (1:15)
 "Second story, same catalog, the next day. Out of 69 collections, an agent was asked a question no single layer answers: which hospitals and pharmacies sit inside high or very-high hydraulic hazard zones, and how many residents live in those municipalities. Nobody guided it."
 [Click 1]
@@ -643,7 +744,7 @@
           <a:p>
             <a:fld id="{F7021451-1387-4CA6-816F-3879F97B5CBC}" type="slidenum">
               <a:rPr lang="en-US"/>
-              <a:t>10</a:t>
+              <a:t>11</a:t>
             </a:fld>
             <a:endParaRPr lang="en-US"/>
           </a:p>
@@ -662,7 +763,7 @@
 </p:notes>
 </file>
 
-<file path=ppt/notesSlides/notesSlide11.xml><?xml version="1.0" encoding="utf-8"?>
+<file path=ppt/notesSlides/notesSlide12.xml><?xml version="1.0" encoding="utf-8"?>
 <p:notes xmlns:a="http://schemas.openxmlformats.org/drawingml/2006/main" xmlns:r="http://schemas.openxmlformats.org/officeDocument/2006/relationships" xmlns:p="http://schemas.openxmlformats.org/presentationml/2006/main">
   <p:cSld>
     <p:spTree>
@@ -744,7 +845,7 @@
           <a:p>
             <a:fld id="{F7021451-1387-4CA6-816F-3879F97B5CBC}" type="slidenum">
               <a:rPr lang="en-US"/>
-              <a:t>11</a:t>
+              <a:t>12</a:t>
             </a:fld>
             <a:endParaRPr lang="en-US"/>
           </a:p>
@@ -763,7 +864,7 @@
 </p:notes>
 </file>
 
-<file path=ppt/notesSlides/notesSlide12.xml><?xml version="1.0" encoding="utf-8"?>
+<file path=ppt/notesSlides/notesSlide13.xml><?xml version="1.0" encoding="utf-8"?>
 <p:notes xmlns:a="http://schemas.openxmlformats.org/drawingml/2006/main" xmlns:r="http://schemas.openxmlformats.org/officeDocument/2006/relationships" xmlns:p="http://schemas.openxmlformats.org/presentationml/2006/main">
   <p:cSld>
     <p:spTree>
@@ -840,7 +941,7 @@
           <a:p>
             <a:fld id="{F7021451-1387-4CA6-816F-3879F97B5CBC}" type="slidenum">
               <a:rPr lang="en-US"/>
-              <a:t>12</a:t>
+              <a:t>13</a:t>
             </a:fld>
             <a:endParaRPr lang="en-US"/>
           </a:p>
@@ -859,7 +960,7 @@
 </p:notes>
 </file>
 
-<file path=ppt/notesSlides/notesSlide13.xml><?xml version="1.0" encoding="utf-8"?>
+<file path=ppt/notesSlides/notesSlide14.xml><?xml version="1.0" encoding="utf-8"?>
 <p:notes xmlns:a="http://schemas.openxmlformats.org/drawingml/2006/main" xmlns:r="http://schemas.openxmlformats.org/officeDocument/2006/relationships" xmlns:p="http://schemas.openxmlformats.org/presentationml/2006/main">
   <p:cSld>
     <p:spTree>
@@ -939,7 +1040,7 @@
           <a:p>
             <a:fld id="{F7021451-1387-4CA6-816F-3879F97B5CBC}" type="slidenum">
               <a:rPr lang="en-US"/>
-              <a:t>13</a:t>
+              <a:t>14</a:t>
             </a:fld>
             <a:endParaRPr lang="en-US"/>
           </a:p>
@@ -958,7 +1059,7 @@
 </p:notes>
 </file>
 
-<file path=ppt/notesSlides/notesSlide14.xml><?xml version="1.0" encoding="utf-8"?>
+<file path=ppt/notesSlides/notesSlide15.xml><?xml version="1.0" encoding="utf-8"?>
 <p:notes xmlns:a="http://schemas.openxmlformats.org/drawingml/2006/main" xmlns:r="http://schemas.openxmlformats.org/officeDocument/2006/relationships" xmlns:p="http://schemas.openxmlformats.org/presentationml/2006/main">
   <p:cSld>
     <p:spTree>
@@ -1038,7 +1139,7 @@
           <a:p>
             <a:fld id="{F7021451-1387-4CA6-816F-3879F97B5CBC}" type="slidenum">
               <a:rPr lang="en-US"/>
-              <a:t>14</a:t>
+              <a:t>15</a:t>
             </a:fld>
             <a:endParaRPr lang="en-US"/>
           </a:p>
@@ -1057,7 +1158,7 @@
 </p:notes>
 </file>
 
-<file path=ppt/notesSlides/notesSlide15.xml><?xml version="1.0" encoding="utf-8"?>
+<file path=ppt/notesSlides/notesSlide16.xml><?xml version="1.0" encoding="utf-8"?>
 <p:notes xmlns:a="http://schemas.openxmlformats.org/drawingml/2006/main" xmlns:r="http://schemas.openxmlformats.org/officeDocument/2006/relationships" xmlns:p="http://schemas.openxmlformats.org/presentationml/2006/main">
   <p:cSld>
     <p:spTree>
@@ -1141,7 +1242,7 @@
           <a:p>
             <a:fld id="{F7021451-1387-4CA6-816F-3879F97B5CBC}" type="slidenum">
               <a:rPr lang="en-US"/>
-              <a:t>15</a:t>
+              <a:t>16</a:t>
             </a:fld>
             <a:endParaRPr lang="en-US"/>
           </a:p>
@@ -1160,7 +1261,7 @@
 </p:notes>
 </file>
 
-<file path=ppt/notesSlides/notesSlide16.xml><?xml version="1.0" encoding="utf-8"?>
+<file path=ppt/notesSlides/notesSlide17.xml><?xml version="1.0" encoding="utf-8"?>
 <p:notes xmlns:a="http://schemas.openxmlformats.org/drawingml/2006/main" xmlns:r="http://schemas.openxmlformats.org/officeDocument/2006/relationships" xmlns:p="http://schemas.openxmlformats.org/presentationml/2006/main">
   <p:cSld>
     <p:spTree>
@@ -1237,7 +1338,7 @@
           <a:p>
             <a:fld id="{F7021451-1387-4CA6-816F-3879F97B5CBC}" type="slidenum">
               <a:rPr lang="en-US"/>
-              <a:t>16</a:t>
+              <a:t>17</a:t>
             </a:fld>
             <a:endParaRPr lang="en-US"/>
           </a:p>
@@ -1256,7 +1357,7 @@
 </p:notes>
 </file>
 
-<file path=ppt/notesSlides/notesSlide17.xml><?xml version="1.0" encoding="utf-8"?>
+<file path=ppt/notesSlides/notesSlide18.xml><?xml version="1.0" encoding="utf-8"?>
 <p:notes xmlns:a="http://schemas.openxmlformats.org/drawingml/2006/main" xmlns:r="http://schemas.openxmlformats.org/officeDocument/2006/relationships" xmlns:p="http://schemas.openxmlformats.org/presentationml/2006/main">
   <p:cSld>
     <p:spTree>
@@ -1335,7 +1436,7 @@
           <a:p>
             <a:fld id="{F7021451-1387-4CA6-816F-3879F97B5CBC}" type="slidenum">
               <a:rPr lang="en-US"/>
-              <a:t>17</a:t>
+              <a:t>18</a:t>
             </a:fld>
             <a:endParaRPr lang="en-US"/>
           </a:p>
@@ -1354,7 +1455,7 @@
 </p:notes>
 </file>
 
-<file path=ppt/notesSlides/notesSlide18.xml><?xml version="1.0" encoding="utf-8"?>
+<file path=ppt/notesSlides/notesSlide19.xml><?xml version="1.0" encoding="utf-8"?>
 <p:notes xmlns:a="http://schemas.openxmlformats.org/drawingml/2006/main" xmlns:r="http://schemas.openxmlformats.org/officeDocument/2006/relationships" xmlns:p="http://schemas.openxmlformats.org/presentationml/2006/main">
   <p:cSld>
     <p:spTree>
@@ -1429,7 +1530,7 @@
           <a:p>
             <a:fld id="{F7021451-1387-4CA6-816F-3879F97B5CBC}" type="slidenum">
               <a:rPr lang="en-US"/>
-              <a:t>18</a:t>
+              <a:t>19</a:t>
             </a:fld>
             <a:endParaRPr lang="en-US"/>
           </a:p>
@@ -1448,7 +1549,99 @@
 </p:notes>
 </file>
 
-<file path=ppt/notesSlides/notesSlide19.xml><?xml version="1.0" encoding="utf-8"?>
+<file path=ppt/notesSlides/notesSlide2.xml><?xml version="1.0" encoding="utf-8"?>
+<p:notes xmlns:a="http://schemas.openxmlformats.org/drawingml/2006/main" xmlns:r="http://schemas.openxmlformats.org/officeDocument/2006/relationships" xmlns:p="http://schemas.openxmlformats.org/presentationml/2006/main">
+  <p:cSld>
+    <p:spTree>
+      <p:nvGrpSpPr>
+        <p:cNvPr id="1" name=""/>
+        <p:cNvGrpSpPr/>
+        <p:nvPr/>
+      </p:nvGrpSpPr>
+      <p:grpSpPr>
+        <a:xfrm>
+          <a:off x="0" y="0"/>
+          <a:ext cx="0" cy="0"/>
+          <a:chOff x="0" y="0"/>
+          <a:chExt cx="0" cy="0"/>
+        </a:xfrm>
+      </p:grpSpPr>
+      <p:sp>
+        <p:nvSpPr>
+          <p:cNvPr id="2" name="Slide Image Placeholder 1"/>
+          <p:cNvSpPr>
+            <a:spLocks noGrp="1" noRot="1" noChangeAspect="1"/>
+          </p:cNvSpPr>
+          <p:nvPr>
+            <p:ph type="sldImg"/>
+          </p:nvPr>
+        </p:nvSpPr>
+        <p:spPr/>
+      </p:sp>
+      <p:sp>
+        <p:nvSpPr>
+          <p:cNvPr id="3" name="Notes Placeholder 2"/>
+          <p:cNvSpPr>
+            <a:spLocks noGrp="1"/>
+          </p:cNvSpPr>
+          <p:nvPr>
+            <p:ph type="body" idx="1"/>
+          </p:nvPr>
+        </p:nvSpPr>
+        <p:spPr/>
+        <p:txBody>
+          <a:bodyPr/>
+          <a:lstStyle/>
+          <a:p>
+            <a:r>
+              <a:rPr lang="en-US" dirty="0"/>
+              <a:t>[Say] (0:30)
+"Briefly, who is talking. I am Director of Engineering for Professional Services at CARTO, I collaborate on the Portolan SDI project, and I have spent more than twenty years in the geospatial industry, most of it contributing to open-source software. I am based in Seville. Everything I show is open; the slides and the catalog are at the addresses on the right."
+[Sources]
+- https://github.com/cayetanobv
+- https://cayetanobv.github.io/ogc-metadata-summit-bolzano/</a:t>
+            </a:r>
+            <a:endParaRPr lang="en-US" dirty="0"/>
+          </a:p>
+        </p:txBody>
+      </p:sp>
+      <p:sp>
+        <p:nvSpPr>
+          <p:cNvPr id="4" name="Slide Number Placeholder 3"/>
+          <p:cNvSpPr>
+            <a:spLocks noGrp="1"/>
+          </p:cNvSpPr>
+          <p:nvPr>
+            <p:ph type="sldNum" sz="quarter" idx="10"/>
+          </p:nvPr>
+        </p:nvSpPr>
+        <p:spPr/>
+        <p:txBody>
+          <a:bodyPr/>
+          <a:lstStyle/>
+          <a:p>
+            <a:fld id="{F7021451-1387-4CA6-816F-3879F97B5CBC}" type="slidenum">
+              <a:rPr lang="en-US"/>
+              <a:t>2</a:t>
+            </a:fld>
+            <a:endParaRPr lang="en-US"/>
+          </a:p>
+        </p:txBody>
+      </p:sp>
+    </p:spTree>
+    <p:extLst>
+      <p:ext uri="{BB962C8B-B14F-4D97-AF65-F5344CB8AC3E}">
+        <p14:creationId xmlns:p14="http://schemas.microsoft.com/office/powerpoint/2010/main" val="1024086991"/>
+      </p:ext>
+    </p:extLst>
+  </p:cSld>
+  <p:clrMapOvr>
+    <a:masterClrMapping/>
+  </p:clrMapOvr>
+</p:notes>
+</file>
+
+<file path=ppt/notesSlides/notesSlide20.xml><?xml version="1.0" encoding="utf-8"?>
 <p:notes xmlns:a="http://schemas.openxmlformats.org/drawingml/2006/main" xmlns:r="http://schemas.openxmlformats.org/officeDocument/2006/relationships" xmlns:p="http://schemas.openxmlformats.org/presentationml/2006/main">
   <p:cSld>
     <p:spTree>
@@ -1529,7 +1722,7 @@
           <a:p>
             <a:fld id="{F7021451-1387-4CA6-816F-3879F97B5CBC}" type="slidenum">
               <a:rPr lang="en-US"/>
-              <a:t>19</a:t>
+              <a:t>20</a:t>
             </a:fld>
             <a:endParaRPr lang="en-US"/>
           </a:p>
@@ -1548,99 +1741,7 @@
 </p:notes>
 </file>
 
-<file path=ppt/notesSlides/notesSlide2.xml><?xml version="1.0" encoding="utf-8"?>
-<p:notes xmlns:a="http://schemas.openxmlformats.org/drawingml/2006/main" xmlns:r="http://schemas.openxmlformats.org/officeDocument/2006/relationships" xmlns:p="http://schemas.openxmlformats.org/presentationml/2006/main">
-  <p:cSld>
-    <p:spTree>
-      <p:nvGrpSpPr>
-        <p:cNvPr id="1" name=""/>
-        <p:cNvGrpSpPr/>
-        <p:nvPr/>
-      </p:nvGrpSpPr>
-      <p:grpSpPr>
-        <a:xfrm>
-          <a:off x="0" y="0"/>
-          <a:ext cx="0" cy="0"/>
-          <a:chOff x="0" y="0"/>
-          <a:chExt cx="0" cy="0"/>
-        </a:xfrm>
-      </p:grpSpPr>
-      <p:sp>
-        <p:nvSpPr>
-          <p:cNvPr id="2" name="Slide Image Placeholder 1"/>
-          <p:cNvSpPr>
-            <a:spLocks noGrp="1" noRot="1" noChangeAspect="1"/>
-          </p:cNvSpPr>
-          <p:nvPr>
-            <p:ph type="sldImg"/>
-          </p:nvPr>
-        </p:nvSpPr>
-        <p:spPr/>
-      </p:sp>
-      <p:sp>
-        <p:nvSpPr>
-          <p:cNvPr id="3" name="Notes Placeholder 2"/>
-          <p:cNvSpPr>
-            <a:spLocks noGrp="1"/>
-          </p:cNvSpPr>
-          <p:nvPr>
-            <p:ph type="body" idx="1"/>
-          </p:nvPr>
-        </p:nvSpPr>
-        <p:spPr/>
-        <p:txBody>
-          <a:bodyPr/>
-          <a:lstStyle/>
-          <a:p>
-            <a:r>
-              <a:rPr lang="en-US" dirty="0"/>
-              <a:t>[Say] (0:30)
-"Briefly, who is talking. I am Director of Engineering for Professional Services at CARTO, I collaborate on the Portolan SDI project, and I have spent more than twenty years in the geospatial industry, most of it contributing to open-source software. I am based in Seville. Everything I show is open; the slides and the catalog are at the addresses on the right."
-[Sources]
-- https://github.com/cayetanobv
-- https://cayetanobv.github.io/ogc-metadata-summit-bolzano/</a:t>
-            </a:r>
-            <a:endParaRPr lang="en-US" dirty="0"/>
-          </a:p>
-        </p:txBody>
-      </p:sp>
-      <p:sp>
-        <p:nvSpPr>
-          <p:cNvPr id="4" name="Slide Number Placeholder 3"/>
-          <p:cNvSpPr>
-            <a:spLocks noGrp="1"/>
-          </p:cNvSpPr>
-          <p:nvPr>
-            <p:ph type="sldNum" sz="quarter" idx="10"/>
-          </p:nvPr>
-        </p:nvSpPr>
-        <p:spPr/>
-        <p:txBody>
-          <a:bodyPr/>
-          <a:lstStyle/>
-          <a:p>
-            <a:fld id="{F7021451-1387-4CA6-816F-3879F97B5CBC}" type="slidenum">
-              <a:rPr lang="en-US"/>
-              <a:t>2</a:t>
-            </a:fld>
-            <a:endParaRPr lang="en-US"/>
-          </a:p>
-        </p:txBody>
-      </p:sp>
-    </p:spTree>
-    <p:extLst>
-      <p:ext uri="{BB962C8B-B14F-4D97-AF65-F5344CB8AC3E}">
-        <p14:creationId xmlns:p14="http://schemas.microsoft.com/office/powerpoint/2010/main" val="1024086991"/>
-      </p:ext>
-    </p:extLst>
-  </p:cSld>
-  <p:clrMapOvr>
-    <a:masterClrMapping/>
-  </p:clrMapOvr>
-</p:notes>
-</file>
-
-<file path=ppt/notesSlides/notesSlide20.xml><?xml version="1.0" encoding="utf-8"?>
+<file path=ppt/notesSlides/notesSlide21.xml><?xml version="1.0" encoding="utf-8"?>
 <p:notes xmlns:a="http://schemas.openxmlformats.org/drawingml/2006/main" xmlns:r="http://schemas.openxmlformats.org/officeDocument/2006/relationships" xmlns:p="http://schemas.openxmlformats.org/presentationml/2006/main">
   <p:cSld>
     <p:spTree>
@@ -1711,7 +1812,7 @@
           <a:p>
             <a:fld id="{F7021451-1387-4CA6-816F-3879F97B5CBC}" type="slidenum">
               <a:rPr lang="en-US"/>
-              <a:t>20</a:t>
+              <a:t>21</a:t>
             </a:fld>
             <a:endParaRPr lang="en-US"/>
           </a:p>
@@ -1976,21 +2077,15 @@
           <a:p>
             <a:r>
               <a:rPr lang="en-US" dirty="0"/>
-              <a:t>[Say] (1:15)
-"Everything a Portolan catalog is made of, you already know, and most of it carries an OGC stamp. STAC, catalog to asset, has been an OGC Community Standard since last October. Every STAC Item is a GeoJSON Feature, an IETF standard. Cloud Optimized GeoTIFF is an OGC Standard since 2023. GeoParquet has its own OGC Standards Working Group; approval of 1.0 is the remaining formality. Zarr, which we plan but have not shipped, is an OGC Community Standard. PMTiles for display is a community format, and underneath it all are HTTP range requests on object storage. Nothing here is new."
-[Click 1]
-"STAC does its normal job: it describes and links the same objects, catalog, collection, item, asset. Portolan uses the static side of STAC only: files, no API."
-[Click 2]
-"Every one of those standards deliberately leaves the publishing choices open. That is the right design for a standard and the wrong thing to leave open for a reader, because every open choice is a branch every reader has to handle. Portolan makes six of those choices explicit: structure and links, formats and statistics, access and hosting, licence and provenance, README and AGENTS documentation, and visualisation. A catalog declares which version of the profile it follows. STAC describes the data. Portolan defines how it is published."
+              <a:t>[Say] (0:45)
+"Everything a Portolan catalog is made of, you already know, and most of it carries an OGC stamp. STAC, catalog to asset, has been an OGC Community Standard since last October. Every STAC Item is a GeoJSON Feature, an IETF standard. Cloud Optimized GeoTIFF is an OGC Standard since 2023. GeoParquet has its own OGC Standards Working Group; approval of 1.0 is the remaining formality. Zarr, which we plan but have not shipped, is an OGC Community Standard. PMTiles for display is a community format, and underneath it all are HTTP range requests on object storage. Nothing here is new. And Portolan uses the static side of STAC only: files, no API."
 [Sources]
 - https://www.ogc.org/announcement/ogc-announces-publication-of-the-spatiotemporal-asset-catalog-community-standards/ (28 Oct 2025; "an Item … is simply a GeoJSON Feature")
 - https://datatracker.ietf.org/doc/html/rfc7946 (GeoJSON, IETF, not an OGC document)
 - https://docs.ogc.org/is/21-026/21-026.html (OGC Cloud Optimized GeoTIFF Standard 1.0, 2023)
 - https://github.com/opengeospatial/geoparquet/blob/main/README.md ("official Standards Working Group … pending OGC approval", checked 3 Sep 2026)
 - https://www.ogc.org/announcement/ogc-forms-new-geozarr-standards-working-group-to-establish-a-zarr-encoding-for-geospatial-data/ (Zarr V2 endorsed as OGC Community Standard, June 2022)
-- https://docs.protomaps.com/pmtiles/ (PMTiles; not an OGC document)
-- https://github.com/portolan-sdi/portolan-spec/blob/main/specs/portolan/core.md (the six families of publishing choices)
-- VizTheGap by Youssef Harby, CNG Japan 2026 deck, reused as team material</a:t>
+- https://docs.protomaps.com/pmtiles/ (PMTiles; not an OGC document)</a:t>
             </a:r>
             <a:endParaRPr lang="en-US" dirty="0"/>
           </a:p>
@@ -2033,6 +2128,104 @@
 </file>
 
 <file path=ppt/notesSlides/notesSlide6.xml><?xml version="1.0" encoding="utf-8"?>
+<p:notes xmlns:a="http://schemas.openxmlformats.org/drawingml/2006/main" xmlns:r="http://schemas.openxmlformats.org/officeDocument/2006/relationships" xmlns:p="http://schemas.openxmlformats.org/presentationml/2006/main">
+  <p:cSld>
+    <p:spTree>
+      <p:nvGrpSpPr>
+        <p:cNvPr id="1" name=""/>
+        <p:cNvGrpSpPr/>
+        <p:nvPr/>
+      </p:nvGrpSpPr>
+      <p:grpSpPr>
+        <a:xfrm>
+          <a:off x="0" y="0"/>
+          <a:ext cx="0" cy="0"/>
+          <a:chOff x="0" y="0"/>
+          <a:chExt cx="0" cy="0"/>
+        </a:xfrm>
+      </p:grpSpPr>
+      <p:sp>
+        <p:nvSpPr>
+          <p:cNvPr id="2" name="Slide Image Placeholder 1"/>
+          <p:cNvSpPr>
+            <a:spLocks noGrp="1" noRot="1" noChangeAspect="1"/>
+          </p:cNvSpPr>
+          <p:nvPr>
+            <p:ph type="sldImg"/>
+          </p:nvPr>
+        </p:nvSpPr>
+        <p:spPr/>
+      </p:sp>
+      <p:sp>
+        <p:nvSpPr>
+          <p:cNvPr id="3" name="Notes Placeholder 2"/>
+          <p:cNvSpPr>
+            <a:spLocks noGrp="1"/>
+          </p:cNvSpPr>
+          <p:nvPr>
+            <p:ph type="body" idx="1"/>
+          </p:nvPr>
+        </p:nvSpPr>
+        <p:spPr/>
+        <p:txBody>
+          <a:bodyPr/>
+          <a:lstStyle/>
+          <a:p>
+            <a:r>
+              <a:rPr lang="en-US" dirty="0"/>
+              <a:t>[Say] (0:35)
+"So what is left to specify?"
+[Click 1]
+"STAC does its normal job: it describes and links the same objects, catalog, collection, item, asset."
+[Click 2]
+"Every one of those standards deliberately leaves the publishing choices open. That is the right design for a standard and the wrong thing to leave open for a reader, because every open choice is a branch every reader has to handle. Portolan makes six of those choices explicit: structure and links, formats and statistics, access and hosting, licence and provenance, README and AGENTS documentation, and visualisation. A catalog declares which version of the profile it follows. It is a publishing profile on top of these standards, not a new format."
+[Sources]
+- https://github.com/portolan-sdi/portolan-spec/blob/main/specs/portolan/core.md (the six families of publishing choices)
+- https://github.com/portolan-sdi/portolan-spec/releases/tag/v0.2.0
+- https://github.com/portolan-sdi/portolan-ops/blob/main/copy/messaging.md ("Isn't this just STAC and cloud-optimized formats?")
+- VizTheGap by Youssef Harby, CNG Japan 2026 deck, reused as team material</a:t>
+            </a:r>
+            <a:endParaRPr lang="en-US" dirty="0"/>
+          </a:p>
+        </p:txBody>
+      </p:sp>
+      <p:sp>
+        <p:nvSpPr>
+          <p:cNvPr id="4" name="Slide Number Placeholder 3"/>
+          <p:cNvSpPr>
+            <a:spLocks noGrp="1"/>
+          </p:cNvSpPr>
+          <p:nvPr>
+            <p:ph type="sldNum" sz="quarter" idx="10"/>
+          </p:nvPr>
+        </p:nvSpPr>
+        <p:spPr/>
+        <p:txBody>
+          <a:bodyPr/>
+          <a:lstStyle/>
+          <a:p>
+            <a:fld id="{F7021451-1387-4CA6-816F-3879F97B5CBC}" type="slidenum">
+              <a:rPr lang="en-US"/>
+              <a:t>6</a:t>
+            </a:fld>
+            <a:endParaRPr lang="en-US"/>
+          </a:p>
+        </p:txBody>
+      </p:sp>
+    </p:spTree>
+    <p:extLst>
+      <p:ext uri="{BB962C8B-B14F-4D97-AF65-F5344CB8AC3E}">
+        <p14:creationId xmlns:p14="http://schemas.microsoft.com/office/powerpoint/2010/main" val="1024086991"/>
+      </p:ext>
+    </p:extLst>
+  </p:cSld>
+  <p:clrMapOvr>
+    <a:masterClrMapping/>
+  </p:clrMapOvr>
+</p:notes>
+</file>
+
+<file path=ppt/notesSlides/notesSlide7.xml><?xml version="1.0" encoding="utf-8"?>
 <p:notes xmlns:a="http://schemas.openxmlformats.org/drawingml/2006/main" xmlns:r="http://schemas.openxmlformats.org/officeDocument/2006/relationships" xmlns:p="http://schemas.openxmlformats.org/presentationml/2006/main">
   <p:cSld>
     <p:spTree>
@@ -2114,7 +2307,7 @@
           <a:p>
             <a:fld id="{F7021451-1387-4CA6-816F-3879F97B5CBC}" type="slidenum">
               <a:rPr lang="en-US"/>
-              <a:t>6</a:t>
+              <a:t>7</a:t>
             </a:fld>
             <a:endParaRPr lang="en-US"/>
           </a:p>
@@ -2133,7 +2326,7 @@
 </p:notes>
 </file>
 
-<file path=ppt/notesSlides/notesSlide7.xml><?xml version="1.0" encoding="utf-8"?>
+<file path=ppt/notesSlides/notesSlide8.xml><?xml version="1.0" encoding="utf-8"?>
 <p:notes xmlns:a="http://schemas.openxmlformats.org/drawingml/2006/main" xmlns:r="http://schemas.openxmlformats.org/officeDocument/2006/relationships" xmlns:p="http://schemas.openxmlformats.org/presentationml/2006/main">
   <p:cSld>
     <p:spTree>
@@ -2211,7 +2404,7 @@
           <a:p>
             <a:fld id="{F7021451-1387-4CA6-816F-3879F97B5CBC}" type="slidenum">
               <a:rPr lang="en-US"/>
-              <a:t>7</a:t>
+              <a:t>8</a:t>
             </a:fld>
             <a:endParaRPr lang="en-US"/>
           </a:p>
@@ -2230,7 +2423,7 @@
 </p:notes>
 </file>
 
-<file path=ppt/notesSlides/notesSlide8.xml><?xml version="1.0" encoding="utf-8"?>
+<file path=ppt/notesSlides/notesSlide9.xml><?xml version="1.0" encoding="utf-8"?>
 <p:notes xmlns:a="http://schemas.openxmlformats.org/drawingml/2006/main" xmlns:r="http://schemas.openxmlformats.org/officeDocument/2006/relationships" xmlns:p="http://schemas.openxmlformats.org/presentationml/2006/main">
   <p:cSld>
     <p:spTree>
@@ -2292,106 +2485,6 @@
   https://data.civis.bz.it/dataset/farmacie
 - https://github.com/portolan-sdi/portolan-cli · https://github.com/portolan-sdi/rashid
 - Example catalog, live: https://storage.googleapis.com/south-tyrol-geodata-portolan-mirror/catalog.json · in the Portolan browser: https://browser.portolan-sdi.org/#/external/storage.googleapis.com/south-tyrol-geodata-portolan-mirror/catalog.json</a:t>
-            </a:r>
-            <a:endParaRPr lang="en-US" dirty="0"/>
-          </a:p>
-        </p:txBody>
-      </p:sp>
-      <p:sp>
-        <p:nvSpPr>
-          <p:cNvPr id="4" name="Slide Number Placeholder 3"/>
-          <p:cNvSpPr>
-            <a:spLocks noGrp="1"/>
-          </p:cNvSpPr>
-          <p:nvPr>
-            <p:ph type="sldNum" sz="quarter" idx="10"/>
-          </p:nvPr>
-        </p:nvSpPr>
-        <p:spPr/>
-        <p:txBody>
-          <a:bodyPr/>
-          <a:lstStyle/>
-          <a:p>
-            <a:fld id="{F7021451-1387-4CA6-816F-3879F97B5CBC}" type="slidenum">
-              <a:rPr lang="en-US"/>
-              <a:t>8</a:t>
-            </a:fld>
-            <a:endParaRPr lang="en-US"/>
-          </a:p>
-        </p:txBody>
-      </p:sp>
-    </p:spTree>
-    <p:extLst>
-      <p:ext uri="{BB962C8B-B14F-4D97-AF65-F5344CB8AC3E}">
-        <p14:creationId xmlns:p14="http://schemas.microsoft.com/office/powerpoint/2010/main" val="1024086991"/>
-      </p:ext>
-    </p:extLst>
-  </p:cSld>
-  <p:clrMapOvr>
-    <a:masterClrMapping/>
-  </p:clrMapOvr>
-</p:notes>
-</file>
-
-<file path=ppt/notesSlides/notesSlide9.xml><?xml version="1.0" encoding="utf-8"?>
-<p:notes xmlns:a="http://schemas.openxmlformats.org/drawingml/2006/main" xmlns:r="http://schemas.openxmlformats.org/officeDocument/2006/relationships" xmlns:p="http://schemas.openxmlformats.org/presentationml/2006/main">
-  <p:cSld>
-    <p:spTree>
-      <p:nvGrpSpPr>
-        <p:cNvPr id="1" name=""/>
-        <p:cNvGrpSpPr/>
-        <p:nvPr/>
-      </p:nvGrpSpPr>
-      <p:grpSpPr>
-        <a:xfrm>
-          <a:off x="0" y="0"/>
-          <a:ext cx="0" cy="0"/>
-          <a:chOff x="0" y="0"/>
-          <a:chExt cx="0" cy="0"/>
-        </a:xfrm>
-      </p:grpSpPr>
-      <p:sp>
-        <p:nvSpPr>
-          <p:cNvPr id="2" name="Slide Image Placeholder 1"/>
-          <p:cNvSpPr>
-            <a:spLocks noGrp="1" noRot="1" noChangeAspect="1"/>
-          </p:cNvSpPr>
-          <p:nvPr>
-            <p:ph type="sldImg"/>
-          </p:nvPr>
-        </p:nvSpPr>
-        <p:spPr/>
-      </p:sp>
-      <p:sp>
-        <p:nvSpPr>
-          <p:cNvPr id="3" name="Notes Placeholder 2"/>
-          <p:cNvSpPr>
-            <a:spLocks noGrp="1"/>
-          </p:cNvSpPr>
-          <p:nvPr>
-            <p:ph type="body" idx="1"/>
-          </p:nvPr>
-        </p:nvSpPr>
-        <p:spPr/>
-        <p:txBody>
-          <a:bodyPr/>
-          <a:lstStyle/>
-          <a:p>
-            <a:r>
-              <a:rPr lang="en-US" dirty="0"/>
-              <a:t>[Say] (0:50)
-"Before the second story, one slide on where all that metadata actually came from, because this is the part metadata maintainers ask about. Three kinds of value fill a record, and the CLI keeps them apart."
-[Click 1]
-"Measured, in green: what the tool reads from the file itself. Extent, coordinate system, row count, columns and types, geometry type, checksums. Re-read on every run, so the record cannot drift from the data. Harvested, in orange: what the source already published. The abstract, keywords, the dataset page, the styles, pulled from the WFS and the portal, or drafted by an agent. Where the service had nothing, the tool writes a TODO marker, so the reviewer opens a checklist and not a blank. Asserted, in blue: what only the publisher can say. Who is accountable, the licence, the providers, the known issues."
-[Click 2]
-"And the asserted part is written once. Every level of the tree carries a metadata file; a child inherits everything from its ancestors. Eighty-one files in this catalog; one of them carries the licence, the contact and the providers for all sixty-nine collections. Only title and description stay local."
-[Click 3]
-"portolan add merges the three into the STAC record, the README and the AGENTS file. So the working rule is: drafted by a tool, approved by a person, gated by the validator in CI on every push. Drafting is where tools help. The reading and the accountability stay human."
-[Sources]
-- https://github.com/cayetanobv/south-tyrol-geodata-portolan-mirror (81 metadata.yaml files, 11 themes, 69 collections; CI runs rashid check on every push; counted 4 Sep 2026)
-- https://cli.portolan-sdi.org/ (portolan add, portolan extract, metadata.yaml inheritance, --merge-strategy smart; portolan-cli 0.8.0)
-- https://github.com/portolan-sdi/portolan-spec/blob/main/specs/portolan/core.md
-- Portolan AI policy: "drafting is where tools help; the reading and the accountability stay human"</a:t>
             </a:r>
             <a:endParaRPr lang="en-US" dirty="0"/>
           </a:p>
@@ -3211,6 +3304,45 @@
 <file path=ppt/slides/slide20.xml><?xml version="1.0" encoding="utf-8"?>
 <p:sld xmlns:a="http://schemas.openxmlformats.org/drawingml/2006/main" xmlns:r="http://schemas.openxmlformats.org/officeDocument/2006/relationships" xmlns:p="http://schemas.openxmlformats.org/presentationml/2006/main">
   <p:cSld name="Slide 20">
+    <p:bg>
+      <p:bgPr>
+        <a:blipFill dpi="0" rotWithShape="1">
+          <a:blip r:embed="rId1">
+            <a:lum/>
+          </a:blip>
+          <a:srcRect/>
+          <a:stretch>
+            <a:fillRect/>
+          </a:stretch>
+        </a:blipFill>
+        <a:effectLst/>
+      </p:bgPr>
+    </p:bg>
+    <p:spTree>
+      <p:nvGrpSpPr>
+        <p:cNvPr id="1" name=""/>
+        <p:cNvGrpSpPr/>
+        <p:nvPr/>
+      </p:nvGrpSpPr>
+      <p:grpSpPr>
+        <a:xfrm>
+          <a:off x="0" y="0"/>
+          <a:ext cx="0" cy="0"/>
+          <a:chOff x="0" y="0"/>
+          <a:chExt cx="0" cy="0"/>
+        </a:xfrm>
+      </p:grpSpPr>
+    </p:spTree>
+  </p:cSld>
+  <p:clrMapOvr>
+    <a:masterClrMapping/>
+  </p:clrMapOvr>
+</p:sld>
+</file>
+
+<file path=ppt/slides/slide21.xml><?xml version="1.0" encoding="utf-8"?>
+<p:sld xmlns:a="http://schemas.openxmlformats.org/drawingml/2006/main" xmlns:r="http://schemas.openxmlformats.org/officeDocument/2006/relationships" xmlns:p="http://schemas.openxmlformats.org/presentationml/2006/main">
+  <p:cSld name="Slide 21">
     <p:bg>
       <p:bgPr>
         <a:blipFill dpi="0" rotWithShape="1">

</xml_diff>

<commit_message>
Metadata-sources diagram: harvested values draft into the collection YAML for review; only the YAML tree and the measurements feed portolan add
Co-Authored-By: Claude Fable 5.1 <noreply@anthropic.com>
</commit_message>
<xml_diff>
--- a/export/ogc-metadata-summit-2026.pptx
+++ b/export/ogc-metadata-summit-2026.pptx
@@ -615,13 +615,13 @@
             <a:r>
               <a:rPr lang="en-US" dirty="0"/>
               <a:t>[Say] (0:50)
-"Before the second story, one slide on where all that metadata actually came from, because this is the part metadata maintainers ask about. Three kinds of value fill a record, and the CLI keeps them apart."
+"Before the second story, one slide on where all that metadata actually came from, because this is the part metadata maintainers ask about. Two things reach the record: what the publisher declares in a YAML file, and what the tool measures from the data. And a third kind of value gets into the YAML by a shortcut."
 [Click 1]
-"Measured, in green: what the tool reads from the file itself. Extent, coordinate system, row count, columns and types, geometry type, checksums. Re-read on every run, so the record cannot drift from the data. Harvested, in orange: what the source already published. The abstract, keywords, the dataset page, the styles, pulled from the WFS and the portal, or drafted by an agent. Where the service had nothing, the tool writes a TODO marker, so the reviewer opens a checklist and not a blank. Asserted, in blue: what only the publisher can say. Who is accountable, the licence, the providers, the known issues."
+"Measured, in green: what the tool reads from the file itself. Extent, coordinate system, row count, columns and types, checksums. Re-read on every run, so the record cannot drift from the data. Harvested, in orange: what the source already published. Abstract, keywords, the dataset page, pulled from the WFS and the portal by portolan extract, or drafted by an agent. It is written into the collection's YAML for review, never straight into the record; where the service had nothing, the tool writes a TODO marker, so the reviewer opens a checklist and not a blank. Asserted, in blue: what only the publisher can say. Who is accountable, the licence, the providers, the known issues."
 [Click 2]
-"And the asserted part is written once. Every level of the tree carries a metadata file; a child inherits everything from its ancestors. Eighty-one files in this catalog; one of them carries the licence, the contact and the providers for all sixty-nine collections. Only title and description stay local."
+"And the declared part is written once. Every level of the tree carries a metadata file; a child inherits everything from its ancestors. Eighty-one files in this catalog; one of them carries the licence, the contact and the providers for all sixty-nine collections. Only title and description stay local."
 [Click 3]
-"portolan add merges the three into the STAC record, the README and the AGENTS file. So the working rule is: drafted by a tool, approved by a person, gated by the validator in CI on every push. Drafting is where tools help. The reading and the accountability stay human."
+"portolan add merges the YAML tree and the measurements into the STAC record, the README and the AGENTS file. So the working rule is: drafted by a tool, approved by a person, gated by the validator in CI on every push. Drafting is where tools help. The reading and the accountability stay human."
 [Sources]
 - https://github.com/cayetanobv/south-tyrol-geodata-portolan-mirror (81 metadata.yaml files, 11 themes, 69 collections; CI runs rashid check on every push; counted 4 Sep 2026)
 - https://cli.portolan-sdi.org/ (portolan add, portolan extract, metadata.yaml inheritance, --merge-strategy smart; portolan-cli 0.8.0)

</xml_diff>

<commit_message>
Closing slides: QR keeps a white frame in dark mode; slide 17 loses the blue rule; Slack channel moves to the bottom of the Questions slide
Co-Authored-By: Claude Fable 5.1 <noreply@anthropic.com>
</commit_message>
<xml_diff>
--- a/export/ogc-metadata-summit-2026.pptx
+++ b/export/ogc-metadata-summit-2026.pptx
@@ -1310,7 +1310,7 @@
               <a:t>[Say] (0:45)
 "Let me close with what we have not solved. Today every collection names who produced, licensed, processed and hosts the data; whether a catalog is official or a mirror is derived from that; and the registry is nothing more than a catalog of about twenty independently hosted catalogs. If it disappeared tomorrow, every one of them would keep working. All of that is declarative. So three open questions, and they map straight onto the Testbed on Trusted Data and Systems: how should authority be signalled cryptographically? What does trust mean when the consumer is an agent nobody is watching? And how does a mirror prove it is faithful to its source?"
 [Click 1]
-"Portolan has been public for five days. It is built by contributors across several organisations, it wants early adopters, and it still expects breaking changes. The first goal is about a hundred reference catalogs. The community call is Fridays at ten, Central European time, the Slack channel is open, and I am at the demo desk during the coffee breaks. These are the questions we would like to work on with the people in this room. Thank you."
+"Portolan has been public for five days. It is built by contributors across several organisations, it wants early adopters, and it still expects breaking changes. The first goal is about a hundred reference catalogs. The community call is Fridays at ten, Central European time, the Slack channel is on the next slide, and I am at the demo desk during the coffee breaks. These are the questions we would like to work on with the people in this room. Thank you."
 [Sources]
 - https://github.com/portolan-sdi/portolan-spec/blob/main/specs/portolan/core.md (Providers, Source Provenance)
 - https://github.com/portolan-sdi/portolan-registry
@@ -1404,7 +1404,7 @@
             <a:r>
               <a:rPr lang="en-US" dirty="0"/>
               <a:t>[Say] (shown during Q&amp;A, no talk time)
-"Feedback as GitHub issues against the spec or against any catalog. Mirrors of national datasets are welcome, there is an open list. The validator and the grader are open for anyone to run. One URL: portolan-sdi.org. And find me at the demo desk."
+"Feedback as GitHub issues against the spec or against any catalog. Mirrors of national datasets are welcome, there is an open list. The validator and the grader are open for anyone to run. One URL: portolan-sdi.org. The community lives in the #portolan channel of the Cloud-Native Geospatial Forum Slack and on the Friday call. And find me at the demo desk."
 [Sources]
 - https://www.portolan-sdi.org/
 - https://github.com/portolan-sdi

</xml_diff>